<commit_message>
docs: clarify planning stages and visualize cache cost efficiency
Signed-off-by: KaisennHu <74917084+KaisennHu@users.noreply.github.com>
</commit_message>
<xml_diff>
--- a/submissions/kaisennhu/07_答辩PPT/答辩介绍.pptx
+++ b/submissions/kaisennhu/07_答辩PPT/答辩介绍.pptx
@@ -652,7 +652,7 @@
           <a:lstStyle/>
           <a:p>
             <a:r>
-              <a:t>真实请求命中率=cache_hits/198542个请求，不使用engine的promote_hit_rate：该字段实际是promote_success/promote_count，只代表成功入池率。命中字节从未进入schedule_decisions的请求长度求和，和官方cache_hits计数交叉核验；它是缓存服务的逻辑字节，不能直接当成节省的物理SSD字节。提升搬运字节3.615GiB→0.305GiB，调用费722994→24676；命中复制仍付费81662→16806。缓存净收益对双方各自前台策略做关闭PROMOTE对照；保留其他参数及前台代码，计入缓存改变资源竞争、命中和后续选路的联动，是完整Trace净效应而非单次命中的价格。baseline关闭/启用总J3686550/3581641，净贡献104909；本方案2344079/2273874，净贡献70205。启用缓存相对关闭缓存：双方均6例正收益；贪心17例负收益，本方案2例负收益，其余持平。不能据绝对贡献较小声称缓存模块独立胜过贪心：更便宜的前台减少了可被缓存替代的成本。总J节省1307767可按官方计费恒等式拆为前台调用费408197、提升调用费698318、命中调用费64856、模拟时间费136396，费用拆分不是独立因果消融。39×双方×开关=156次运行均通过官方validator；单次测确定性成本，不产生新的墙钟速度结论。所有原启用版本输出哈希与已有三轮记录一致。扩展退化和极端碎片1.58GiB边界仍见验证报告。</a:t>
+              <a:t>本页两张主图都是正常启用缓存的两套完整方案直接比较，同组39条公开Trace，各自从零起算、组内共享同一比例，费用越低越好；不混入关闭缓存的消融。后台总调用费=提升CPU/NPU费+框架命中H2D调用费：贪心722994+81662=804656，本方案24676+16806=41482，下降94.8447535%。该值不含前台调用费，也不含模拟搬运时间费，不称为整个后台J。平均每次命中的调用费=整条Trace汇总后台调用费/真实命中请求数；804656/40831=19.7069873，本方案41482/8403=4.93657027，下降74.9501525%。这是把所有提升投入（含最终没有命中的提升）和命中调用费摊到总命中数上的比值，包含准入选择的效果，不是单次命中固有单价。官方单次命中调用收费两者均为2，算法没有降低这一收费。每次提升的平均命中数=40831/8817=4.63094与8403/301=27.91694，后者6.02835倍。两项均为完整Trace的汇总效率，不代表单个对象必命中27.92次，不是同尺寸、同缓存内容的受控模块对照。请求总数相同198542，命中率20.57%→4.23%；提升次数与命中数均在页脚公开。选更少的缓存对象、保留更集中复用，是对总计数的解释，不声称每道门槛的独立因果贡献。high_mixed可直接核验：贪心3566次提升、提升调用费292412、命中0；本方案均0。全Trace J530416→174066还有前台变化，不能全算缓存收益。提升调用费单项下降96.59%，提升搬运字节3881057800→327938527，下降91.55%。补充消融与主图分开：双方各自保留前台，仅关闭PROMOTE，贪心J3686550→3581641，缓存净贡献104909；本方案2344079→2273874，缓存净贡献70205。绝对命中量和缓存净贡献较小，不能声称缓存模块在同一前台下收益更大。消融双方各6例正收益，贪心17例负收益、本方案2例；这不表示相对baseline退化。06_reuse_hot：本方案开/关36356/36302，baseline41233；mid_reuse：88409/87179，baseline185453。完整方案分别优于baseline11.83%、52.33%。公开39条35胜4平0负；扩展292条96条退化，详见报告。所有数据由已提交CSV聚合，算法与原始性能记录不变。</a:t>
             </a:r>
           </a:p>
         </p:txBody>
@@ -932,7 +932,7 @@
           <a:lstStyle/>
           <a:p>
             <a:r>
-              <a:t>本页五次点击按执行顺序展开同一输入的代码和数值：1初始化，2联合枚举与组估价，3更新前缀和前驱，4细化 DP，5回溯与官方结果。代码为半开区间伪代码，源码把终点写成j+1。三个源区间[0,512)、[512,1024)、[1024,1536)，目标同卡且分别对齐，不必彼此连续。每条边表示一组片段加一条路径，两阶段均联合选边界和路径。快速DP先以3个片段/3个卡上请求估计qs=qc=3；本例time_cost_per_us=1、池空压力系数为1。读工作1536/(21504×2%×2^20)×10^6=3.40597970145μs；D2D按20×qc MiB/s估计，所以qc=3时复制24.4140625μs；H2D估计7.15255737305μs。三路径调用费分别2、5、12，故表中E是5.40597970145、32.8200422015、22.5585370745。显示值保留3位小数，不应当作实际J。dp[1]=3.135326567、dp[2]=4.270653134；两组的最优累计估价7.40597970145高于整组5.40597970145。细化 DP是同一分组问题增加组数维度：D[h][j]为前j段恰好h组的最低估价，固定cnt后重估带宽，最终看D[cnt][n]。其作用是控制搜索开销，同时缓解组数与并发互相依赖。系统保守空闲、规模及预算允许才运行；qs=active_ssd+cnt，复制并发按快速方案的卡号/类型比例估计，不等于统一取cnt。此例快速方案全DIRECT，细化阶段候选复制qc=1，所以整组AGGREGATE会重算为81.6481672015；不能继续使用快速表内32.820。本例按代码实际尝试顺序cnt=1、3、2，最低E分别5.40597970145、9.40597970145、7.40597970145，页面按组数升序展示。回溯后检验所有NDS请求槽位与两类缓冲池总量，按通过候选中的最低估价选计划，无通过候选则保留快速方案。条件、状态上限和200万预算详见算法文档及复杂度页。这不是精确全Trace最优，DP不规划未来、不决定PROMOTE，也不模拟执行中的队列和流水。最终一个DIRECT传输覆盖三个请求，官方实际Trace时间ceil(3.40597970145)=4μs、CPU=2、NPU=0、J=6；三个分别DIRECT则T=4μs、调用费6、J=10。该例已重新记录所有候选和细化DP终值，输出与原示例逐字节一致，并通过官方validator。</a:t>
+              <a:t>讲解顺序是同一前台规划的三个串行步骤，不是两个互相投票的独立算法。快速DP每批必运行：用片段数与卡上请求数作为初始负载代理，对合法的分组加路径候选求一维前缀最小值，输出完整基础方案。细化DP不是只给原方案打分，也不是只改变路径：它复用同一合法候选边集合，从基础方案读取组数与卡号/复制类型比例，在固定候选总组数cnt后重新求解D[h][j]，可同时改变分组和路径。cnt影响SSD估价并发；复制估价按基础方案的各卡/类型占比计算，并按对应上限处理。为何有两阶段：分组影响并发，而并发影响估价；基础方案提供复制分布，有限细化缓解该相互依赖，避免每批进行高维全量搜索。细化入口要求无活动传输、排队、在途提升、占槽或旧未完成请求；最多1024请求、2048 iov、16384片段，基础方案最多2048操作。合法边至多262144，单次存储状态至多131072，共享200万估价/转移预算；具体预检查与回溯另计。每个cnt回溯后检查总槽位和两类临时池容量。最终选通过检查且完成求解的细化候选中估价最低者；无可用候选则保留基础方案。代码不将快速E和细化E直接比较，也不保证细化后的真实J必降。DP只处理当前未命中的合法连续片段，每起点最多向后看128片段，不规划未来、不决定PROMOTE。五次点击依次显示基础规划、细化、输出选择、更新公式与数值示例、实际结果。三个源区间[0,512)、[512,1024)、[1024,1536)，目标同卡且分别对齐。快速阶段qs=qc=3，整组D/A/F的E为5.406/32.820/22.559；快速dp[1/2/3]=3.135/4.271/5.406。细化时基础方案全DIRECT，复制估价q=1，因此整组AGGREGATE E重算为81.648，不能沿用快速阶段数值。页面只展示同一细化阶段内可比的最终候选：1/2/3组最低E为5.406/7.406/9.406，均由DIRECT取得；代码实际尝试顺序1、3、2。最终读工作3.4059797微秒，Trace时间向上取整为4微秒，调用费2，官方J=6；分别读3次时T=4、调用费6、J=10。已核验输入、估价及官方输出；放映不运行C++。</a:t>
             </a:r>
           </a:p>
         </p:txBody>
@@ -5964,7 +5964,7 @@
       </p:sp>
       <p:sp>
         <p:nvSpPr>
-          <p:cNvPr id="3" name="后台：显著减少提升投入，保留正的缓存净收益"/>
+          <p:cNvPr id="3" name="后台：总调用费更少，每次命中分摊的投入更低"/>
           <p:cNvSpPr txBox="1"/>
           <p:nvPr/>
         </p:nvSpPr>
@@ -6001,14 +6001,14 @@
                 <a:latin typeface="Microsoft YaHei"/>
                 <a:ea typeface="Microsoft YaHei"/>
               </a:rPr>
-              <a:t>后台：显著减少提升投入，保留正的缓存净收益</a:t>
-            </a:r>
-          </a:p>
-        </p:txBody>
-      </p:sp>
-      <p:sp>
-        <p:nvSpPr>
-          <p:cNvPr id="4" name="缓存净收益 ΔJ = 各自关闭 PROMOTE 的 J − 启用时的 J；正值表示收益。39 条分别回放后求和。"/>
+              <a:t>后台：总调用费更少，每次命中分摊的投入更低</a:t>
+            </a:r>
+          </a:p>
+        </p:txBody>
+      </p:sp>
+      <p:sp>
+        <p:nvSpPr>
+          <p:cNvPr id="4" name="39 条公开 Trace，双方均启用缓存；后台调用费 = PROMOTE 调用费 + 命中复制调用费。"/>
           <p:cNvSpPr txBox="1"/>
           <p:nvPr/>
         </p:nvSpPr>
@@ -6045,7 +6045,7 @@
                 <a:latin typeface="Microsoft YaHei"/>
                 <a:ea typeface="Microsoft YaHei"/>
               </a:rPr>
-              <a:t>缓存净收益 ΔJ = 各自关闭 PROMOTE 的 J − 启用时的 J；正值表示收益。39 条分别回放后求和。</a:t>
+              <a:t>39 条公开 Trace，双方均启用缓存；后台调用费 = PROMOTE 调用费 + 命中复制调用费。</a:t>
             </a:r>
           </a:p>
         </p:txBody>
@@ -6176,14 +6176,58 @@
       </p:sp>
       <p:sp>
         <p:nvSpPr>
-          <p:cNvPr id="8" name="提升 CPU + NPU 调用费"/>
+          <p:cNvPr id="8" name="Rectangle 7"/>
+          <p:cNvSpPr/>
+          <p:nvPr/>
+        </p:nvSpPr>
+        <p:spPr>
+          <a:xfrm>
+            <a:off x="609600" y="2085975"/>
+            <a:ext cx="5238750" cy="2867025"/>
+          </a:xfrm>
+          <a:prstGeom prst="rect">
+            <a:avLst/>
+          </a:prstGeom>
+          <a:solidFill>
+            <a:srgbClr val="F3F8F6"/>
+          </a:solidFill>
+          <a:ln>
+            <a:noFill/>
+          </a:ln>
+          <a:effectLst/>
+        </p:spPr>
+        <p:style>
+          <a:lnRef idx="1">
+            <a:schemeClr val="accent1"/>
+          </a:lnRef>
+          <a:fillRef idx="3">
+            <a:schemeClr val="accent1"/>
+          </a:fillRef>
+          <a:effectRef idx="0">
+            <a:schemeClr val="accent1"/>
+          </a:effectRef>
+          <a:fontRef idx="minor">
+            <a:schemeClr val="lt1"/>
+          </a:fontRef>
+        </p:style>
+        <p:txBody>
+          <a:bodyPr rtlCol="0" anchor="ctr"/>
+          <a:lstStyle/>
+          <a:p>
+            <a:pPr algn="ctr"/>
+          </a:p>
+        </p:txBody>
+      </p:sp>
+      <p:sp>
+        <p:nvSpPr>
+          <p:cNvPr id="9" name="39 条累计后台调用费"/>
           <p:cNvSpPr txBox="1"/>
           <p:nvPr/>
         </p:nvSpPr>
         <p:spPr>
           <a:xfrm>
-            <a:off x="609600" y="2124075"/>
-            <a:ext cx="3352800" cy="314325"/>
+            <a:off x="800100" y="2219325"/>
+            <a:ext cx="4857750" cy="314325"/>
           </a:xfrm>
           <a:prstGeom prst="rect">
             <a:avLst/>
@@ -6206,28 +6250,28 @@
               </a:spcAft>
             </a:pPr>
             <a:r>
-              <a:rPr sz="1950" b="1" lang="zh-CN">
+              <a:rPr sz="2025" b="1" lang="zh-CN">
                 <a:solidFill>
                   <a:srgbClr val="24756D"/>
                 </a:solidFill>
                 <a:latin typeface="Microsoft YaHei"/>
                 <a:ea typeface="Microsoft YaHei"/>
               </a:rPr>
-              <a:t>提升 CPU + NPU 调用费</a:t>
-            </a:r>
-          </a:p>
-        </p:txBody>
-      </p:sp>
-      <p:sp>
-        <p:nvSpPr>
-          <p:cNvPr id="9" name="官方贪心  722,994"/>
+              <a:t>39 条累计后台调用费</a:t>
+            </a:r>
+          </a:p>
+        </p:txBody>
+      </p:sp>
+      <p:sp>
+        <p:nvSpPr>
+          <p:cNvPr id="10" name="包含未带来命中的提升投入"/>
           <p:cNvSpPr txBox="1"/>
           <p:nvPr/>
         </p:nvSpPr>
         <p:spPr>
           <a:xfrm>
-            <a:off x="609600" y="2571750"/>
-            <a:ext cx="3352800" cy="276225"/>
+            <a:off x="800100" y="2619375"/>
+            <a:ext cx="4857750" cy="219075"/>
           </a:xfrm>
           <a:prstGeom prst="rect">
             <a:avLst/>
@@ -6250,28 +6294,116 @@
               </a:spcAft>
             </a:pPr>
             <a:r>
-              <a:rPr sz="1575" b="0" lang="zh-CN">
+              <a:rPr sz="1350" b="0" lang="zh-CN">
                 <a:solidFill>
                   <a:srgbClr val="657184"/>
                 </a:solidFill>
                 <a:latin typeface="Microsoft YaHei"/>
                 <a:ea typeface="Microsoft YaHei"/>
               </a:rPr>
-              <a:t>官方贪心  722,994</a:t>
-            </a:r>
-          </a:p>
-        </p:txBody>
-      </p:sp>
-      <p:sp>
-        <p:nvSpPr>
-          <p:cNvPr id="10" name="Rectangle 9"/>
+              <a:t>包含未带来命中的提升投入</a:t>
+            </a:r>
+          </a:p>
+        </p:txBody>
+      </p:sp>
+      <p:sp>
+        <p:nvSpPr>
+          <p:cNvPr id="11" name="↓ 94.84%"/>
+          <p:cNvSpPr txBox="1"/>
+          <p:nvPr/>
+        </p:nvSpPr>
+        <p:spPr>
+          <a:xfrm>
+            <a:off x="800100" y="2924175"/>
+            <a:ext cx="4857750" cy="533400"/>
+          </a:xfrm>
+          <a:prstGeom prst="rect">
+            <a:avLst/>
+          </a:prstGeom>
+          <a:noFill/>
+          <a:effectLst/>
+        </p:spPr>
+        <p:txBody>
+          <a:bodyPr wrap="square" lIns="0" rIns="0" tIns="0" bIns="0">
+            <a:spAutoFit/>
+          </a:bodyPr>
+          <a:lstStyle/>
+          <a:p>
+            <a:pPr algn="l">
+              <a:lnSpc>
+                <a:spcPct val="112000"/>
+              </a:lnSpc>
+              <a:spcAft>
+                <a:spcPts val="500"/>
+              </a:spcAft>
+            </a:pPr>
+            <a:r>
+              <a:rPr sz="3600" b="1" lang="zh-CN">
+                <a:solidFill>
+                  <a:srgbClr val="24756D"/>
+                </a:solidFill>
+                <a:latin typeface="Microsoft YaHei"/>
+                <a:ea typeface="Microsoft YaHei"/>
+              </a:rPr>
+              <a:t>↓ 94.84%</a:t>
+            </a:r>
+          </a:p>
+        </p:txBody>
+      </p:sp>
+      <p:sp>
+        <p:nvSpPr>
+          <p:cNvPr id="12" name="官方贪心    804,656"/>
+          <p:cNvSpPr txBox="1"/>
+          <p:nvPr/>
+        </p:nvSpPr>
+        <p:spPr>
+          <a:xfrm>
+            <a:off x="800100" y="3524250"/>
+            <a:ext cx="4857750" cy="304800"/>
+          </a:xfrm>
+          <a:prstGeom prst="rect">
+            <a:avLst/>
+          </a:prstGeom>
+          <a:noFill/>
+          <a:effectLst/>
+        </p:spPr>
+        <p:txBody>
+          <a:bodyPr wrap="square" lIns="0" rIns="0" tIns="0" bIns="0">
+            <a:spAutoFit/>
+          </a:bodyPr>
+          <a:lstStyle/>
+          <a:p>
+            <a:pPr algn="l">
+              <a:lnSpc>
+                <a:spcPct val="112000"/>
+              </a:lnSpc>
+              <a:spcAft>
+                <a:spcPts val="500"/>
+              </a:spcAft>
+            </a:pPr>
+            <a:r>
+              <a:rPr sz="1950" b="0" lang="zh-CN">
+                <a:solidFill>
+                  <a:srgbClr val="657184"/>
+                </a:solidFill>
+                <a:latin typeface="Microsoft YaHei"/>
+                <a:ea typeface="Microsoft YaHei"/>
+              </a:rPr>
+              <a:t>官方贪心    804,656</a:t>
+            </a:r>
+          </a:p>
+        </p:txBody>
+      </p:sp>
+      <p:sp>
+        <p:nvSpPr>
+          <p:cNvPr id="13" name="Rectangle 12"/>
           <p:cNvSpPr/>
           <p:nvPr/>
         </p:nvSpPr>
         <p:spPr>
           <a:xfrm>
-            <a:off x="609600" y="2905125"/>
-            <a:ext cx="3238500" cy="180975"/>
+            <a:off x="800100" y="3895725"/>
+            <a:ext cx="4857750" cy="171450"/>
           </a:xfrm>
           <a:prstGeom prst="rect">
             <a:avLst/>
@@ -6308,14 +6440,14 @@
       </p:sp>
       <p:sp>
         <p:nvSpPr>
-          <p:cNvPr id="11" name="本方案  24,676"/>
+          <p:cNvPr id="14" name="本方案        41,482"/>
           <p:cNvSpPr txBox="1"/>
           <p:nvPr/>
         </p:nvSpPr>
         <p:spPr>
           <a:xfrm>
-            <a:off x="609600" y="3228975"/>
-            <a:ext cx="3352800" cy="276225"/>
+            <a:off x="800100" y="4248150"/>
+            <a:ext cx="4857750" cy="304800"/>
           </a:xfrm>
           <a:prstGeom prst="rect">
             <a:avLst/>
@@ -6338,28 +6470,28 @@
               </a:spcAft>
             </a:pPr>
             <a:r>
-              <a:rPr sz="1650" b="1" lang="zh-CN">
+              <a:rPr sz="2025" b="1" lang="zh-CN">
                 <a:solidFill>
                   <a:srgbClr val="24756D"/>
                 </a:solidFill>
                 <a:latin typeface="Microsoft YaHei"/>
                 <a:ea typeface="Microsoft YaHei"/>
               </a:rPr>
-              <a:t>本方案  24,676</a:t>
-            </a:r>
-          </a:p>
-        </p:txBody>
-      </p:sp>
-      <p:sp>
-        <p:nvSpPr>
-          <p:cNvPr id="12" name="Rectangle 11"/>
+              <a:t>本方案        41,482</a:t>
+            </a:r>
+          </a:p>
+        </p:txBody>
+      </p:sp>
+      <p:sp>
+        <p:nvSpPr>
+          <p:cNvPr id="15" name="Rectangle 14"/>
           <p:cNvSpPr/>
           <p:nvPr/>
         </p:nvSpPr>
         <p:spPr>
           <a:xfrm>
-            <a:off x="609600" y="3562350"/>
-            <a:ext cx="110530" cy="180975"/>
+            <a:off x="800100" y="4648200"/>
+            <a:ext cx="250428" cy="171450"/>
           </a:xfrm>
           <a:prstGeom prst="rect">
             <a:avLst/>
@@ -6396,14 +6528,58 @@
       </p:sp>
       <p:sp>
         <p:nvSpPr>
-          <p:cNvPr id="13" name="投入减少 96.59%"/>
+          <p:cNvPr id="16" name="Rectangle 15"/>
+          <p:cNvSpPr/>
+          <p:nvPr/>
+        </p:nvSpPr>
+        <p:spPr>
+          <a:xfrm>
+            <a:off x="6343650" y="2085975"/>
+            <a:ext cx="5238750" cy="2867025"/>
+          </a:xfrm>
+          <a:prstGeom prst="rect">
+            <a:avLst/>
+          </a:prstGeom>
+          <a:solidFill>
+            <a:srgbClr val="F3F8F6"/>
+          </a:solidFill>
+          <a:ln>
+            <a:noFill/>
+          </a:ln>
+          <a:effectLst/>
+        </p:spPr>
+        <p:style>
+          <a:lnRef idx="1">
+            <a:schemeClr val="accent1"/>
+          </a:lnRef>
+          <a:fillRef idx="3">
+            <a:schemeClr val="accent1"/>
+          </a:fillRef>
+          <a:effectRef idx="0">
+            <a:schemeClr val="accent1"/>
+          </a:effectRef>
+          <a:fontRef idx="minor">
+            <a:schemeClr val="lt1"/>
+          </a:fontRef>
+        </p:style>
+        <p:txBody>
+          <a:bodyPr rtlCol="0" anchor="ctr"/>
+          <a:lstStyle/>
+          <a:p>
+            <a:pPr algn="ctr"/>
+          </a:p>
+        </p:txBody>
+      </p:sp>
+      <p:sp>
+        <p:nvSpPr>
+          <p:cNvPr id="17" name="每次命中分摊的后台调用费"/>
           <p:cNvSpPr txBox="1"/>
           <p:nvPr/>
         </p:nvSpPr>
         <p:spPr>
           <a:xfrm>
-            <a:off x="609600" y="3905249"/>
-            <a:ext cx="3352800" cy="295275"/>
+            <a:off x="6534150" y="2219325"/>
+            <a:ext cx="4857750" cy="314325"/>
           </a:xfrm>
           <a:prstGeom prst="rect">
             <a:avLst/>
@@ -6426,28 +6602,28 @@
               </a:spcAft>
             </a:pPr>
             <a:r>
-              <a:rPr sz="1875" b="1" lang="zh-CN">
+              <a:rPr sz="2025" b="1" lang="zh-CN">
                 <a:solidFill>
                   <a:srgbClr val="24756D"/>
                 </a:solidFill>
                 <a:latin typeface="Microsoft YaHei"/>
                 <a:ea typeface="Microsoft YaHei"/>
               </a:rPr>
-              <a:t>投入减少 96.59%</a:t>
-            </a:r>
-          </a:p>
-        </p:txBody>
-      </p:sp>
-      <p:sp>
-        <p:nvSpPr>
-          <p:cNvPr id="14" name="真实命中请求数"/>
+              <a:t>每次命中分摊的后台调用费</a:t>
+            </a:r>
+          </a:p>
+        </p:txBody>
+      </p:sp>
+      <p:sp>
+        <p:nvSpPr>
+          <p:cNvPr id="18" name="总后台调用费 ÷ 命中请求数"/>
           <p:cNvSpPr txBox="1"/>
           <p:nvPr/>
         </p:nvSpPr>
         <p:spPr>
           <a:xfrm>
-            <a:off x="4343400" y="2124075"/>
-            <a:ext cx="3352800" cy="314325"/>
+            <a:off x="6534150" y="2619375"/>
+            <a:ext cx="4857750" cy="219075"/>
           </a:xfrm>
           <a:prstGeom prst="rect">
             <a:avLst/>
@@ -6470,28 +6646,28 @@
               </a:spcAft>
             </a:pPr>
             <a:r>
-              <a:rPr sz="1950" b="1" lang="zh-CN">
-                <a:solidFill>
-                  <a:srgbClr val="24756D"/>
-                </a:solidFill>
-                <a:latin typeface="Microsoft YaHei"/>
-                <a:ea typeface="Microsoft YaHei"/>
-              </a:rPr>
-              <a:t>真实命中请求数</a:t>
-            </a:r>
-          </a:p>
-        </p:txBody>
-      </p:sp>
-      <p:sp>
-        <p:nvSpPr>
-          <p:cNvPr id="15" name="官方贪心  40,831 次"/>
+              <a:rPr sz="1350" b="0" lang="zh-CN">
+                <a:solidFill>
+                  <a:srgbClr val="657184"/>
+                </a:solidFill>
+                <a:latin typeface="Microsoft YaHei"/>
+                <a:ea typeface="Microsoft YaHei"/>
+              </a:rPr>
+              <a:t>总后台调用费 ÷ 命中请求数</a:t>
+            </a:r>
+          </a:p>
+        </p:txBody>
+      </p:sp>
+      <p:sp>
+        <p:nvSpPr>
+          <p:cNvPr id="19" name="↓ 74.95%"/>
           <p:cNvSpPr txBox="1"/>
           <p:nvPr/>
         </p:nvSpPr>
         <p:spPr>
           <a:xfrm>
-            <a:off x="4343400" y="2571750"/>
-            <a:ext cx="3352800" cy="276225"/>
+            <a:off x="6534150" y="2924175"/>
+            <a:ext cx="4857750" cy="533400"/>
           </a:xfrm>
           <a:prstGeom prst="rect">
             <a:avLst/>
@@ -6514,28 +6690,72 @@
               </a:spcAft>
             </a:pPr>
             <a:r>
-              <a:rPr sz="1575" b="0" lang="zh-CN">
+              <a:rPr sz="3600" b="1" lang="zh-CN">
+                <a:solidFill>
+                  <a:srgbClr val="24756D"/>
+                </a:solidFill>
+                <a:latin typeface="Microsoft YaHei"/>
+                <a:ea typeface="Microsoft YaHei"/>
+              </a:rPr>
+              <a:t>↓ 74.95%</a:t>
+            </a:r>
+          </a:p>
+        </p:txBody>
+      </p:sp>
+      <p:sp>
+        <p:nvSpPr>
+          <p:cNvPr id="20" name="官方贪心    19.71"/>
+          <p:cNvSpPr txBox="1"/>
+          <p:nvPr/>
+        </p:nvSpPr>
+        <p:spPr>
+          <a:xfrm>
+            <a:off x="6534150" y="3524250"/>
+            <a:ext cx="4857750" cy="304800"/>
+          </a:xfrm>
+          <a:prstGeom prst="rect">
+            <a:avLst/>
+          </a:prstGeom>
+          <a:noFill/>
+          <a:effectLst/>
+        </p:spPr>
+        <p:txBody>
+          <a:bodyPr wrap="square" lIns="0" rIns="0" tIns="0" bIns="0">
+            <a:spAutoFit/>
+          </a:bodyPr>
+          <a:lstStyle/>
+          <a:p>
+            <a:pPr algn="l">
+              <a:lnSpc>
+                <a:spcPct val="112000"/>
+              </a:lnSpc>
+              <a:spcAft>
+                <a:spcPts val="500"/>
+              </a:spcAft>
+            </a:pPr>
+            <a:r>
+              <a:rPr sz="1950" b="0" lang="zh-CN">
                 <a:solidFill>
                   <a:srgbClr val="657184"/>
                 </a:solidFill>
                 <a:latin typeface="Microsoft YaHei"/>
                 <a:ea typeface="Microsoft YaHei"/>
               </a:rPr>
-              <a:t>官方贪心  40,831 次</a:t>
-            </a:r>
-          </a:p>
-        </p:txBody>
-      </p:sp>
-      <p:sp>
-        <p:nvSpPr>
-          <p:cNvPr id="16" name="Rectangle 15"/>
+              <a:t>官方贪心    19.71</a:t>
+            </a:r>
+          </a:p>
+        </p:txBody>
+      </p:sp>
+      <p:sp>
+        <p:nvSpPr>
+          <p:cNvPr id="21" name="Rectangle 20"/>
           <p:cNvSpPr/>
           <p:nvPr/>
         </p:nvSpPr>
         <p:spPr>
           <a:xfrm>
-            <a:off x="4343400" y="2905125"/>
-            <a:ext cx="3238500" cy="180975"/>
+            <a:off x="6534150" y="3895725"/>
+            <a:ext cx="4857750" cy="171450"/>
           </a:xfrm>
           <a:prstGeom prst="rect">
             <a:avLst/>
@@ -6572,14 +6792,14 @@
       </p:sp>
       <p:sp>
         <p:nvSpPr>
-          <p:cNvPr id="17" name="本方案  8,403 次"/>
+          <p:cNvPr id="22" name="本方案        4.94"/>
           <p:cNvSpPr txBox="1"/>
           <p:nvPr/>
         </p:nvSpPr>
         <p:spPr>
           <a:xfrm>
-            <a:off x="4343400" y="3228975"/>
-            <a:ext cx="3352800" cy="276225"/>
+            <a:off x="6534150" y="4248150"/>
+            <a:ext cx="4857750" cy="304800"/>
           </a:xfrm>
           <a:prstGeom prst="rect">
             <a:avLst/>
@@ -6602,28 +6822,28 @@
               </a:spcAft>
             </a:pPr>
             <a:r>
-              <a:rPr sz="1650" b="1" lang="zh-CN">
+              <a:rPr sz="2025" b="1" lang="zh-CN">
                 <a:solidFill>
                   <a:srgbClr val="24756D"/>
                 </a:solidFill>
                 <a:latin typeface="Microsoft YaHei"/>
                 <a:ea typeface="Microsoft YaHei"/>
               </a:rPr>
-              <a:t>本方案  8,403 次</a:t>
-            </a:r>
-          </a:p>
-        </p:txBody>
-      </p:sp>
-      <p:sp>
-        <p:nvSpPr>
-          <p:cNvPr id="18" name="Rectangle 17"/>
+              <a:t>本方案        4.94</a:t>
+            </a:r>
+          </a:p>
+        </p:txBody>
+      </p:sp>
+      <p:sp>
+        <p:nvSpPr>
+          <p:cNvPr id="23" name="Rectangle 22"/>
           <p:cNvSpPr/>
           <p:nvPr/>
         </p:nvSpPr>
         <p:spPr>
           <a:xfrm>
-            <a:off x="4343400" y="3562350"/>
-            <a:ext cx="666481" cy="180975"/>
+            <a:off x="6534150" y="4648200"/>
+            <a:ext cx="1216858" cy="171450"/>
           </a:xfrm>
           <a:prstGeom prst="rect">
             <a:avLst/>
@@ -6660,14 +6880,14 @@
       </p:sp>
       <p:sp>
         <p:nvSpPr>
-          <p:cNvPr id="19" name="命中次数减少 79.42%"/>
+          <p:cNvPr id="24" name="每次提升的平均命中数：4.63 → 27.92，达到贪心的 6.03 倍。"/>
           <p:cNvSpPr txBox="1"/>
           <p:nvPr/>
         </p:nvSpPr>
         <p:spPr>
           <a:xfrm>
-            <a:off x="4343400" y="3905249"/>
-            <a:ext cx="3352800" cy="295275"/>
+            <a:off x="609600" y="5143500"/>
+            <a:ext cx="10972800" cy="314325"/>
           </a:xfrm>
           <a:prstGeom prst="rect">
             <a:avLst/>
@@ -6690,122 +6910,34 @@
               </a:spcAft>
             </a:pPr>
             <a:r>
-              <a:rPr sz="1875" b="1" lang="zh-CN">
+              <a:rPr sz="2025" b="1" lang="zh-CN">
                 <a:solidFill>
                   <a:srgbClr val="24756D"/>
                 </a:solidFill>
                 <a:latin typeface="Microsoft YaHei"/>
                 <a:ea typeface="Microsoft YaHei"/>
               </a:rPr>
-              <a:t>命中次数减少 79.42%</a:t>
-            </a:r>
-          </a:p>
-        </p:txBody>
-      </p:sp>
-      <p:sp>
-        <p:nvSpPr>
-          <p:cNvPr id="20" name="缓存净收益 ΔJ"/>
-          <p:cNvSpPr txBox="1"/>
-          <p:nvPr/>
-        </p:nvSpPr>
-        <p:spPr>
-          <a:xfrm>
-            <a:off x="8077200" y="2124075"/>
-            <a:ext cx="3505200" cy="314325"/>
-          </a:xfrm>
-          <a:prstGeom prst="rect">
-            <a:avLst/>
-          </a:prstGeom>
-          <a:noFill/>
-          <a:effectLst/>
-        </p:spPr>
-        <p:txBody>
-          <a:bodyPr wrap="square" lIns="0" rIns="0" tIns="0" bIns="0">
-            <a:spAutoFit/>
-          </a:bodyPr>
-          <a:lstStyle/>
-          <a:p>
-            <a:pPr algn="l">
-              <a:lnSpc>
-                <a:spcPct val="112000"/>
-              </a:lnSpc>
-              <a:spcAft>
-                <a:spcPts val="500"/>
-              </a:spcAft>
-            </a:pPr>
-            <a:r>
-              <a:rPr sz="1950" b="1" lang="zh-CN">
-                <a:solidFill>
-                  <a:srgbClr val="24756D"/>
-                </a:solidFill>
-                <a:latin typeface="Microsoft YaHei"/>
-                <a:ea typeface="Microsoft YaHei"/>
-              </a:rPr>
-              <a:t>缓存净收益 ΔJ</a:t>
-            </a:r>
-          </a:p>
-        </p:txBody>
-      </p:sp>
-      <p:sp>
-        <p:nvSpPr>
-          <p:cNvPr id="21" name="官方贪心  +104,909"/>
-          <p:cNvSpPr txBox="1"/>
-          <p:nvPr/>
-        </p:nvSpPr>
-        <p:spPr>
-          <a:xfrm>
-            <a:off x="8077200" y="2571750"/>
-            <a:ext cx="3505200" cy="276225"/>
-          </a:xfrm>
-          <a:prstGeom prst="rect">
-            <a:avLst/>
-          </a:prstGeom>
-          <a:noFill/>
-          <a:effectLst/>
-        </p:spPr>
-        <p:txBody>
-          <a:bodyPr wrap="square" lIns="0" rIns="0" tIns="0" bIns="0">
-            <a:spAutoFit/>
-          </a:bodyPr>
-          <a:lstStyle/>
-          <a:p>
-            <a:pPr algn="l">
-              <a:lnSpc>
-                <a:spcPct val="112000"/>
-              </a:lnSpc>
-              <a:spcAft>
-                <a:spcPts val="500"/>
-              </a:spcAft>
-            </a:pPr>
-            <a:r>
-              <a:rPr sz="1575" b="0" lang="zh-CN">
-                <a:solidFill>
-                  <a:srgbClr val="657184"/>
-                </a:solidFill>
-                <a:latin typeface="Microsoft YaHei"/>
-                <a:ea typeface="Microsoft YaHei"/>
-              </a:rPr>
-              <a:t>官方贪心  +104,909</a:t>
-            </a:r>
-          </a:p>
-        </p:txBody>
-      </p:sp>
-      <p:sp>
-        <p:nvSpPr>
-          <p:cNvPr id="22" name="Rectangle 21"/>
+              <a:t>每次提升的平均命中数：4.63 → 27.92，达到贪心的 6.03 倍。</a:t>
+            </a:r>
+          </a:p>
+        </p:txBody>
+      </p:sp>
+      <p:sp>
+        <p:nvSpPr>
+          <p:cNvPr id="25" name="Rectangle 24"/>
           <p:cNvSpPr/>
           <p:nvPr/>
         </p:nvSpPr>
         <p:spPr>
           <a:xfrm>
-            <a:off x="8077200" y="2905125"/>
-            <a:ext cx="3390900" cy="180975"/>
+            <a:off x="609600" y="5600700"/>
+            <a:ext cx="10972800" cy="409575"/>
           </a:xfrm>
           <a:prstGeom prst="rect">
             <a:avLst/>
           </a:prstGeom>
           <a:solidFill>
-            <a:srgbClr val="C8D2DF"/>
+            <a:srgbClr val="F5F7FA"/>
           </a:solidFill>
           <a:ln>
             <a:noFill/>
@@ -6836,14 +6968,14 @@
       </p:sp>
       <p:sp>
         <p:nvSpPr>
-          <p:cNvPr id="23" name="本方案  +70,205"/>
+          <p:cNvPr id="26" name="原因实例 high_mixed：双方命中均为 0，提升 3,566 → 0，省去 292,412 调用费。"/>
           <p:cNvSpPr txBox="1"/>
           <p:nvPr/>
         </p:nvSpPr>
         <p:spPr>
           <a:xfrm>
-            <a:off x="8077200" y="3228975"/>
-            <a:ext cx="3505200" cy="276225"/>
+            <a:off x="762000" y="5686425"/>
+            <a:ext cx="10668000" cy="257175"/>
           </a:xfrm>
           <a:prstGeom prst="rect">
             <a:avLst/>
@@ -6868,70 +7000,26 @@
             <a:r>
               <a:rPr sz="1650" b="1" lang="zh-CN">
                 <a:solidFill>
-                  <a:srgbClr val="24756D"/>
-                </a:solidFill>
-                <a:latin typeface="Microsoft YaHei"/>
-                <a:ea typeface="Microsoft YaHei"/>
-              </a:rPr>
-              <a:t>本方案  +70,205</a:t>
-            </a:r>
-          </a:p>
-        </p:txBody>
-      </p:sp>
-      <p:sp>
-        <p:nvSpPr>
-          <p:cNvPr id="24" name="Rectangle 23"/>
-          <p:cNvSpPr/>
-          <p:nvPr/>
-        </p:nvSpPr>
-        <p:spPr>
-          <a:xfrm>
-            <a:off x="8077200" y="3562350"/>
-            <a:ext cx="2269186" cy="180975"/>
-          </a:xfrm>
-          <a:prstGeom prst="rect">
-            <a:avLst/>
-          </a:prstGeom>
-          <a:solidFill>
-            <a:srgbClr val="24756D"/>
-          </a:solidFill>
-          <a:ln>
-            <a:noFill/>
-          </a:ln>
-          <a:effectLst/>
-        </p:spPr>
-        <p:style>
-          <a:lnRef idx="1">
-            <a:schemeClr val="accent1"/>
-          </a:lnRef>
-          <a:fillRef idx="3">
-            <a:schemeClr val="accent1"/>
-          </a:fillRef>
-          <a:effectRef idx="0">
-            <a:schemeClr val="accent1"/>
-          </a:effectRef>
-          <a:fontRef idx="minor">
-            <a:schemeClr val="lt1"/>
-          </a:fontRef>
-        </p:style>
-        <p:txBody>
-          <a:bodyPr rtlCol="0" anchor="ctr"/>
-          <a:lstStyle/>
-          <a:p>
-            <a:pPr algn="ctr"/>
-          </a:p>
-        </p:txBody>
-      </p:sp>
-      <p:sp>
-        <p:nvSpPr>
-          <p:cNvPr id="25" name="仍有净收益，绝对值更小"/>
+                  <a:srgbClr val="1F2937"/>
+                </a:solidFill>
+                <a:latin typeface="Microsoft YaHei"/>
+                <a:ea typeface="Microsoft YaHei"/>
+              </a:rPr>
+              <a:t>原因实例 high_mixed：双方命中均为 0，提升 3,566 → 0，省去 292,412 调用费。</a:t>
+            </a:r>
+          </a:p>
+        </p:txBody>
+      </p:sp>
+      <p:sp>
+        <p:nvSpPr>
+          <p:cNvPr id="27" name="先汇总再相除：提升 8,817 → 301；命中 40,831 → 8,403。单次命中固定调用费仍为 2，降低的是提升投入的摊销。"/>
           <p:cNvSpPr txBox="1"/>
           <p:nvPr/>
         </p:nvSpPr>
         <p:spPr>
           <a:xfrm>
-            <a:off x="8077200" y="3905249"/>
-            <a:ext cx="3505200" cy="295275"/>
+            <a:off x="609600" y="6105525"/>
+            <a:ext cx="10972800" cy="161925"/>
           </a:xfrm>
           <a:prstGeom prst="rect">
             <a:avLst/>
@@ -6954,210 +7042,14 @@
               </a:spcAft>
             </a:pPr>
             <a:r>
-              <a:rPr sz="1875" b="1" lang="zh-CN">
-                <a:solidFill>
-                  <a:srgbClr val="24756D"/>
-                </a:solidFill>
-                <a:latin typeface="Microsoft YaHei"/>
-                <a:ea typeface="Microsoft YaHei"/>
-              </a:rPr>
-              <a:t>仍有净收益，绝对值更小</a:t>
-            </a:r>
-          </a:p>
-        </p:txBody>
-      </p:sp>
-      <p:sp>
-        <p:nvSpPr>
-          <p:cNvPr id="26" name="提升次数：8,817 → 301；请求命中率：20.57% → 4.23%；命中字节：19.40 → 8.21 GiB。"/>
-          <p:cNvSpPr txBox="1"/>
-          <p:nvPr/>
-        </p:nvSpPr>
-        <p:spPr>
-          <a:xfrm>
-            <a:off x="609600" y="4476750"/>
-            <a:ext cx="10972800" cy="304800"/>
-          </a:xfrm>
-          <a:prstGeom prst="rect">
-            <a:avLst/>
-          </a:prstGeom>
-          <a:noFill/>
-          <a:effectLst/>
-        </p:spPr>
-        <p:txBody>
-          <a:bodyPr wrap="square" lIns="0" rIns="0" tIns="0" bIns="0">
-            <a:spAutoFit/>
-          </a:bodyPr>
-          <a:lstStyle/>
-          <a:p>
-            <a:pPr algn="l">
-              <a:lnSpc>
-                <a:spcPct val="112000"/>
-              </a:lnSpc>
-              <a:spcAft>
-                <a:spcPts val="500"/>
-              </a:spcAft>
-            </a:pPr>
-            <a:r>
-              <a:rPr sz="1725" b="1" lang="zh-CN">
-                <a:solidFill>
-                  <a:srgbClr val="1F2937"/>
-                </a:solidFill>
-                <a:latin typeface="Microsoft YaHei"/>
-                <a:ea typeface="Microsoft YaHei"/>
-              </a:rPr>
-              <a:t>提升次数：8,817 → 301；请求命中率：20.57% → 4.23%；命中字节：19.40 → 8.21 GiB。</a:t>
-            </a:r>
-          </a:p>
-        </p:txBody>
-      </p:sp>
-      <p:sp>
-        <p:nvSpPr>
-          <p:cNvPr id="27" name="Rectangle 26"/>
-          <p:cNvSpPr/>
-          <p:nvPr/>
-        </p:nvSpPr>
-        <p:spPr>
-          <a:xfrm>
-            <a:off x="609600" y="4933950"/>
-            <a:ext cx="10972800" cy="771525"/>
-          </a:xfrm>
-          <a:prstGeom prst="rect">
-            <a:avLst/>
-          </a:prstGeom>
-          <a:solidFill>
-            <a:srgbClr val="EEF6F3"/>
-          </a:solidFill>
-          <a:ln>
-            <a:noFill/>
-          </a:ln>
-          <a:effectLst/>
-        </p:spPr>
-        <p:style>
-          <a:lnRef idx="1">
-            <a:schemeClr val="accent1"/>
-          </a:lnRef>
-          <a:fillRef idx="3">
-            <a:schemeClr val="accent1"/>
-          </a:fillRef>
-          <a:effectRef idx="0">
-            <a:schemeClr val="accent1"/>
-          </a:effectRef>
-          <a:fontRef idx="minor">
-            <a:schemeClr val="lt1"/>
-          </a:fontRef>
-        </p:style>
-        <p:txBody>
-          <a:bodyPr rtlCol="0" anchor="ctr"/>
-          <a:lstStyle/>
-          <a:p>
-            <a:pPr algn="ctr"/>
-          </a:p>
-        </p:txBody>
-      </p:sp>
-      <p:sp>
-        <p:nvSpPr>
-          <p:cNvPr id="28" name="原因：前台读取已更便宜，后台控制额外投入；提升调用费节省 69.83 万，命中调用费节省 6.49 万。 本方案没有追求更多命中，缓存净贡献也低于贪心；整体优势来自联合规划与更少的调用投入。"/>
-          <p:cNvSpPr txBox="1"/>
-          <p:nvPr/>
-        </p:nvSpPr>
-        <p:spPr>
-          <a:xfrm>
-            <a:off x="781050" y="5048250"/>
-            <a:ext cx="10629900" cy="552450"/>
-          </a:xfrm>
-          <a:prstGeom prst="rect">
-            <a:avLst/>
-          </a:prstGeom>
-          <a:noFill/>
-          <a:effectLst/>
-        </p:spPr>
-        <p:txBody>
-          <a:bodyPr wrap="square" lIns="0" rIns="0" tIns="0" bIns="0">
-            <a:spAutoFit/>
-          </a:bodyPr>
-          <a:lstStyle/>
-          <a:p>
-            <a:pPr algn="l">
-              <a:lnSpc>
-                <a:spcPct val="112000"/>
-              </a:lnSpc>
-              <a:spcAft>
-                <a:spcPts val="500"/>
-              </a:spcAft>
-            </a:pPr>
-            <a:r>
-              <a:rPr sz="1650" b="0" lang="zh-CN">
-                <a:solidFill>
-                  <a:srgbClr val="1F2937"/>
-                </a:solidFill>
-                <a:latin typeface="Microsoft YaHei"/>
-                <a:ea typeface="Microsoft YaHei"/>
-              </a:rPr>
-              <a:t>原因：前台读取已更便宜，后台控制额外投入；提升调用费节省 69.83 万，命中调用费节省 6.49 万。</a:t>
-            </a:r>
-          </a:p>
-          <a:p>
-            <a:pPr algn="l">
-              <a:lnSpc>
-                <a:spcPct val="112000"/>
-              </a:lnSpc>
-              <a:spcAft>
-                <a:spcPts val="500"/>
-              </a:spcAft>
-            </a:pPr>
-            <a:r>
-              <a:rPr sz="1650" b="0" lang="zh-CN">
-                <a:solidFill>
-                  <a:srgbClr val="1F2937"/>
-                </a:solidFill>
-                <a:latin typeface="Microsoft YaHei"/>
-                <a:ea typeface="Microsoft YaHei"/>
-              </a:rPr>
-              <a:t>本方案没有追求更多命中，缓存净贡献也低于贪心；整体优势来自联合规划与更少的调用投入。</a:t>
-            </a:r>
-          </a:p>
-        </p:txBody>
-      </p:sp>
-      <p:sp>
-        <p:nvSpPr>
-          <p:cNvPr id="29" name="边界：本方案缓存对照仍有 2 例负收益；扩展集 96/292 例较贪心退化，最大 J 增幅 94.27%。"/>
-          <p:cNvSpPr txBox="1"/>
-          <p:nvPr/>
-        </p:nvSpPr>
-        <p:spPr>
-          <a:xfrm>
-            <a:off x="609600" y="5857875"/>
-            <a:ext cx="10972800" cy="266700"/>
-          </a:xfrm>
-          <a:prstGeom prst="rect">
-            <a:avLst/>
-          </a:prstGeom>
-          <a:noFill/>
-          <a:effectLst/>
-        </p:spPr>
-        <p:txBody>
-          <a:bodyPr wrap="square" lIns="0" rIns="0" tIns="0" bIns="0">
-            <a:spAutoFit/>
-          </a:bodyPr>
-          <a:lstStyle/>
-          <a:p>
-            <a:pPr algn="l">
-              <a:lnSpc>
-                <a:spcPct val="112000"/>
-              </a:lnSpc>
-              <a:spcAft>
-                <a:spcPts val="500"/>
-              </a:spcAft>
-            </a:pPr>
-            <a:r>
-              <a:rPr sz="1500" b="0" lang="zh-CN">
+              <a:rPr sz="1125" b="0" lang="zh-CN">
                 <a:solidFill>
                   <a:srgbClr val="657184"/>
                 </a:solidFill>
                 <a:latin typeface="Microsoft YaHei"/>
                 <a:ea typeface="Microsoft YaHei"/>
               </a:rPr>
-              <a:t>边界：本方案缓存对照仍有 2 例负收益；扩展集 96/292 例较贪心退化，最大 J 增幅 94.27%。</a:t>
+              <a:t>先汇总再相除：提升 8,817 → 301；命中 40,831 → 8,403。单次命中固定调用费仍为 2，降低的是提升投入的摊销。</a:t>
             </a:r>
           </a:p>
         </p:txBody>
@@ -9860,7 +9752,7 @@
       </p:sp>
       <p:sp>
         <p:nvSpPr>
-          <p:cNvPr id="21" name="分块与联合 DP"/>
+          <p:cNvPr id="21" name="联合 DP：基础方案 → 按需细化"/>
           <p:cNvSpPr txBox="1"/>
           <p:nvPr/>
         </p:nvSpPr>
@@ -9897,7 +9789,7 @@
                 <a:latin typeface="Microsoft YaHei"/>
                 <a:ea typeface="Microsoft YaHei"/>
               </a:rPr>
-              <a:t>分块与联合 DP</a:t>
+              <a:t>联合 DP：基础方案 → 按需细化</a:t>
             </a:r>
           </a:p>
         </p:txBody>
@@ -10532,7 +10424,7 @@
       <p:grpSpPr/>
       <p:sp>
         <p:nvSpPr>
-          <p:cNvPr id="2" name="前台联合 DP · 代码可视化"/>
+          <p:cNvPr id="2" name="前台 · 分组与路径联合规划"/>
           <p:cNvSpPr txBox="1"/>
           <p:nvPr/>
         </p:nvSpPr>
@@ -10569,14 +10461,14 @@
                 <a:latin typeface="Microsoft YaHei"/>
                 <a:ea typeface="Microsoft YaHei"/>
               </a:rPr>
-              <a:t>前台联合 DP · 代码可视化</a:t>
-            </a:r>
-          </a:p>
-        </p:txBody>
-      </p:sp>
-      <p:sp>
-        <p:nvSpPr>
-          <p:cNvPr id="3" name="先用快速 DP 规划，满足条件再用细化 DP"/>
+              <a:t>前台 · 分组与路径联合规划</a:t>
+            </a:r>
+          </a:p>
+        </p:txBody>
+      </p:sp>
+      <p:sp>
+        <p:nvSpPr>
+          <p:cNvPr id="3" name="联合 DP：先出基础方案，再按需细化"/>
           <p:cNvSpPr txBox="1"/>
           <p:nvPr/>
         </p:nvSpPr>
@@ -10613,14 +10505,14 @@
                 <a:latin typeface="Microsoft YaHei"/>
                 <a:ea typeface="Microsoft YaHei"/>
               </a:rPr>
-              <a:t>先用快速 DP 规划，满足条件再用细化 DP</a:t>
-            </a:r>
-          </a:p>
-        </p:txBody>
-      </p:sp>
-      <p:sp>
-        <p:nvSpPr>
-          <p:cNvPr id="4" name="范围：仅本批未命中请求；每个起点最多向后看 128 片段，过滤同卡、相邻、对齐及资源约束。"/>
+              <a:t>联合 DP：先出基础方案，再按需细化</a:t>
+            </a:r>
+          </a:p>
+        </p:txBody>
+      </p:sp>
+      <p:sp>
+        <p:nvSpPr>
+          <p:cNvPr id="4" name="分组影响并发，并发又影响成本；基础方案提供复制分布，细化按候选组数重新求解。"/>
           <p:cNvSpPr txBox="1"/>
           <p:nvPr/>
         </p:nvSpPr>
@@ -10657,7 +10549,7 @@
                 <a:latin typeface="Microsoft YaHei"/>
                 <a:ea typeface="Microsoft YaHei"/>
               </a:rPr>
-              <a:t>范围：仅本批未命中请求；每个起点最多向后看 128 片段，过滤同卡、相邻、对齐及资源约束。</a:t>
+              <a:t>分组影响并发，并发又影响成本；基础方案提供复制分布，细化按候选组数重新求解。</a:t>
             </a:r>
           </a:p>
         </p:txBody>
@@ -10788,597 +10680,28 @@
       </p:sp>
       <p:grpSp>
         <p:nvGrpSpPr>
-          <p:cNvPr id="8" name="步骤1：三个对齐片段与初始状态"/>
+          <p:cNvPr id="8" name="步骤1：快速 DP 输出基础方案"/>
           <p:cNvGrpSpPr/>
           <p:nvPr/>
         </p:nvGrpSpPr>
         <p:grpSpPr>
           <a:xfrm>
-            <a:off x="609600" y="2009774"/>
-            <a:ext cx="10972799" cy="419100"/>
-            <a:chOff x="609600" y="2009774"/>
-            <a:chExt cx="10972799" cy="419100"/>
+            <a:off x="609600" y="2076450"/>
+            <a:ext cx="3143250" cy="1114425"/>
+            <a:chOff x="609600" y="2076450"/>
+            <a:chExt cx="3143250" cy="1114425"/>
           </a:xfrm>
         </p:grpSpPr>
         <p:sp>
           <p:nvSpPr>
-            <p:cNvPr id="9" name="同卡、相邻、对齐"/>
-            <p:cNvSpPr txBox="1"/>
+            <p:cNvPr id="9" name="Rectangle 8"/>
+            <p:cNvSpPr/>
             <p:nvPr/>
           </p:nvSpPr>
           <p:spPr>
             <a:xfrm>
               <a:off x="609600" y="2076450"/>
-              <a:ext cx="1743075" cy="295275"/>
-            </a:xfrm>
-            <a:prstGeom prst="rect">
-              <a:avLst/>
-            </a:prstGeom>
-            <a:noFill/>
-            <a:effectLst/>
-          </p:spPr>
-          <p:txBody>
-            <a:bodyPr wrap="square" lIns="0" rIns="0" tIns="0" bIns="0">
-              <a:spAutoFit/>
-            </a:bodyPr>
-            <a:lstStyle/>
-            <a:p>
-              <a:pPr algn="l">
-                <a:lnSpc>
-                  <a:spcPct val="112000"/>
-                </a:lnSpc>
-                <a:spcAft>
-                  <a:spcPts val="500"/>
-                </a:spcAft>
-              </a:pPr>
-              <a:r>
-                <a:rPr sz="1650" b="1" lang="zh-CN">
-                  <a:solidFill>
-                    <a:srgbClr val="1F2937"/>
-                  </a:solidFill>
-                  <a:latin typeface="Microsoft YaHei"/>
-                  <a:ea typeface="Microsoft YaHei"/>
-                </a:rPr>
-                <a:t>同卡、相邻、对齐</a:t>
-              </a:r>
-            </a:p>
-          </p:txBody>
-        </p:sp>
-        <p:sp>
-          <p:nvSpPr>
-            <p:cNvPr id="10" name="Rectangle 9"/>
-            <p:cNvSpPr/>
-            <p:nvPr/>
-          </p:nvSpPr>
-          <p:spPr>
-            <a:xfrm>
-              <a:off x="2438400" y="2009774"/>
-              <a:ext cx="1571625" cy="419100"/>
-            </a:xfrm>
-            <a:prstGeom prst="rect">
-              <a:avLst/>
-            </a:prstGeom>
-            <a:solidFill>
-              <a:srgbClr val="EDF3FA"/>
-            </a:solidFill>
-            <a:ln w="8890">
-              <a:solidFill>
-                <a:srgbClr val="DCE2E9"/>
-              </a:solidFill>
-            </a:ln>
-            <a:effectLst/>
-          </p:spPr>
-          <p:style>
-            <a:lnRef idx="1">
-              <a:schemeClr val="accent1"/>
-            </a:lnRef>
-            <a:fillRef idx="3">
-              <a:schemeClr val="accent1"/>
-            </a:fillRef>
-            <a:effectRef idx="0">
-              <a:schemeClr val="accent1"/>
-            </a:effectRef>
-            <a:fontRef idx="minor">
-              <a:schemeClr val="lt1"/>
-            </a:fontRef>
-          </p:style>
-          <p:txBody>
-            <a:bodyPr rtlCol="0" anchor="ctr"/>
-            <a:lstStyle/>
-            <a:p>
-              <a:pPr algn="ctr"/>
-            </a:p>
-          </p:txBody>
-        </p:sp>
-        <p:sp>
-          <p:nvSpPr>
-            <p:cNvPr id="11" name="P0 · 512B"/>
-            <p:cNvSpPr txBox="1"/>
-            <p:nvPr/>
-          </p:nvSpPr>
-          <p:spPr>
-            <a:xfrm>
-              <a:off x="2514600" y="2095499"/>
-              <a:ext cx="1419225" cy="276225"/>
-            </a:xfrm>
-            <a:prstGeom prst="rect">
-              <a:avLst/>
-            </a:prstGeom>
-            <a:noFill/>
-            <a:effectLst/>
-          </p:spPr>
-          <p:txBody>
-            <a:bodyPr wrap="square" lIns="0" rIns="0" tIns="0" bIns="0">
-              <a:spAutoFit/>
-            </a:bodyPr>
-            <a:lstStyle/>
-            <a:p>
-              <a:pPr algn="ctr">
-                <a:lnSpc>
-                  <a:spcPct val="112000"/>
-                </a:lnSpc>
-                <a:spcAft>
-                  <a:spcPts val="500"/>
-                </a:spcAft>
-              </a:pPr>
-              <a:r>
-                <a:rPr sz="1725" b="1" lang="zh-CN">
-                  <a:solidFill>
-                    <a:srgbClr val="285EA8"/>
-                  </a:solidFill>
-                  <a:latin typeface="Microsoft YaHei"/>
-                  <a:ea typeface="Microsoft YaHei"/>
-                </a:rPr>
-                <a:t>P0 · 512B</a:t>
-              </a:r>
-            </a:p>
-          </p:txBody>
-        </p:sp>
-        <p:sp>
-          <p:nvSpPr>
-            <p:cNvPr id="12" name="Rectangle 11"/>
-            <p:cNvSpPr/>
-            <p:nvPr/>
-          </p:nvSpPr>
-          <p:spPr>
-            <a:xfrm>
-              <a:off x="4162424" y="2009774"/>
-              <a:ext cx="1571625" cy="419100"/>
-            </a:xfrm>
-            <a:prstGeom prst="rect">
-              <a:avLst/>
-            </a:prstGeom>
-            <a:solidFill>
-              <a:srgbClr val="EDF3FA"/>
-            </a:solidFill>
-            <a:ln w="8890">
-              <a:solidFill>
-                <a:srgbClr val="DCE2E9"/>
-              </a:solidFill>
-            </a:ln>
-            <a:effectLst/>
-          </p:spPr>
-          <p:style>
-            <a:lnRef idx="1">
-              <a:schemeClr val="accent1"/>
-            </a:lnRef>
-            <a:fillRef idx="3">
-              <a:schemeClr val="accent1"/>
-            </a:fillRef>
-            <a:effectRef idx="0">
-              <a:schemeClr val="accent1"/>
-            </a:effectRef>
-            <a:fontRef idx="minor">
-              <a:schemeClr val="lt1"/>
-            </a:fontRef>
-          </p:style>
-          <p:txBody>
-            <a:bodyPr rtlCol="0" anchor="ctr"/>
-            <a:lstStyle/>
-            <a:p>
-              <a:pPr algn="ctr"/>
-            </a:p>
-          </p:txBody>
-        </p:sp>
-        <p:sp>
-          <p:nvSpPr>
-            <p:cNvPr id="13" name="P1 · 512B"/>
-            <p:cNvSpPr txBox="1"/>
-            <p:nvPr/>
-          </p:nvSpPr>
-          <p:spPr>
-            <a:xfrm>
-              <a:off x="4238625" y="2095499"/>
-              <a:ext cx="1419225" cy="276225"/>
-            </a:xfrm>
-            <a:prstGeom prst="rect">
-              <a:avLst/>
-            </a:prstGeom>
-            <a:noFill/>
-            <a:effectLst/>
-          </p:spPr>
-          <p:txBody>
-            <a:bodyPr wrap="square" lIns="0" rIns="0" tIns="0" bIns="0">
-              <a:spAutoFit/>
-            </a:bodyPr>
-            <a:lstStyle/>
-            <a:p>
-              <a:pPr algn="ctr">
-                <a:lnSpc>
-                  <a:spcPct val="112000"/>
-                </a:lnSpc>
-                <a:spcAft>
-                  <a:spcPts val="500"/>
-                </a:spcAft>
-              </a:pPr>
-              <a:r>
-                <a:rPr sz="1725" b="1" lang="zh-CN">
-                  <a:solidFill>
-                    <a:srgbClr val="285EA8"/>
-                  </a:solidFill>
-                  <a:latin typeface="Microsoft YaHei"/>
-                  <a:ea typeface="Microsoft YaHei"/>
-                </a:rPr>
-                <a:t>P1 · 512B</a:t>
-              </a:r>
-            </a:p>
-          </p:txBody>
-        </p:sp>
-        <p:sp>
-          <p:nvSpPr>
-            <p:cNvPr id="14" name="Rectangle 13"/>
-            <p:cNvSpPr/>
-            <p:nvPr/>
-          </p:nvSpPr>
-          <p:spPr>
-            <a:xfrm>
-              <a:off x="5886450" y="2009774"/>
-              <a:ext cx="1571625" cy="419100"/>
-            </a:xfrm>
-            <a:prstGeom prst="rect">
-              <a:avLst/>
-            </a:prstGeom>
-            <a:solidFill>
-              <a:srgbClr val="EDF3FA"/>
-            </a:solidFill>
-            <a:ln w="8890">
-              <a:solidFill>
-                <a:srgbClr val="DCE2E9"/>
-              </a:solidFill>
-            </a:ln>
-            <a:effectLst/>
-          </p:spPr>
-          <p:style>
-            <a:lnRef idx="1">
-              <a:schemeClr val="accent1"/>
-            </a:lnRef>
-            <a:fillRef idx="3">
-              <a:schemeClr val="accent1"/>
-            </a:fillRef>
-            <a:effectRef idx="0">
-              <a:schemeClr val="accent1"/>
-            </a:effectRef>
-            <a:fontRef idx="minor">
-              <a:schemeClr val="lt1"/>
-            </a:fontRef>
-          </p:style>
-          <p:txBody>
-            <a:bodyPr rtlCol="0" anchor="ctr"/>
-            <a:lstStyle/>
-            <a:p>
-              <a:pPr algn="ctr"/>
-            </a:p>
-          </p:txBody>
-        </p:sp>
-        <p:sp>
-          <p:nvSpPr>
-            <p:cNvPr id="15" name="P2 · 512B"/>
-            <p:cNvSpPr txBox="1"/>
-            <p:nvPr/>
-          </p:nvSpPr>
-          <p:spPr>
-            <a:xfrm>
-              <a:off x="5962650" y="2095499"/>
-              <a:ext cx="1419225" cy="276225"/>
-            </a:xfrm>
-            <a:prstGeom prst="rect">
-              <a:avLst/>
-            </a:prstGeom>
-            <a:noFill/>
-            <a:effectLst/>
-          </p:spPr>
-          <p:txBody>
-            <a:bodyPr wrap="square" lIns="0" rIns="0" tIns="0" bIns="0">
-              <a:spAutoFit/>
-            </a:bodyPr>
-            <a:lstStyle/>
-            <a:p>
-              <a:pPr algn="ctr">
-                <a:lnSpc>
-                  <a:spcPct val="112000"/>
-                </a:lnSpc>
-                <a:spcAft>
-                  <a:spcPts val="500"/>
-                </a:spcAft>
-              </a:pPr>
-              <a:r>
-                <a:rPr sz="1725" b="1" lang="zh-CN">
-                  <a:solidFill>
-                    <a:srgbClr val="285EA8"/>
-                  </a:solidFill>
-                  <a:latin typeface="Microsoft YaHei"/>
-                  <a:ea typeface="Microsoft YaHei"/>
-                </a:rPr>
-                <a:t>P2 · 512B</a:t>
-              </a:r>
-            </a:p>
-          </p:txBody>
-        </p:sp>
-        <p:sp>
-          <p:nvSpPr>
-            <p:cNvPr id="16" name="dp[0] = 0，其余初始不可达"/>
-            <p:cNvSpPr txBox="1"/>
-            <p:nvPr/>
-          </p:nvSpPr>
-          <p:spPr>
-            <a:xfrm>
-              <a:off x="7981949" y="2095499"/>
-              <a:ext cx="3600450" cy="285750"/>
-            </a:xfrm>
-            <a:prstGeom prst="rect">
-              <a:avLst/>
-            </a:prstGeom>
-            <a:noFill/>
-            <a:effectLst/>
-          </p:spPr>
-          <p:txBody>
-            <a:bodyPr wrap="square" lIns="0" rIns="0" tIns="0" bIns="0">
-              <a:spAutoFit/>
-            </a:bodyPr>
-            <a:lstStyle/>
-            <a:p>
-              <a:pPr algn="l">
-                <a:lnSpc>
-                  <a:spcPct val="112000"/>
-                </a:lnSpc>
-                <a:spcAft>
-                  <a:spcPts val="500"/>
-                </a:spcAft>
-              </a:pPr>
-              <a:r>
-                <a:rPr sz="1650" b="1" lang="zh-CN">
-                  <a:solidFill>
-                    <a:srgbClr val="1F2937"/>
-                  </a:solidFill>
-                  <a:latin typeface="Microsoft YaHei"/>
-                  <a:ea typeface="Microsoft YaHei"/>
-                </a:rPr>
-                <a:t>dp[0] = 0，其余初始不可达</a:t>
-              </a:r>
-            </a:p>
-          </p:txBody>
-        </p:sp>
-      </p:grpSp>
-      <p:sp>
-        <p:nvSpPr>
-          <p:cNvPr id="17" name="dp[j]：前 j 个片段的最低累计估价"/>
-          <p:cNvSpPr txBox="1"/>
-          <p:nvPr/>
-        </p:nvSpPr>
-        <p:spPr>
-          <a:xfrm>
-            <a:off x="609600" y="2581275"/>
-            <a:ext cx="4953000" cy="285750"/>
-          </a:xfrm>
-          <a:prstGeom prst="rect">
-            <a:avLst/>
-          </a:prstGeom>
-          <a:noFill/>
-          <a:effectLst/>
-        </p:spPr>
-        <p:txBody>
-          <a:bodyPr wrap="square" lIns="0" rIns="0" tIns="0" bIns="0">
-            <a:spAutoFit/>
-          </a:bodyPr>
-          <a:lstStyle/>
-          <a:p>
-            <a:pPr algn="l">
-              <a:lnSpc>
-                <a:spcPct val="112000"/>
-              </a:lnSpc>
-              <a:spcAft>
-                <a:spcPts val="500"/>
-              </a:spcAft>
-            </a:pPr>
-            <a:r>
-              <a:rPr sz="1650" b="1" lang="zh-CN">
-                <a:solidFill>
-                  <a:srgbClr val="657184"/>
-                </a:solidFill>
-                <a:latin typeface="Microsoft YaHei"/>
-                <a:ea typeface="Microsoft YaHei"/>
-              </a:rPr>
-              <a:t>dp[j]：前 j 个片段的最低累计估价</a:t>
-            </a:r>
-          </a:p>
-        </p:txBody>
-      </p:sp>
-      <p:sp>
-        <p:nvSpPr>
-          <p:cNvPr id="18" name="Rectangle 17"/>
-          <p:cNvSpPr/>
-          <p:nvPr/>
-        </p:nvSpPr>
-        <p:spPr>
-          <a:xfrm>
-            <a:off x="609600" y="2952750"/>
-            <a:ext cx="4953000" cy="1790700"/>
-          </a:xfrm>
-          <a:prstGeom prst="rect">
-            <a:avLst/>
-          </a:prstGeom>
-          <a:solidFill>
-            <a:srgbClr val="F5F7FA"/>
-          </a:solidFill>
-          <a:ln>
-            <a:noFill/>
-          </a:ln>
-          <a:effectLst/>
-        </p:spPr>
-        <p:style>
-          <a:lnRef idx="1">
-            <a:schemeClr val="accent1"/>
-          </a:lnRef>
-          <a:fillRef idx="3">
-            <a:schemeClr val="accent1"/>
-          </a:fillRef>
-          <a:effectRef idx="0">
-            <a:schemeClr val="accent1"/>
-          </a:effectRef>
-          <a:fontRef idx="minor">
-            <a:schemeClr val="lt1"/>
-          </a:fontRef>
-        </p:style>
-        <p:txBody>
-          <a:bodyPr rtlCol="0" anchor="ctr"/>
-          <a:lstStyle/>
-          <a:p>
-            <a:pPr algn="ctr"/>
-          </a:p>
-        </p:txBody>
-      </p:sp>
-      <p:grpSp>
-        <p:nvGrpSpPr>
-          <p:cNvPr id="19" name="步骤2：快速阶段枚举合法分组和路径"/>
-          <p:cNvGrpSpPr/>
-          <p:nvPr/>
-        </p:nvGrpSpPr>
-        <p:grpSpPr>
-          <a:xfrm>
-            <a:off x="781050" y="2581275"/>
-            <a:ext cx="10801350" cy="1600200"/>
-            <a:chOff x="781050" y="2581275"/>
-            <a:chExt cx="10801350" cy="1600200"/>
-          </a:xfrm>
-        </p:grpSpPr>
-        <p:sp>
-          <p:nvSpPr>
-            <p:cNvPr id="20" name="for (合法的 [i,j), path) {   v = dp[i] + estimate(...);"/>
-            <p:cNvSpPr txBox="1"/>
-            <p:nvPr/>
-          </p:nvSpPr>
-          <p:spPr>
-            <a:xfrm>
-              <a:off x="781050" y="3067050"/>
-              <a:ext cx="4686300" cy="619125"/>
-            </a:xfrm>
-            <a:prstGeom prst="rect">
-              <a:avLst/>
-            </a:prstGeom>
-            <a:noFill/>
-            <a:effectLst/>
-          </p:spPr>
-          <p:txBody>
-            <a:bodyPr wrap="square" lIns="0" rIns="0" tIns="0" bIns="0">
-              <a:spAutoFit/>
-            </a:bodyPr>
-            <a:lstStyle/>
-            <a:p>
-              <a:pPr algn="l">
-                <a:lnSpc>
-                  <a:spcPct val="112000"/>
-                </a:lnSpc>
-                <a:spcAft>
-                  <a:spcPts val="500"/>
-                </a:spcAft>
-              </a:pPr>
-              <a:r>
-                <a:rPr sz="1575" b="1" lang="zh-CN">
-                  <a:solidFill>
-                    <a:srgbClr val="285EA8"/>
-                  </a:solidFill>
-                  <a:latin typeface="Microsoft YaHei"/>
-                  <a:ea typeface="Microsoft YaHei"/>
-                </a:rPr>
-                <a:t>for (合法的 [i,j), path) {</a:t>
-              </a:r>
-            </a:p>
-            <a:p>
-              <a:pPr algn="l">
-                <a:lnSpc>
-                  <a:spcPct val="112000"/>
-                </a:lnSpc>
-                <a:spcAft>
-                  <a:spcPts val="500"/>
-                </a:spcAft>
-              </a:pPr>
-              <a:r>
-                <a:rPr sz="1575" b="1" lang="zh-CN">
-                  <a:solidFill>
-                    <a:srgbClr val="285EA8"/>
-                  </a:solidFill>
-                  <a:latin typeface="Microsoft YaHei"/>
-                  <a:ea typeface="Microsoft YaHei"/>
-                </a:rPr>
-                <a:t>  v = dp[i] + estimate(...);</a:t>
-              </a:r>
-            </a:p>
-          </p:txBody>
-        </p:sp>
-        <p:sp>
-          <p:nvSpPr>
-            <p:cNvPr id="21" name="快速阶段：SSD / 复制并发均估为 3，空池"/>
-            <p:cNvSpPr txBox="1"/>
-            <p:nvPr/>
-          </p:nvSpPr>
-          <p:spPr>
-            <a:xfrm>
-              <a:off x="5924550" y="2581275"/>
-              <a:ext cx="5657850" cy="285750"/>
-            </a:xfrm>
-            <a:prstGeom prst="rect">
-              <a:avLst/>
-            </a:prstGeom>
-            <a:noFill/>
-            <a:effectLst/>
-          </p:spPr>
-          <p:txBody>
-            <a:bodyPr wrap="square" lIns="0" rIns="0" tIns="0" bIns="0">
-              <a:spAutoFit/>
-            </a:bodyPr>
-            <a:lstStyle/>
-            <a:p>
-              <a:pPr algn="l">
-                <a:lnSpc>
-                  <a:spcPct val="112000"/>
-                </a:lnSpc>
-                <a:spcAft>
-                  <a:spcPts val="500"/>
-                </a:spcAft>
-              </a:pPr>
-              <a:r>
-                <a:rPr sz="1575" b="1" lang="zh-CN">
-                  <a:solidFill>
-                    <a:srgbClr val="1F2937"/>
-                  </a:solidFill>
-                  <a:latin typeface="Microsoft YaHei"/>
-                  <a:ea typeface="Microsoft YaHei"/>
-                </a:rPr>
-                <a:t>快速阶段：SSD / 复制并发均估为 3，空池</a:t>
-              </a:r>
-            </a:p>
-          </p:txBody>
-        </p:sp>
-        <p:sp>
-          <p:nvSpPr>
-            <p:cNvPr id="22" name="Rectangle 21"/>
-            <p:cNvSpPr/>
-            <p:nvPr/>
-          </p:nvSpPr>
-          <p:spPr>
-            <a:xfrm>
-              <a:off x="5924550" y="2952750"/>
-              <a:ext cx="5657850" cy="314325"/>
+              <a:ext cx="3143250" cy="1114425"/>
             </a:xfrm>
             <a:prstGeom prst="rect">
               <a:avLst/>
@@ -11415,14 +10738,14 @@
         </p:sp>
         <p:sp>
           <p:nvSpPr>
-            <p:cNvPr id="23" name="路径"/>
+            <p:cNvPr id="10" name="① 快速 DP：先有方案"/>
             <p:cNvSpPr txBox="1"/>
             <p:nvPr/>
           </p:nvSpPr>
           <p:spPr>
             <a:xfrm>
-              <a:off x="6038850" y="3000375"/>
-              <a:ext cx="1685925" cy="238125"/>
+              <a:off x="762000" y="2209800"/>
+              <a:ext cx="2838450" cy="285750"/>
             </a:xfrm>
             <a:prstGeom prst="rect">
               <a:avLst/>
@@ -11445,28 +10768,28 @@
                 </a:spcAft>
               </a:pPr>
               <a:r>
-                <a:rPr sz="1425" b="1" lang="zh-CN">
+                <a:rPr sz="1800" b="1" lang="zh-CN">
                   <a:solidFill>
                     <a:srgbClr val="285EA8"/>
                   </a:solidFill>
                   <a:latin typeface="Microsoft YaHei"/>
                   <a:ea typeface="Microsoft YaHei"/>
                 </a:rPr>
-                <a:t>路径</a:t>
+                <a:t>① 快速 DP：先有方案</a:t>
               </a:r>
             </a:p>
           </p:txBody>
         </p:sp>
         <p:sp>
           <p:nvSpPr>
-            <p:cNvPr id="24" name="读μs + 复制μs + 调用费 = E"/>
+            <p:cNvPr id="11" name="联合选分组和路径 同时得到各卡的复制路径占比"/>
             <p:cNvSpPr txBox="1"/>
             <p:nvPr/>
           </p:nvSpPr>
           <p:spPr>
             <a:xfrm>
-              <a:off x="7848600" y="3000375"/>
-              <a:ext cx="3609975" cy="238125"/>
+              <a:off x="762000" y="2619375"/>
+              <a:ext cx="2838450" cy="504825"/>
             </a:xfrm>
             <a:prstGeom prst="rect">
               <a:avLst/>
@@ -11489,337 +10812,14 @@
                 </a:spcAft>
               </a:pPr>
               <a:r>
-                <a:rPr sz="1425" b="1" lang="zh-CN">
-                  <a:solidFill>
-                    <a:srgbClr val="285EA8"/>
-                  </a:solidFill>
-                  <a:latin typeface="Microsoft YaHei"/>
-                  <a:ea typeface="Microsoft YaHei"/>
-                </a:rPr>
-                <a:t>读μs + 复制μs + 调用费 = E</a:t>
-              </a:r>
-            </a:p>
-          </p:txBody>
-        </p:sp>
-        <p:sp>
-          <p:nvSpPr>
-            <p:cNvPr id="25" name="DIRECT"/>
-            <p:cNvSpPr txBox="1"/>
-            <p:nvPr/>
-          </p:nvSpPr>
-          <p:spPr>
-            <a:xfrm>
-              <a:off x="6038850" y="3343275"/>
-              <a:ext cx="1714500" cy="266700"/>
-            </a:xfrm>
-            <a:prstGeom prst="rect">
-              <a:avLst/>
-            </a:prstGeom>
-            <a:noFill/>
-            <a:effectLst/>
-          </p:spPr>
-          <p:txBody>
-            <a:bodyPr wrap="square" lIns="0" rIns="0" tIns="0" bIns="0">
-              <a:spAutoFit/>
-            </a:bodyPr>
-            <a:lstStyle/>
-            <a:p>
-              <a:pPr algn="l">
-                <a:lnSpc>
-                  <a:spcPct val="112000"/>
-                </a:lnSpc>
-                <a:spcAft>
-                  <a:spcPts val="500"/>
-                </a:spcAft>
-              </a:pPr>
-              <a:r>
-                <a:rPr sz="1500" b="1" lang="zh-CN">
-                  <a:solidFill>
-                    <a:srgbClr val="285EA8"/>
-                  </a:solidFill>
-                  <a:latin typeface="Microsoft YaHei"/>
-                  <a:ea typeface="Microsoft YaHei"/>
-                </a:rPr>
-                <a:t>DIRECT</a:t>
-              </a:r>
-            </a:p>
-          </p:txBody>
-        </p:sp>
-        <p:sp>
-          <p:nvSpPr>
-            <p:cNvPr id="26" name="3.406 + 0 + 2 = 5.406"/>
-            <p:cNvSpPr txBox="1"/>
-            <p:nvPr/>
-          </p:nvSpPr>
-          <p:spPr>
-            <a:xfrm>
-              <a:off x="7848600" y="3343275"/>
-              <a:ext cx="3619500" cy="266700"/>
-            </a:xfrm>
-            <a:prstGeom prst="rect">
-              <a:avLst/>
-            </a:prstGeom>
-            <a:noFill/>
-            <a:effectLst/>
-          </p:spPr>
-          <p:txBody>
-            <a:bodyPr wrap="square" lIns="0" rIns="0" tIns="0" bIns="0">
-              <a:spAutoFit/>
-            </a:bodyPr>
-            <a:lstStyle/>
-            <a:p>
-              <a:pPr algn="l">
-                <a:lnSpc>
-                  <a:spcPct val="112000"/>
-                </a:lnSpc>
-                <a:spcAft>
-                  <a:spcPts val="500"/>
-                </a:spcAft>
-              </a:pPr>
-              <a:r>
-                <a:rPr sz="1500" b="1" lang="zh-CN">
-                  <a:solidFill>
-                    <a:srgbClr val="285EA8"/>
-                  </a:solidFill>
-                  <a:latin typeface="Microsoft YaHei"/>
-                  <a:ea typeface="Microsoft YaHei"/>
-                </a:rPr>
-                <a:t>3.406 + 0 + 2 = 5.406</a:t>
-              </a:r>
-            </a:p>
-          </p:txBody>
-        </p:sp>
-        <p:sp>
-          <p:nvSpPr>
-            <p:cNvPr id="27" name="AGGREGATE"/>
-            <p:cNvSpPr txBox="1"/>
-            <p:nvPr/>
-          </p:nvSpPr>
-          <p:spPr>
-            <a:xfrm>
-              <a:off x="6038850" y="3629025"/>
-              <a:ext cx="1714500" cy="266700"/>
-            </a:xfrm>
-            <a:prstGeom prst="rect">
-              <a:avLst/>
-            </a:prstGeom>
-            <a:noFill/>
-            <a:effectLst/>
-          </p:spPr>
-          <p:txBody>
-            <a:bodyPr wrap="square" lIns="0" rIns="0" tIns="0" bIns="0">
-              <a:spAutoFit/>
-            </a:bodyPr>
-            <a:lstStyle/>
-            <a:p>
-              <a:pPr algn="l">
-                <a:lnSpc>
-                  <a:spcPct val="112000"/>
-                </a:lnSpc>
-                <a:spcAft>
-                  <a:spcPts val="500"/>
-                </a:spcAft>
-              </a:pPr>
-              <a:r>
-                <a:rPr sz="1500" b="0" lang="zh-CN">
+                <a:rPr sz="1575" b="0" lang="zh-CN">
                   <a:solidFill>
                     <a:srgbClr val="1F2937"/>
                   </a:solidFill>
                   <a:latin typeface="Microsoft YaHei"/>
                   <a:ea typeface="Microsoft YaHei"/>
                 </a:rPr>
-                <a:t>AGGREGATE</a:t>
-              </a:r>
-            </a:p>
-          </p:txBody>
-        </p:sp>
-        <p:sp>
-          <p:nvSpPr>
-            <p:cNvPr id="28" name="3.406 + 24.414 + 5 = 32.820"/>
-            <p:cNvSpPr txBox="1"/>
-            <p:nvPr/>
-          </p:nvSpPr>
-          <p:spPr>
-            <a:xfrm>
-              <a:off x="7848600" y="3629025"/>
-              <a:ext cx="3619500" cy="266700"/>
-            </a:xfrm>
-            <a:prstGeom prst="rect">
-              <a:avLst/>
-            </a:prstGeom>
-            <a:noFill/>
-            <a:effectLst/>
-          </p:spPr>
-          <p:txBody>
-            <a:bodyPr wrap="square" lIns="0" rIns="0" tIns="0" bIns="0">
-              <a:spAutoFit/>
-            </a:bodyPr>
-            <a:lstStyle/>
-            <a:p>
-              <a:pPr algn="l">
-                <a:lnSpc>
-                  <a:spcPct val="112000"/>
-                </a:lnSpc>
-                <a:spcAft>
-                  <a:spcPts val="500"/>
-                </a:spcAft>
-              </a:pPr>
-              <a:r>
-                <a:rPr sz="1500" b="0" lang="zh-CN">
-                  <a:solidFill>
-                    <a:srgbClr val="1F2937"/>
-                  </a:solidFill>
-                  <a:latin typeface="Microsoft YaHei"/>
-                  <a:ea typeface="Microsoft YaHei"/>
-                </a:rPr>
-                <a:t>3.406 + 24.414 + 5 = 32.820</a:t>
-              </a:r>
-            </a:p>
-          </p:txBody>
-        </p:sp>
-        <p:sp>
-          <p:nvSpPr>
-            <p:cNvPr id="29" name="FALLBACK"/>
-            <p:cNvSpPr txBox="1"/>
-            <p:nvPr/>
-          </p:nvSpPr>
-          <p:spPr>
-            <a:xfrm>
-              <a:off x="6038850" y="3914775"/>
-              <a:ext cx="1714500" cy="266700"/>
-            </a:xfrm>
-            <a:prstGeom prst="rect">
-              <a:avLst/>
-            </a:prstGeom>
-            <a:noFill/>
-            <a:effectLst/>
-          </p:spPr>
-          <p:txBody>
-            <a:bodyPr wrap="square" lIns="0" rIns="0" tIns="0" bIns="0">
-              <a:spAutoFit/>
-            </a:bodyPr>
-            <a:lstStyle/>
-            <a:p>
-              <a:pPr algn="l">
-                <a:lnSpc>
-                  <a:spcPct val="112000"/>
-                </a:lnSpc>
-                <a:spcAft>
-                  <a:spcPts val="500"/>
-                </a:spcAft>
-              </a:pPr>
-              <a:r>
-                <a:rPr sz="1500" b="0" lang="zh-CN">
-                  <a:solidFill>
-                    <a:srgbClr val="1F2937"/>
-                  </a:solidFill>
-                  <a:latin typeface="Microsoft YaHei"/>
-                  <a:ea typeface="Microsoft YaHei"/>
-                </a:rPr>
-                <a:t>FALLBACK</a:t>
-              </a:r>
-            </a:p>
-          </p:txBody>
-        </p:sp>
-        <p:sp>
-          <p:nvSpPr>
-            <p:cNvPr id="30" name="3.406 + 7.153 + 12 = 22.559"/>
-            <p:cNvSpPr txBox="1"/>
-            <p:nvPr/>
-          </p:nvSpPr>
-          <p:spPr>
-            <a:xfrm>
-              <a:off x="7848600" y="3914775"/>
-              <a:ext cx="3619500" cy="266700"/>
-            </a:xfrm>
-            <a:prstGeom prst="rect">
-              <a:avLst/>
-            </a:prstGeom>
-            <a:noFill/>
-            <a:effectLst/>
-          </p:spPr>
-          <p:txBody>
-            <a:bodyPr wrap="square" lIns="0" rIns="0" tIns="0" bIns="0">
-              <a:spAutoFit/>
-            </a:bodyPr>
-            <a:lstStyle/>
-            <a:p>
-              <a:pPr algn="l">
-                <a:lnSpc>
-                  <a:spcPct val="112000"/>
-                </a:lnSpc>
-                <a:spcAft>
-                  <a:spcPts val="500"/>
-                </a:spcAft>
-              </a:pPr>
-              <a:r>
-                <a:rPr sz="1500" b="0" lang="zh-CN">
-                  <a:solidFill>
-                    <a:srgbClr val="1F2937"/>
-                  </a:solidFill>
-                  <a:latin typeface="Microsoft YaHei"/>
-                  <a:ea typeface="Microsoft YaHei"/>
-                </a:rPr>
-                <a:t>3.406 + 7.153 + 12 = 22.559</a:t>
-              </a:r>
-            </a:p>
-          </p:txBody>
-        </p:sp>
-      </p:grpSp>
-      <p:grpSp>
-        <p:nvGrpSpPr>
-          <p:cNvPr id="31" name="步骤3：更新累计估价并记录边界和路径"/>
-          <p:cNvGrpSpPr/>
-          <p:nvPr/>
-        </p:nvGrpSpPr>
-        <p:grpSpPr>
-          <a:xfrm>
-            <a:off x="781050" y="3648075"/>
-            <a:ext cx="10801350" cy="1152525"/>
-            <a:chOff x="781050" y="3648075"/>
-            <a:chExt cx="10801350" cy="1152525"/>
-          </a:xfrm>
-        </p:grpSpPr>
-        <p:sp>
-          <p:nvSpPr>
-            <p:cNvPr id="32" name="  if (v &lt; dp[j]) {     dp[j]=v; prev[j]=i; paths[j]=path;   } }"/>
-            <p:cNvSpPr txBox="1"/>
-            <p:nvPr/>
-          </p:nvSpPr>
-          <p:spPr>
-            <a:xfrm>
-              <a:off x="781050" y="3648075"/>
-              <a:ext cx="4686300" cy="1028700"/>
-            </a:xfrm>
-            <a:prstGeom prst="rect">
-              <a:avLst/>
-            </a:prstGeom>
-            <a:noFill/>
-            <a:effectLst/>
-          </p:spPr>
-          <p:txBody>
-            <a:bodyPr wrap="square" lIns="0" rIns="0" tIns="0" bIns="0">
-              <a:spAutoFit/>
-            </a:bodyPr>
-            <a:lstStyle/>
-            <a:p>
-              <a:pPr algn="l">
-                <a:lnSpc>
-                  <a:spcPct val="112000"/>
-                </a:lnSpc>
-                <a:spcAft>
-                  <a:spcPts val="500"/>
-                </a:spcAft>
-              </a:pPr>
-              <a:r>
-                <a:rPr sz="1425" b="1" lang="zh-CN">
-                  <a:solidFill>
-                    <a:srgbClr val="24756D"/>
-                  </a:solidFill>
-                  <a:latin typeface="Microsoft YaHei"/>
-                  <a:ea typeface="Microsoft YaHei"/>
-                </a:rPr>
-                <a:t>  if (v &lt; dp[j]) {</a:t>
+                <a:t>联合选分组和路径</a:t>
               </a:r>
             </a:p>
             <a:p>
@@ -11832,142 +10832,14 @@
                 </a:spcAft>
               </a:pPr>
               <a:r>
-                <a:rPr sz="1425" b="1" lang="zh-CN">
-                  <a:solidFill>
-                    <a:srgbClr val="24756D"/>
-                  </a:solidFill>
-                  <a:latin typeface="Microsoft YaHei"/>
-                  <a:ea typeface="Microsoft YaHei"/>
-                </a:rPr>
-                <a:t>    dp[j]=v; prev[j]=i; paths[j]=path;</a:t>
-              </a:r>
-            </a:p>
-            <a:p>
-              <a:pPr algn="l">
-                <a:lnSpc>
-                  <a:spcPct val="112000"/>
-                </a:lnSpc>
-                <a:spcAft>
-                  <a:spcPts val="500"/>
-                </a:spcAft>
-              </a:pPr>
-              <a:r>
-                <a:rPr sz="1425" b="1" lang="zh-CN">
-                  <a:solidFill>
-                    <a:srgbClr val="24756D"/>
-                  </a:solidFill>
-                  <a:latin typeface="Microsoft YaHei"/>
-                  <a:ea typeface="Microsoft YaHei"/>
-                </a:rPr>
-                <a:t>  }</a:t>
-              </a:r>
-            </a:p>
-            <a:p>
-              <a:pPr algn="l">
-                <a:lnSpc>
-                  <a:spcPct val="112000"/>
-                </a:lnSpc>
-                <a:spcAft>
-                  <a:spcPts val="500"/>
-                </a:spcAft>
-              </a:pPr>
-              <a:r>
-                <a:rPr sz="1425" b="1" lang="zh-CN">
-                  <a:solidFill>
-                    <a:srgbClr val="24756D"/>
-                  </a:solidFill>
-                  <a:latin typeface="Microsoft YaHei"/>
-                  <a:ea typeface="Microsoft YaHei"/>
-                </a:rPr>
-                <a:t>}</a:t>
-              </a:r>
-            </a:p>
-          </p:txBody>
-        </p:sp>
-        <p:sp>
-          <p:nvSpPr>
-            <p:cNvPr id="33" name="dp[1]=3.135；dp[2]=4.271；dp[3]=5.406"/>
-            <p:cNvSpPr txBox="1"/>
-            <p:nvPr/>
-          </p:nvSpPr>
-          <p:spPr>
-            <a:xfrm>
-              <a:off x="5924550" y="4286250"/>
-              <a:ext cx="5657850" cy="238125"/>
-            </a:xfrm>
-            <a:prstGeom prst="rect">
-              <a:avLst/>
-            </a:prstGeom>
-            <a:noFill/>
-            <a:effectLst/>
-          </p:spPr>
-          <p:txBody>
-            <a:bodyPr wrap="square" lIns="0" rIns="0" tIns="0" bIns="0">
-              <a:spAutoFit/>
-            </a:bodyPr>
-            <a:lstStyle/>
-            <a:p>
-              <a:pPr algn="l">
-                <a:lnSpc>
-                  <a:spcPct val="112000"/>
-                </a:lnSpc>
-                <a:spcAft>
-                  <a:spcPts val="500"/>
-                </a:spcAft>
-              </a:pPr>
-              <a:r>
-                <a:rPr sz="1575" b="1" lang="zh-CN">
-                  <a:solidFill>
-                    <a:srgbClr val="285EA8"/>
-                  </a:solidFill>
-                  <a:latin typeface="Microsoft YaHei"/>
-                  <a:ea typeface="Microsoft YaHei"/>
-                </a:rPr>
-                <a:t>dp[1]=3.135；dp[2]=4.271；dp[3]=5.406</a:t>
-              </a:r>
-            </a:p>
-          </p:txBody>
-        </p:sp>
-        <p:sp>
-          <p:nvSpPr>
-            <p:cNvPr id="34" name="快速 DP 输出：[P0,P1,P2] → DIRECT，E=5.406。"/>
-            <p:cNvSpPr txBox="1"/>
-            <p:nvPr/>
-          </p:nvSpPr>
-          <p:spPr>
-            <a:xfrm>
-              <a:off x="5924550" y="4572000"/>
-              <a:ext cx="5657850" cy="228600"/>
-            </a:xfrm>
-            <a:prstGeom prst="rect">
-              <a:avLst/>
-            </a:prstGeom>
-            <a:noFill/>
-            <a:effectLst/>
-          </p:spPr>
-          <p:txBody>
-            <a:bodyPr wrap="square" lIns="0" rIns="0" tIns="0" bIns="0">
-              <a:spAutoFit/>
-            </a:bodyPr>
-            <a:lstStyle/>
-            <a:p>
-              <a:pPr algn="l">
-                <a:lnSpc>
-                  <a:spcPct val="112000"/>
-                </a:lnSpc>
-                <a:spcAft>
-                  <a:spcPts val="500"/>
-                </a:spcAft>
-              </a:pPr>
-              <a:r>
-                <a:rPr sz="1500" b="0" lang="zh-CN">
+                <a:rPr sz="1575" b="0" lang="zh-CN">
                   <a:solidFill>
                     <a:srgbClr val="1F2937"/>
                   </a:solidFill>
                   <a:latin typeface="Microsoft YaHei"/>
                   <a:ea typeface="Microsoft YaHei"/>
                 </a:rPr>
-                <a:t>快速 DP 输出：[P0,P1,P2] → DIRECT，E=5.406。</a:t>
+                <a:t>同时得到各卡的复制路径占比</a:t>
               </a:r>
             </a:p>
           </p:txBody>
@@ -11975,28 +10847,65 @@
       </p:grpSp>
       <p:grpSp>
         <p:nvGrpSpPr>
-          <p:cNvPr id="35" name="步骤4：有条件地按细化 DP"/>
+          <p:cNvPr id="12" name="步骤2：沿用候选与基础方案统计，按需细化"/>
           <p:cNvGrpSpPr/>
           <p:nvPr/>
         </p:nvGrpSpPr>
         <p:grpSpPr>
           <a:xfrm>
-            <a:off x="609600" y="4943475"/>
-            <a:ext cx="10972800" cy="657225"/>
-            <a:chOff x="609600" y="4943475"/>
-            <a:chExt cx="10972800" cy="657225"/>
+            <a:off x="3829050" y="2076450"/>
+            <a:ext cx="3857624" cy="1114425"/>
+            <a:chOff x="3829050" y="2076450"/>
+            <a:chExt cx="3857624" cy="1114425"/>
           </a:xfrm>
         </p:grpSpPr>
+        <p:cxnSp>
+          <p:nvCxnSpPr>
+            <p:cNvPr id="13" name="Connector 12"/>
+            <p:cNvCxnSpPr/>
+            <p:nvPr/>
+          </p:nvCxnSpPr>
+          <p:spPr>
+            <a:xfrm>
+              <a:off x="3829050" y="2609850"/>
+              <a:ext cx="238125" cy="0"/>
+            </a:xfrm>
+            <a:prstGeom prst="line">
+              <a:avLst/>
+            </a:prstGeom>
+            <a:ln w="20320">
+              <a:solidFill>
+                <a:srgbClr val="285EA8"/>
+              </a:solidFill>
+              <a:tailEnd type="triangle"/>
+            </a:ln>
+            <a:effectLst/>
+          </p:spPr>
+          <p:style>
+            <a:lnRef idx="2">
+              <a:schemeClr val="accent1"/>
+            </a:lnRef>
+            <a:fillRef idx="0">
+              <a:schemeClr val="accent1"/>
+            </a:fillRef>
+            <a:effectRef idx="0">
+              <a:schemeClr val="accent1"/>
+            </a:effectRef>
+            <a:fontRef idx="minor">
+              <a:schemeClr val="tx1"/>
+            </a:fontRef>
+          </p:style>
+        </p:cxnSp>
         <p:sp>
           <p:nvSpPr>
-            <p:cNvPr id="36" name="Rectangle 35"/>
+            <p:cNvPr id="14" name="Rectangle 13"/>
             <p:cNvSpPr/>
             <p:nvPr/>
           </p:nvSpPr>
           <p:spPr>
             <a:xfrm>
-              <a:off x="609600" y="4943475"/>
-              <a:ext cx="10972800" cy="657225"/>
+              <a:off x="4190999" y="2076450"/>
+              <a:ext cx="3495675" cy="1114425"/>
             </a:xfrm>
             <a:prstGeom prst="rect">
               <a:avLst/>
@@ -12033,14 +10942,14 @@
         </p:sp>
         <p:sp>
           <p:nvSpPr>
-            <p:cNvPr id="37" name="细化 DP：空闲且规模、预算允许时，采样候选组数 cnt、重估并发，检查总槽位与池容量。"/>
+            <p:cNvPr id="15" name="② 细化 DP：按组数重估"/>
             <p:cNvSpPr txBox="1"/>
             <p:nvPr/>
           </p:nvSpPr>
           <p:spPr>
             <a:xfrm>
-              <a:off x="781050" y="5029200"/>
-              <a:ext cx="10629900" cy="276225"/>
+              <a:off x="4343400" y="2209800"/>
+              <a:ext cx="3190875" cy="285750"/>
             </a:xfrm>
             <a:prstGeom prst="rect">
               <a:avLst/>
@@ -12063,28 +10972,487 @@
                 </a:spcAft>
               </a:pPr>
               <a:r>
-                <a:rPr sz="1725" b="1" lang="zh-CN">
+                <a:rPr sz="1800" b="1" lang="zh-CN">
                   <a:solidFill>
                     <a:srgbClr val="24756D"/>
                   </a:solidFill>
                   <a:latin typeface="Microsoft YaHei"/>
                   <a:ea typeface="Microsoft YaHei"/>
                 </a:rPr>
-                <a:t>细化 DP：空闲且规模、预算允许时，采样候选组数 cnt、重估并发，检查总槽位与池容量。</a:t>
+                <a:t>② 细化 DP：按组数重估</a:t>
               </a:r>
             </a:p>
           </p:txBody>
         </p:sp>
         <p:sp>
           <p:nvSpPr>
-            <p:cNvPr id="38" name="1/2/3 组的最优 E=5.406/7.406/9.406 → 仍输出 1 组 DIRECT；AGG 重估 32.820 → 81.648。"/>
+            <p:cNvPr id="16" name="沿用候选，重估 SSD / 复制并发 重新选择分组和路径"/>
             <p:cNvSpPr txBox="1"/>
             <p:nvPr/>
           </p:nvSpPr>
           <p:spPr>
             <a:xfrm>
-              <a:off x="781050" y="5362575"/>
-              <a:ext cx="10629900" cy="228600"/>
+              <a:off x="4343400" y="2619375"/>
+              <a:ext cx="3190875" cy="504825"/>
+            </a:xfrm>
+            <a:prstGeom prst="rect">
+              <a:avLst/>
+            </a:prstGeom>
+            <a:noFill/>
+            <a:effectLst/>
+          </p:spPr>
+          <p:txBody>
+            <a:bodyPr wrap="square" lIns="0" rIns="0" tIns="0" bIns="0">
+              <a:spAutoFit/>
+            </a:bodyPr>
+            <a:lstStyle/>
+            <a:p>
+              <a:pPr algn="l">
+                <a:lnSpc>
+                  <a:spcPct val="112000"/>
+                </a:lnSpc>
+                <a:spcAft>
+                  <a:spcPts val="500"/>
+                </a:spcAft>
+              </a:pPr>
+              <a:r>
+                <a:rPr sz="1575" b="0" lang="zh-CN">
+                  <a:solidFill>
+                    <a:srgbClr val="1F2937"/>
+                  </a:solidFill>
+                  <a:latin typeface="Microsoft YaHei"/>
+                  <a:ea typeface="Microsoft YaHei"/>
+                </a:rPr>
+                <a:t>沿用候选，重估 SSD / 复制并发</a:t>
+              </a:r>
+            </a:p>
+            <a:p>
+              <a:pPr algn="l">
+                <a:lnSpc>
+                  <a:spcPct val="112000"/>
+                </a:lnSpc>
+                <a:spcAft>
+                  <a:spcPts val="500"/>
+                </a:spcAft>
+              </a:pPr>
+              <a:r>
+                <a:rPr sz="1575" b="0" lang="zh-CN">
+                  <a:solidFill>
+                    <a:srgbClr val="1F2937"/>
+                  </a:solidFill>
+                  <a:latin typeface="Microsoft YaHei"/>
+                  <a:ea typeface="Microsoft YaHei"/>
+                </a:rPr>
+                <a:t>重新选择分组和路径</a:t>
+              </a:r>
+            </a:p>
+          </p:txBody>
+        </p:sp>
+      </p:grpSp>
+      <p:grpSp>
+        <p:nvGrpSpPr>
+          <p:cNvPr id="17" name="步骤3：按条件选择唯一的提交方案"/>
+          <p:cNvGrpSpPr/>
+          <p:nvPr/>
+        </p:nvGrpSpPr>
+        <p:grpSpPr>
+          <a:xfrm>
+            <a:off x="609600" y="2076450"/>
+            <a:ext cx="10972800" cy="1524000"/>
+            <a:chOff x="609600" y="2076450"/>
+            <a:chExt cx="10972800" cy="1524000"/>
+          </a:xfrm>
+        </p:grpSpPr>
+        <p:cxnSp>
+          <p:nvCxnSpPr>
+            <p:cNvPr id="18" name="Connector 17"/>
+            <p:cNvCxnSpPr/>
+            <p:nvPr/>
+          </p:nvCxnSpPr>
+          <p:spPr>
+            <a:xfrm>
+              <a:off x="7762875" y="2609850"/>
+              <a:ext cx="238125" cy="0"/>
+            </a:xfrm>
+            <a:prstGeom prst="line">
+              <a:avLst/>
+            </a:prstGeom>
+            <a:ln w="20320">
+              <a:solidFill>
+                <a:srgbClr val="285EA8"/>
+              </a:solidFill>
+              <a:tailEnd type="triangle"/>
+            </a:ln>
+            <a:effectLst/>
+          </p:spPr>
+          <p:style>
+            <a:lnRef idx="2">
+              <a:schemeClr val="accent1"/>
+            </a:lnRef>
+            <a:fillRef idx="0">
+              <a:schemeClr val="accent1"/>
+            </a:fillRef>
+            <a:effectRef idx="0">
+              <a:schemeClr val="accent1"/>
+            </a:effectRef>
+            <a:fontRef idx="minor">
+              <a:schemeClr val="tx1"/>
+            </a:fontRef>
+          </p:style>
+        </p:cxnSp>
+        <p:sp>
+          <p:nvSpPr>
+            <p:cNvPr id="19" name="Rectangle 18"/>
+            <p:cNvSpPr/>
+            <p:nvPr/>
+          </p:nvSpPr>
+          <p:spPr>
+            <a:xfrm>
+              <a:off x="8124824" y="2076450"/>
+              <a:ext cx="3457575" cy="1114425"/>
+            </a:xfrm>
+            <a:prstGeom prst="rect">
+              <a:avLst/>
+            </a:prstGeom>
+            <a:solidFill>
+              <a:srgbClr val="EDF3FA"/>
+            </a:solidFill>
+            <a:ln>
+              <a:noFill/>
+            </a:ln>
+            <a:effectLst/>
+          </p:spPr>
+          <p:style>
+            <a:lnRef idx="1">
+              <a:schemeClr val="accent1"/>
+            </a:lnRef>
+            <a:fillRef idx="3">
+              <a:schemeClr val="accent1"/>
+            </a:fillRef>
+            <a:effectRef idx="0">
+              <a:schemeClr val="accent1"/>
+            </a:effectRef>
+            <a:fontRef idx="minor">
+              <a:schemeClr val="lt1"/>
+            </a:fontRef>
+          </p:style>
+          <p:txBody>
+            <a:bodyPr rtlCol="0" anchor="ctr"/>
+            <a:lstStyle/>
+            <a:p>
+              <a:pPr algn="ctr"/>
+            </a:p>
+          </p:txBody>
+        </p:sp>
+        <p:sp>
+          <p:nvSpPr>
+            <p:cNvPr id="20" name="③ 只提交一份最终方案"/>
+            <p:cNvSpPr txBox="1"/>
+            <p:nvPr/>
+          </p:nvSpPr>
+          <p:spPr>
+            <a:xfrm>
+              <a:off x="8277225" y="2209800"/>
+              <a:ext cx="3152775" cy="285750"/>
+            </a:xfrm>
+            <a:prstGeom prst="rect">
+              <a:avLst/>
+            </a:prstGeom>
+            <a:noFill/>
+            <a:effectLst/>
+          </p:spPr>
+          <p:txBody>
+            <a:bodyPr wrap="square" lIns="0" rIns="0" tIns="0" bIns="0">
+              <a:spAutoFit/>
+            </a:bodyPr>
+            <a:lstStyle/>
+            <a:p>
+              <a:pPr algn="l">
+                <a:lnSpc>
+                  <a:spcPct val="112000"/>
+                </a:lnSpc>
+                <a:spcAft>
+                  <a:spcPts val="500"/>
+                </a:spcAft>
+              </a:pPr>
+              <a:r>
+                <a:rPr sz="1800" b="1" lang="zh-CN">
+                  <a:solidFill>
+                    <a:srgbClr val="285EA8"/>
+                  </a:solidFill>
+                  <a:latin typeface="Microsoft YaHei"/>
+                  <a:ea typeface="Microsoft YaHei"/>
+                </a:rPr>
+                <a:t>③ 只提交一份最终方案</a:t>
+              </a:r>
+            </a:p>
+          </p:txBody>
+        </p:sp>
+        <p:sp>
+          <p:nvSpPr>
+            <p:cNvPr id="21" name="有可用细化候选：选其最低估价 否则：保留基础方案"/>
+            <p:cNvSpPr txBox="1"/>
+            <p:nvPr/>
+          </p:nvSpPr>
+          <p:spPr>
+            <a:xfrm>
+              <a:off x="8277225" y="2619375"/>
+              <a:ext cx="3152775" cy="504825"/>
+            </a:xfrm>
+            <a:prstGeom prst="rect">
+              <a:avLst/>
+            </a:prstGeom>
+            <a:noFill/>
+            <a:effectLst/>
+          </p:spPr>
+          <p:txBody>
+            <a:bodyPr wrap="square" lIns="0" rIns="0" tIns="0" bIns="0">
+              <a:spAutoFit/>
+            </a:bodyPr>
+            <a:lstStyle/>
+            <a:p>
+              <a:pPr algn="l">
+                <a:lnSpc>
+                  <a:spcPct val="112000"/>
+                </a:lnSpc>
+                <a:spcAft>
+                  <a:spcPts val="500"/>
+                </a:spcAft>
+              </a:pPr>
+              <a:r>
+                <a:rPr sz="1575" b="0" lang="zh-CN">
+                  <a:solidFill>
+                    <a:srgbClr val="1F2937"/>
+                  </a:solidFill>
+                  <a:latin typeface="Microsoft YaHei"/>
+                  <a:ea typeface="Microsoft YaHei"/>
+                </a:rPr>
+                <a:t>有可用细化候选：选其最低估价</a:t>
+              </a:r>
+            </a:p>
+            <a:p>
+              <a:pPr algn="l">
+                <a:lnSpc>
+                  <a:spcPct val="112000"/>
+                </a:lnSpc>
+                <a:spcAft>
+                  <a:spcPts val="500"/>
+                </a:spcAft>
+              </a:pPr>
+              <a:r>
+                <a:rPr sz="1575" b="0" lang="zh-CN">
+                  <a:solidFill>
+                    <a:srgbClr val="1F2937"/>
+                  </a:solidFill>
+                  <a:latin typeface="Microsoft YaHei"/>
+                  <a:ea typeface="Microsoft YaHei"/>
+                </a:rPr>
+                <a:t>否则：保留基础方案</a:t>
+              </a:r>
+            </a:p>
+          </p:txBody>
+        </p:sp>
+        <p:sp>
+          <p:nvSpPr>
+            <p:cNvPr id="22" name="细化入口：系统空闲，规模与预算允许；候选回溯后，还须通过总槽位与池容量检查。"/>
+            <p:cNvSpPr txBox="1"/>
+            <p:nvPr/>
+          </p:nvSpPr>
+          <p:spPr>
+            <a:xfrm>
+              <a:off x="609600" y="3324225"/>
+              <a:ext cx="10972800" cy="276225"/>
+            </a:xfrm>
+            <a:prstGeom prst="rect">
+              <a:avLst/>
+            </a:prstGeom>
+            <a:noFill/>
+            <a:effectLst/>
+          </p:spPr>
+          <p:txBody>
+            <a:bodyPr wrap="square" lIns="0" rIns="0" tIns="0" bIns="0">
+              <a:spAutoFit/>
+            </a:bodyPr>
+            <a:lstStyle/>
+            <a:p>
+              <a:pPr algn="l">
+                <a:lnSpc>
+                  <a:spcPct val="112000"/>
+                </a:lnSpc>
+                <a:spcAft>
+                  <a:spcPts val="500"/>
+                </a:spcAft>
+              </a:pPr>
+              <a:r>
+                <a:rPr sz="1650" b="1" lang="zh-CN">
+                  <a:solidFill>
+                    <a:srgbClr val="24756D"/>
+                  </a:solidFill>
+                  <a:latin typeface="Microsoft YaHei"/>
+                  <a:ea typeface="Microsoft YaHei"/>
+                </a:rPr>
+                <a:t>细化入口：系统空闲，规模与预算允许；候选回溯后，还须通过总槽位与池容量检查。</a:t>
+              </a:r>
+            </a:p>
+          </p:txBody>
+        </p:sp>
+      </p:grpSp>
+      <p:grpSp>
+        <p:nvGrpSpPr>
+          <p:cNvPr id="23" name="步骤4：同一个联合更新规则与三片段示例"/>
+          <p:cNvGrpSpPr/>
+          <p:nvPr/>
+        </p:nvGrpSpPr>
+        <p:grpSpPr>
+          <a:xfrm>
+            <a:off x="609600" y="3838575"/>
+            <a:ext cx="10972800" cy="1447800"/>
+            <a:chOff x="609600" y="3838575"/>
+            <a:chExt cx="10972800" cy="1447800"/>
+          </a:xfrm>
+        </p:grpSpPr>
+        <p:sp>
+          <p:nvSpPr>
+            <p:cNvPr id="24" name="Rectangle 23"/>
+            <p:cNvSpPr/>
+            <p:nvPr/>
+          </p:nvSpPr>
+          <p:spPr>
+            <a:xfrm>
+              <a:off x="609600" y="3838575"/>
+              <a:ext cx="5238750" cy="1447800"/>
+            </a:xfrm>
+            <a:prstGeom prst="rect">
+              <a:avLst/>
+            </a:prstGeom>
+            <a:solidFill>
+              <a:srgbClr val="F5F7FA"/>
+            </a:solidFill>
+            <a:ln>
+              <a:noFill/>
+            </a:ln>
+            <a:effectLst/>
+          </p:spPr>
+          <p:style>
+            <a:lnRef idx="1">
+              <a:schemeClr val="accent1"/>
+            </a:lnRef>
+            <a:fillRef idx="3">
+              <a:schemeClr val="accent1"/>
+            </a:fillRef>
+            <a:effectRef idx="0">
+              <a:schemeClr val="accent1"/>
+            </a:effectRef>
+            <a:fontRef idx="minor">
+              <a:schemeClr val="lt1"/>
+            </a:fontRef>
+          </p:style>
+          <p:txBody>
+            <a:bodyPr rtlCol="0" anchor="ctr"/>
+            <a:lstStyle/>
+            <a:p>
+              <a:pPr algn="ctr"/>
+            </a:p>
+          </p:txBody>
+        </p:sp>
+        <p:sp>
+          <p:nvSpPr>
+            <p:cNvPr id="25" name="核心更新：每次同时选择边界 i 与路径 path"/>
+            <p:cNvSpPr txBox="1"/>
+            <p:nvPr/>
+          </p:nvSpPr>
+          <p:spPr>
+            <a:xfrm>
+              <a:off x="781050" y="3962399"/>
+              <a:ext cx="4895850" cy="276225"/>
+            </a:xfrm>
+            <a:prstGeom prst="rect">
+              <a:avLst/>
+            </a:prstGeom>
+            <a:noFill/>
+            <a:effectLst/>
+          </p:spPr>
+          <p:txBody>
+            <a:bodyPr wrap="square" lIns="0" rIns="0" tIns="0" bIns="0">
+              <a:spAutoFit/>
+            </a:bodyPr>
+            <a:lstStyle/>
+            <a:p>
+              <a:pPr algn="l">
+                <a:lnSpc>
+                  <a:spcPct val="112000"/>
+                </a:lnSpc>
+                <a:spcAft>
+                  <a:spcPts val="500"/>
+                </a:spcAft>
+              </a:pPr>
+              <a:r>
+                <a:rPr sz="1650" b="1" lang="zh-CN">
+                  <a:solidFill>
+                    <a:srgbClr val="285EA8"/>
+                  </a:solidFill>
+                  <a:latin typeface="Microsoft YaHei"/>
+                  <a:ea typeface="Microsoft YaHei"/>
+                </a:rPr>
+                <a:t>核心更新：每次同时选择边界 i 与路径 path</a:t>
+              </a:r>
+            </a:p>
+          </p:txBody>
+        </p:sp>
+        <p:sp>
+          <p:nvSpPr>
+            <p:cNvPr id="26" name="dp[j] = min { dp[i] + E(i, j, path) }"/>
+            <p:cNvSpPr txBox="1"/>
+            <p:nvPr/>
+          </p:nvSpPr>
+          <p:spPr>
+            <a:xfrm>
+              <a:off x="781050" y="4343400"/>
+              <a:ext cx="4895850" cy="323850"/>
+            </a:xfrm>
+            <a:prstGeom prst="rect">
+              <a:avLst/>
+            </a:prstGeom>
+            <a:noFill/>
+            <a:effectLst/>
+          </p:spPr>
+          <p:txBody>
+            <a:bodyPr wrap="square" lIns="0" rIns="0" tIns="0" bIns="0">
+              <a:spAutoFit/>
+            </a:bodyPr>
+            <a:lstStyle/>
+            <a:p>
+              <a:pPr algn="l">
+                <a:lnSpc>
+                  <a:spcPct val="112000"/>
+                </a:lnSpc>
+                <a:spcAft>
+                  <a:spcPts val="500"/>
+                </a:spcAft>
+              </a:pPr>
+              <a:r>
+                <a:rPr sz="1875" b="1" lang="zh-CN">
+                  <a:solidFill>
+                    <a:srgbClr val="285EA8"/>
+                  </a:solidFill>
+                  <a:latin typeface="Microsoft YaHei"/>
+                  <a:ea typeface="Microsoft YaHei"/>
+                </a:rPr>
+                <a:t>dp[j] = min { dp[i] + E(i, j, path) }</a:t>
+              </a:r>
+            </a:p>
+          </p:txBody>
+        </p:sp>
+        <p:sp>
+          <p:nvSpPr>
+            <p:cNvPr id="27" name="记录前驱与路径；细化时增加已分组数 h， 用 D[h][j] 约束最终组数。"/>
+            <p:cNvSpPr txBox="1"/>
+            <p:nvPr/>
+          </p:nvSpPr>
+          <p:spPr>
+            <a:xfrm>
+              <a:off x="781050" y="4781550"/>
+              <a:ext cx="4895850" cy="409575"/>
             </a:xfrm>
             <a:prstGeom prst="rect">
               <a:avLst/>
@@ -12114,36 +11482,41 @@
                   <a:latin typeface="Microsoft YaHei"/>
                   <a:ea typeface="Microsoft YaHei"/>
                 </a:rPr>
-                <a:t>1/2/3 组的最优 E=5.406/7.406/9.406 → 仍输出 1 组 DIRECT；AGG 重估 32.820 → 81.648。</a:t>
+                <a:t>记录前驱与路径；细化时增加已分组数 h，</a:t>
+              </a:r>
+            </a:p>
+            <a:p>
+              <a:pPr algn="l">
+                <a:lnSpc>
+                  <a:spcPct val="112000"/>
+                </a:lnSpc>
+                <a:spcAft>
+                  <a:spcPts val="500"/>
+                </a:spcAft>
+              </a:pPr>
+              <a:r>
+                <a:rPr sz="1500" b="0" lang="zh-CN">
+                  <a:solidFill>
+                    <a:srgbClr val="1F2937"/>
+                  </a:solidFill>
+                  <a:latin typeface="Microsoft YaHei"/>
+                  <a:ea typeface="Microsoft YaHei"/>
+                </a:rPr>
+                <a:t>用 D[h][j] 约束最终组数。</a:t>
               </a:r>
             </a:p>
           </p:txBody>
         </p:sp>
-      </p:grpSp>
-      <p:grpSp>
-        <p:nvGrpSpPr>
-          <p:cNvPr id="39" name="步骤5：回溯输出与官方实际成本"/>
-          <p:cNvGrpSpPr/>
-          <p:nvPr/>
-        </p:nvGrpSpPr>
-        <p:grpSpPr>
-          <a:xfrm>
-            <a:off x="609600" y="5810250"/>
-            <a:ext cx="10972800" cy="295275"/>
-            <a:chOff x="609600" y="5810250"/>
-            <a:chExt cx="10972800" cy="295275"/>
-          </a:xfrm>
-        </p:grpSpPr>
         <p:sp>
           <p:nvSpPr>
-            <p:cNvPr id="40" name="最终：1 组 DIRECT 读 1536B；实际 T=4μs（向上取整），调用费=2，J=1×4+2=6。"/>
+            <p:cNvPr id="28" name="同卡相邻片段：512B + 512B + 512B"/>
             <p:cNvSpPr txBox="1"/>
             <p:nvPr/>
           </p:nvSpPr>
           <p:spPr>
             <a:xfrm>
-              <a:off x="609600" y="5810250"/>
-              <a:ext cx="10972800" cy="295275"/>
+              <a:off x="6191250" y="3848099"/>
+              <a:ext cx="5391150" cy="276225"/>
             </a:xfrm>
             <a:prstGeom prst="rect">
               <a:avLst/>
@@ -12166,19 +11539,298 @@
                 </a:spcAft>
               </a:pPr>
               <a:r>
-                <a:rPr sz="1800" b="1" lang="zh-CN">
+                <a:rPr sz="1650" b="1" lang="zh-CN">
+                  <a:solidFill>
+                    <a:srgbClr val="1F2937"/>
+                  </a:solidFill>
+                  <a:latin typeface="Microsoft YaHei"/>
+                  <a:ea typeface="Microsoft YaHei"/>
+                </a:rPr>
+                <a:t>同卡相邻片段：512B + 512B + 512B</a:t>
+              </a:r>
+            </a:p>
+          </p:txBody>
+        </p:sp>
+        <p:sp>
+          <p:nvSpPr>
+            <p:cNvPr id="29" name="细化候选组数       1          2          3"/>
+            <p:cNvSpPr txBox="1"/>
+            <p:nvPr/>
+          </p:nvSpPr>
+          <p:spPr>
+            <a:xfrm>
+              <a:off x="6191250" y="4267200"/>
+              <a:ext cx="5391150" cy="238125"/>
+            </a:xfrm>
+            <a:prstGeom prst="rect">
+              <a:avLst/>
+            </a:prstGeom>
+            <a:noFill/>
+            <a:effectLst/>
+          </p:spPr>
+          <p:txBody>
+            <a:bodyPr wrap="square" lIns="0" rIns="0" tIns="0" bIns="0">
+              <a:spAutoFit/>
+            </a:bodyPr>
+            <a:lstStyle/>
+            <a:p>
+              <a:pPr algn="l">
+                <a:lnSpc>
+                  <a:spcPct val="112000"/>
+                </a:lnSpc>
+                <a:spcAft>
+                  <a:spcPts val="500"/>
+                </a:spcAft>
+              </a:pPr>
+              <a:r>
+                <a:rPr sz="1575" b="1" lang="zh-CN">
+                  <a:solidFill>
+                    <a:srgbClr val="24756D"/>
+                  </a:solidFill>
+                  <a:latin typeface="Microsoft YaHei"/>
+                  <a:ea typeface="Microsoft YaHei"/>
+                </a:rPr>
+                <a:t>细化候选组数       1          2          3</a:t>
+              </a:r>
+            </a:p>
+          </p:txBody>
+        </p:sp>
+        <p:sp>
+          <p:nvSpPr>
+            <p:cNvPr id="30" name="最低估价 E       5.406     7.406     9.406"/>
+            <p:cNvSpPr txBox="1"/>
+            <p:nvPr/>
+          </p:nvSpPr>
+          <p:spPr>
+            <a:xfrm>
+              <a:off x="6191250" y="4581525"/>
+              <a:ext cx="5391150" cy="238125"/>
+            </a:xfrm>
+            <a:prstGeom prst="rect">
+              <a:avLst/>
+            </a:prstGeom>
+            <a:noFill/>
+            <a:effectLst/>
+          </p:spPr>
+          <p:txBody>
+            <a:bodyPr wrap="square" lIns="0" rIns="0" tIns="0" bIns="0">
+              <a:spAutoFit/>
+            </a:bodyPr>
+            <a:lstStyle/>
+            <a:p>
+              <a:pPr algn="l">
+                <a:lnSpc>
+                  <a:spcPct val="112000"/>
+                </a:lnSpc>
+                <a:spcAft>
+                  <a:spcPts val="500"/>
+                </a:spcAft>
+              </a:pPr>
+              <a:r>
+                <a:rPr sz="1575" b="0" lang="zh-CN">
+                  <a:solidFill>
+                    <a:srgbClr val="1F2937"/>
+                  </a:solidFill>
+                  <a:latin typeface="Microsoft YaHei"/>
+                  <a:ea typeface="Microsoft YaHei"/>
+                </a:rPr>
+                <a:t>最低估价 E       5.406     7.406     9.406</a:t>
+              </a:r>
+            </a:p>
+          </p:txBody>
+        </p:sp>
+        <p:sp>
+          <p:nvSpPr>
+            <p:cNvPr id="31" name="本例：快速、细化均选 1 组 DIRECT。"/>
+            <p:cNvSpPr txBox="1"/>
+            <p:nvPr/>
+          </p:nvSpPr>
+          <p:spPr>
+            <a:xfrm>
+              <a:off x="6191250" y="4981575"/>
+              <a:ext cx="5391150" cy="247649"/>
+            </a:xfrm>
+            <a:prstGeom prst="rect">
+              <a:avLst/>
+            </a:prstGeom>
+            <a:noFill/>
+            <a:effectLst/>
+          </p:spPr>
+          <p:txBody>
+            <a:bodyPr wrap="square" lIns="0" rIns="0" tIns="0" bIns="0">
+              <a:spAutoFit/>
+            </a:bodyPr>
+            <a:lstStyle/>
+            <a:p>
+              <a:pPr algn="l">
+                <a:lnSpc>
+                  <a:spcPct val="112000"/>
+                </a:lnSpc>
+                <a:spcAft>
+                  <a:spcPts val="500"/>
+                </a:spcAft>
+              </a:pPr>
+              <a:r>
+                <a:rPr sz="1575" b="1" lang="zh-CN">
                   <a:solidFill>
                     <a:srgbClr val="285EA8"/>
                   </a:solidFill>
                   <a:latin typeface="Microsoft YaHei"/>
                   <a:ea typeface="Microsoft YaHei"/>
                 </a:rPr>
-                <a:t>最终：1 组 DIRECT 读 1536B；实际 T=4μs（向上取整），调用费=2，J=1×4+2=6。</a:t>
+                <a:t>本例：快速、细化均选 1 组 DIRECT。</a:t>
               </a:r>
             </a:p>
           </p:txBody>
         </p:sp>
       </p:grpSp>
+      <p:grpSp>
+        <p:nvGrpSpPr>
+          <p:cNvPr id="32" name="步骤5：回溯映射并输出真实计划"/>
+          <p:cNvGrpSpPr/>
+          <p:nvPr/>
+        </p:nvGrpSpPr>
+        <p:grpSpPr>
+          <a:xfrm>
+            <a:off x="609600" y="5505450"/>
+            <a:ext cx="10972800" cy="504825"/>
+            <a:chOff x="609600" y="5505450"/>
+            <a:chExt cx="10972800" cy="504825"/>
+          </a:xfrm>
+        </p:grpSpPr>
+        <p:sp>
+          <p:nvSpPr>
+            <p:cNvPr id="33" name="Rectangle 32"/>
+            <p:cNvSpPr/>
+            <p:nvPr/>
+          </p:nvSpPr>
+          <p:spPr>
+            <a:xfrm>
+              <a:off x="609600" y="5505450"/>
+              <a:ext cx="10972800" cy="504825"/>
+            </a:xfrm>
+            <a:prstGeom prst="rect">
+              <a:avLst/>
+            </a:prstGeom>
+            <a:solidFill>
+              <a:srgbClr val="EDF3FA"/>
+            </a:solidFill>
+            <a:ln>
+              <a:noFill/>
+            </a:ln>
+            <a:effectLst/>
+          </p:spPr>
+          <p:style>
+            <a:lnRef idx="1">
+              <a:schemeClr val="accent1"/>
+            </a:lnRef>
+            <a:fillRef idx="3">
+              <a:schemeClr val="accent1"/>
+            </a:fillRef>
+            <a:effectRef idx="0">
+              <a:schemeClr val="accent1"/>
+            </a:effectRef>
+            <a:fontRef idx="minor">
+              <a:schemeClr val="lt1"/>
+            </a:fontRef>
+          </p:style>
+          <p:txBody>
+            <a:bodyPr rtlCol="0" anchor="ctr"/>
+            <a:lstStyle/>
+            <a:p>
+              <a:pPr algn="ctr"/>
+            </a:p>
+          </p:txBody>
+        </p:sp>
+        <p:sp>
+          <p:nvSpPr>
+            <p:cNvPr id="34" name="最终：1 组 DIRECT 读 1536B；官方 J = 6，分别读取 J = 10，成本降低 40%。"/>
+            <p:cNvSpPr txBox="1"/>
+            <p:nvPr/>
+          </p:nvSpPr>
+          <p:spPr>
+            <a:xfrm>
+              <a:off x="781050" y="5619750"/>
+              <a:ext cx="10629900" cy="295275"/>
+            </a:xfrm>
+            <a:prstGeom prst="rect">
+              <a:avLst/>
+            </a:prstGeom>
+            <a:noFill/>
+            <a:effectLst/>
+          </p:spPr>
+          <p:txBody>
+            <a:bodyPr wrap="square" lIns="0" rIns="0" tIns="0" bIns="0">
+              <a:spAutoFit/>
+            </a:bodyPr>
+            <a:lstStyle/>
+            <a:p>
+              <a:pPr algn="l">
+                <a:lnSpc>
+                  <a:spcPct val="112000"/>
+                </a:lnSpc>
+                <a:spcAft>
+                  <a:spcPts val="500"/>
+                </a:spcAft>
+              </a:pPr>
+              <a:r>
+                <a:rPr sz="1875" b="1" lang="zh-CN">
+                  <a:solidFill>
+                    <a:srgbClr val="285EA8"/>
+                  </a:solidFill>
+                  <a:latin typeface="Microsoft YaHei"/>
+                  <a:ea typeface="Microsoft YaHei"/>
+                </a:rPr>
+                <a:t>最终：1 组 DIRECT 读 1536B；官方 J = 6，分别读取 J = 10，成本降低 40%。</a:t>
+              </a:r>
+            </a:p>
+          </p:txBody>
+        </p:sp>
+      </p:grpSp>
+      <p:sp>
+        <p:nvSpPr>
+          <p:cNvPr id="35" name="E 是候选排序估价；全过程使用公开性能表，策略内部不执行模拟器。"/>
+          <p:cNvSpPr txBox="1"/>
+          <p:nvPr/>
+        </p:nvSpPr>
+        <p:spPr>
+          <a:xfrm>
+            <a:off x="609600" y="6076950"/>
+            <a:ext cx="10972800" cy="171450"/>
+          </a:xfrm>
+          <a:prstGeom prst="rect">
+            <a:avLst/>
+          </a:prstGeom>
+          <a:noFill/>
+          <a:effectLst/>
+        </p:spPr>
+        <p:txBody>
+          <a:bodyPr wrap="square" lIns="0" rIns="0" tIns="0" bIns="0">
+            <a:spAutoFit/>
+          </a:bodyPr>
+          <a:lstStyle/>
+          <a:p>
+            <a:pPr algn="l">
+              <a:lnSpc>
+                <a:spcPct val="112000"/>
+              </a:lnSpc>
+              <a:spcAft>
+                <a:spcPts val="500"/>
+              </a:spcAft>
+            </a:pPr>
+            <a:r>
+              <a:rPr sz="1200" b="0" lang="zh-CN">
+                <a:solidFill>
+                  <a:srgbClr val="657184"/>
+                </a:solidFill>
+                <a:latin typeface="Microsoft YaHei"/>
+                <a:ea typeface="Microsoft YaHei"/>
+              </a:rPr>
+              <a:t>E 是候选排序估价；全过程使用公开性能表，策略内部不执行模拟器。</a:t>
+            </a:r>
+          </a:p>
+        </p:txBody>
+      </p:sp>
     </p:spTree>
   </p:cSld>
   <p:clrMapOvr>
@@ -12271,7 +11923,7 @@
                                           </p:stCondLst>
                                         </p:cTn>
                                         <p:tgtEl>
-                                          <p:spTgt spid="19"/>
+                                          <p:spTgt spid="12"/>
                                         </p:tgtEl>
                                         <p:attrNameLst>
                                           <p:attrName>style.visibility</p:attrName>
@@ -12285,7 +11937,7 @@
                                       <p:cBhvr>
                                         <p:cTn id="12" dur="280"/>
                                         <p:tgtEl>
-                                          <p:spTgt spid="19"/>
+                                          <p:spTgt spid="12"/>
                                         </p:tgtEl>
                                       </p:cBhvr>
                                     </p:animEffect>
@@ -12324,7 +11976,7 @@
                                           </p:stCondLst>
                                         </p:cTn>
                                         <p:tgtEl>
-                                          <p:spTgt spid="31"/>
+                                          <p:spTgt spid="17"/>
                                         </p:tgtEl>
                                         <p:attrNameLst>
                                           <p:attrName>style.visibility</p:attrName>
@@ -12338,7 +11990,7 @@
                                       <p:cBhvr>
                                         <p:cTn id="17" dur="280"/>
                                         <p:tgtEl>
-                                          <p:spTgt spid="31"/>
+                                          <p:spTgt spid="17"/>
                                         </p:tgtEl>
                                       </p:cBhvr>
                                     </p:animEffect>
@@ -12377,7 +12029,7 @@
                                           </p:stCondLst>
                                         </p:cTn>
                                         <p:tgtEl>
-                                          <p:spTgt spid="35"/>
+                                          <p:spTgt spid="23"/>
                                         </p:tgtEl>
                                         <p:attrNameLst>
                                           <p:attrName>style.visibility</p:attrName>
@@ -12391,7 +12043,7 @@
                                       <p:cBhvr>
                                         <p:cTn id="22" dur="280"/>
                                         <p:tgtEl>
-                                          <p:spTgt spid="35"/>
+                                          <p:spTgt spid="23"/>
                                         </p:tgtEl>
                                       </p:cBhvr>
                                     </p:animEffect>
@@ -12430,7 +12082,7 @@
                                           </p:stCondLst>
                                         </p:cTn>
                                         <p:tgtEl>
-                                          <p:spTgt spid="39"/>
+                                          <p:spTgt spid="32"/>
                                         </p:tgtEl>
                                         <p:attrNameLst>
                                           <p:attrName>style.visibility</p:attrName>
@@ -12444,7 +12096,7 @@
                                       <p:cBhvr>
                                         <p:cTn id="27" dur="280"/>
                                         <p:tgtEl>
-                                          <p:spTgt spid="39"/>
+                                          <p:spTgt spid="32"/>
                                         </p:tgtEl>
                                       </p:cBhvr>
                                     </p:animEffect>
@@ -12546,7 +12198,7 @@
       </p:sp>
       <p:sp>
         <p:nvSpPr>
-          <p:cNvPr id="3" name="本次读取完成后，再决定是否为未来复用付费"/>
+          <p:cNvPr id="3" name="用复用证据与成本准入，筛掉不值得的提升"/>
           <p:cNvSpPr txBox="1"/>
           <p:nvPr/>
         </p:nvSpPr>
@@ -12583,14 +12235,14 @@
                 <a:latin typeface="Microsoft YaHei"/>
                 <a:ea typeface="Microsoft YaHei"/>
               </a:rPr>
-              <a:t>本次读取完成后，再决定是否为未来复用付费</a:t>
-            </a:r>
-          </a:p>
-        </p:txBody>
-      </p:sp>
-      <p:sp>
-        <p:nvSpPr>
-          <p:cNvPr id="4" name="依次检查四道条件；任一未通过就返回 nullopt，本次读取已成功完成。"/>
+              <a:t>用复用证据与成本准入，筛掉不值得的提升</a:t>
+            </a:r>
+          </a:p>
+        </p:txBody>
+      </p:sp>
+      <p:sp>
+        <p:nvSpPr>
+          <p:cNvPr id="4" name="读取完成后决定是否缓存；四道条件依次判断，让额外搬运与调用投入有据可依。"/>
           <p:cNvSpPr txBox="1"/>
           <p:nvPr/>
         </p:nvSpPr>
@@ -12627,7 +12279,7 @@
                 <a:latin typeface="Microsoft YaHei"/>
                 <a:ea typeface="Microsoft YaHei"/>
               </a:rPr>
-              <a:t>依次检查四道条件；任一未通过就返回 nullopt，本次读取已成功完成。</a:t>
+              <a:t>读取完成后决定是否缓存；四道条件依次判断，让额外搬运与调用投入有据可依。</a:t>
             </a:r>
           </a:p>
         </p:txBody>
@@ -14000,7 +13652,7 @@
       </p:grpSp>
       <p:sp>
         <p:nvSpPr>
-          <p:cNvPr id="35" name="满池可以替换；提升完成后才能命中。当前不主动延期，低优先级也可能竞争前台资源。"/>
+          <p:cNvPr id="35" name="读取已完成，PROMOTE 只服务未来复用；池满可替换，提升完成后才能命中。"/>
           <p:cNvSpPr txBox="1"/>
           <p:nvPr/>
         </p:nvSpPr>
@@ -14037,7 +13689,7 @@
                 <a:latin typeface="Microsoft YaHei"/>
                 <a:ea typeface="Microsoft YaHei"/>
               </a:rPr>
-              <a:t>满池可以替换；提升完成后才能命中。当前不主动延期，低优先级也可能竞争前台资源。</a:t>
+              <a:t>读取已完成，PROMOTE 只服务未来复用；池满可替换，提升完成后才能命中。</a:t>
             </a:r>
           </a:p>
         </p:txBody>
@@ -15265,7 +14917,7 @@
       </p:sp>
       <p:sp>
         <p:nvSpPr>
-          <p:cNvPr id="23" name="dp / prev / paths：估价、前驱、路径"/>
+          <p:cNvPr id="23" name="dp / prev / paths；细化追加组数维度 h"/>
           <p:cNvSpPr txBox="1"/>
           <p:nvPr/>
         </p:nvSpPr>
@@ -15302,14 +14954,14 @@
                 <a:latin typeface="Microsoft YaHei"/>
                 <a:ea typeface="Microsoft YaHei"/>
               </a:rPr>
-              <a:t>dp / prev / paths：估价、前驱、路径</a:t>
-            </a:r>
-          </a:p>
-        </p:txBody>
-      </p:sp>
-      <p:sp>
-        <p:nvSpPr>
-          <p:cNvPr id="24" name="更优时更新；回溯还原 operation"/>
+              <a:t>dp / prev / paths；细化追加组数维度 h</a:t>
+            </a:r>
+          </a:p>
+        </p:txBody>
+      </p:sp>
+      <p:sp>
+        <p:nvSpPr>
+          <p:cNvPr id="24" name="共用分组与路径候选；回溯生成 operation"/>
           <p:cNvSpPr txBox="1"/>
           <p:nvPr/>
         </p:nvSpPr>
@@ -15346,7 +14998,7 @@
                 <a:latin typeface="Microsoft YaHei"/>
                 <a:ea typeface="Microsoft YaHei"/>
               </a:rPr>
-              <a:t>更优时更新；回溯还原 operation</a:t>
+              <a:t>共用分组与路径候选；回溯生成 operation</a:t>
             </a:r>
           </a:p>
         </p:txBody>
@@ -16051,7 +15703,7 @@
       </p:sp>
       <p:sp>
         <p:nvSpPr>
-          <p:cNvPr id="3" name="用窗口、采样和预算控制搜索，输入输出开销仍随规模增长"/>
+          <p:cNvPr id="3" name="用有限窗口与搜索预算，控制在线调度开销"/>
           <p:cNvSpPr txBox="1"/>
           <p:nvPr/>
         </p:nvSpPr>
@@ -16088,7 +15740,7 @@
                 <a:latin typeface="Microsoft YaHei"/>
                 <a:ea typeface="Microsoft YaHei"/>
               </a:rPr>
-              <a:t>用窗口、采样和预算控制搜索，输入输出开销仍随规模增长</a:t>
+              <a:t>用有限窗口与搜索预算，控制在线调度开销</a:t>
             </a:r>
           </a:p>
         </p:txBody>
@@ -17545,7 +17197,7 @@
       </p:sp>
       <p:sp>
         <p:nvSpPr>
-          <p:cNvPr id="3" name="调度计算多花多少时间，整个程序占用多少资源"/>
+          <p:cNvPr id="3" name="多投入 0.322s 策略计算，进程总耗时下降 14.4%"/>
           <p:cNvSpPr txBox="1"/>
           <p:nvPr/>
         </p:nvSpPr>
@@ -17582,7 +17234,7 @@
                 <a:latin typeface="Microsoft YaHei"/>
                 <a:ea typeface="Microsoft YaHei"/>
               </a:rPr>
-              <a:t>调度计算多花多少时间，整个程序占用多少资源</a:t>
+              <a:t>多投入 0.322s 策略计算，进程总耗时下降 14.4%</a:t>
             </a:r>
           </a:p>
         </p:txBody>
@@ -18957,7 +18609,7 @@
       </p:cxnSp>
       <p:sp>
         <p:nvSpPr>
-          <p:cNvPr id="36" name="联合规划增加了策略计算开销；程序总耗时更短，并不代表调度计算本身更快。"/>
+          <p:cNvPr id="36" name="策略堆峰值 12.34MiB，进程 RSS 下降 33.3%；策略计算增加，整体执行仍更省时。"/>
           <p:cNvSpPr txBox="1"/>
           <p:nvPr/>
         </p:nvSpPr>
@@ -18994,7 +18646,7 @@
                 <a:latin typeface="Microsoft YaHei"/>
                 <a:ea typeface="Microsoft YaHei"/>
               </a:rPr>
-              <a:t>联合规划增加了策略计算开销；程序总耗时更短，并不代表调度计算本身更快。</a:t>
+              <a:t>策略堆峰值 12.34MiB，进程 RSS 下降 33.3%；策略计算增加，整体执行仍更省时。</a:t>
             </a:r>
           </a:p>
         </p:txBody>

</xml_diff>

<commit_message>
docs: separate scheduling observations and map them to design
Signed-off-by: KaisennHu <74917084+KaisennHu@users.noreply.github.com>
</commit_message>
<xml_diff>
--- a/submissions/kaisennhu/07_答辩PPT/答辩介绍.pptx
+++ b/submissions/kaisennhu/07_答辩PPT/答辩介绍.pptx
@@ -792,7 +792,7 @@
           <a:lstStyle/>
           <a:p>
             <a:r>
-              <a:t>合并的两个直接作用是减少重复调用和共享物理读取；对并发、传输大小、资源占用也有影响，故不能只按调用费决定合并。路径替代是同一个候选边的另一个维度，并非另设一个优化模块。官方贪心按逐iov的固定分支选路、同键第二次未命中后尝试HBM提升；本方案改为联合DP和成本准入。池压力权重0.5是启发式，没有最优性保证。</a:t>
+              <a:t>本页先讲事实观察，再讲设计选择。观察1只回答怎样合并：合并可能减少操作固定费，重叠请求还可共享物理读取，但组数和块大小会改变SSD并发、性能桶、缓冲占用，因此不能认为越合并越好。观察2只回答怎样选路：同一组数据在满足对齐、槽位和池容量条件时可能有多条合法路径；DIRECT没有中转复制，AGGREGATE和FALLBACK使用不同临时池、复制类型和调用结构。并非任意组都能走三条路径，低费用也不等于整条Trace更优。前两个观察共同推出一个设计：把分组边界与路径放在同一候选转移中，由联合DP选择，而不是先固定合并再按规则选路；两阶段实现见后续DP页。观察3回答是否值得缓存：PROMOTE先付搬运和调用费，成功入池后才可能被后续同键请求复用；缓存命中仍需KV到目标HBM的复制。复用不足、证据过时或资源竞争可能使投入无法回收，所以后台按复用证据、正的预计净收益、历史预算及容量压力准入；它不是预测必回本的保证。前台节省本次读取成本，后台限制为未来复用支付的额外成本，两者都服务于降低完整Trace的J。组估价E=时间单价×(读工作+复制工作)×池压力系数+调用费；读按物理字节、复制按有效字节，来自公开性能表。DIRECT系数1，中转为1+0.5×对应池已用比例。该启发式只用于估价，不是官方最终J公式。具体阈值与公式留到算法页和设计文档，本页不以公式覆盖观察逻辑。</a:t>
             </a:r>
           </a:p>
         </p:txBody>
@@ -8012,7 +8012,7 @@
       <p:grpSpPr/>
       <p:sp>
         <p:nvSpPr>
-          <p:cNvPr id="2" name="关键观察与设计依据"/>
+          <p:cNvPr id="2" name="设计依据 · 三条观察，两项设计"/>
           <p:cNvSpPr txBox="1"/>
           <p:nvPr/>
         </p:nvSpPr>
@@ -8049,14 +8049,14 @@
                 <a:latin typeface="Microsoft YaHei"/>
                 <a:ea typeface="Microsoft YaHei"/>
               </a:rPr>
-              <a:t>关键观察与设计依据</a:t>
-            </a:r>
-          </a:p>
-        </p:txBody>
-      </p:sp>
-      <p:sp>
-        <p:nvSpPr>
-          <p:cNvPr id="3" name="分组边界与路径互相影响，必须放进同一个 DP"/>
+              <a:t>设计依据 · 三条观察，两项设计</a:t>
+            </a:r>
+          </a:p>
+        </p:txBody>
+      </p:sp>
+      <p:sp>
+        <p:nvSpPr>
+          <p:cNvPr id="3" name="前台联合分组与选路，后台按收益准入"/>
           <p:cNvSpPr txBox="1"/>
           <p:nvPr/>
         </p:nvSpPr>
@@ -8093,14 +8093,14 @@
                 <a:latin typeface="Microsoft YaHei"/>
                 <a:ea typeface="Microsoft YaHei"/>
               </a:rPr>
-              <a:t>分组边界与路径互相影响，必须放进同一个 DP</a:t>
-            </a:r>
-          </a:p>
-        </p:txBody>
-      </p:sp>
-      <p:sp>
-        <p:nvSpPr>
-          <p:cNvPr id="4" name="前台选“哪些片段一起搬、走哪条路”；后台另行判断“是否为后续复用建立缓存”。"/>
+              <a:t>前台联合分组与选路，后台按收益准入</a:t>
+            </a:r>
+          </a:p>
+        </p:txBody>
+      </p:sp>
+      <p:sp>
+        <p:nvSpPr>
+          <p:cNvPr id="4" name="先看三个问题特性：合并的收益与代价、路径的成本差异，以及缓存的回本条件。"/>
           <p:cNvSpPr txBox="1"/>
           <p:nvPr/>
         </p:nvSpPr>
@@ -8137,7 +8137,7 @@
                 <a:latin typeface="Microsoft YaHei"/>
                 <a:ea typeface="Microsoft YaHei"/>
               </a:rPr>
-              <a:t>前台选“哪些片段一起搬、走哪条路”；后台另行判断“是否为后续复用建立缓存”。</a:t>
+              <a:t>先看三个问题特性：合并的收益与代价、路径的成本差异，以及缓存的回本条件。</a:t>
             </a:r>
           </a:p>
         </p:txBody>
@@ -8268,14 +8268,102 @@
       </p:sp>
       <p:sp>
         <p:nvSpPr>
-          <p:cNvPr id="8" name="Rectangle 7"/>
+          <p:cNvPr id="8" name="前台 · 本次读取"/>
+          <p:cNvSpPr txBox="1"/>
+          <p:nvPr/>
+        </p:nvSpPr>
+        <p:spPr>
+          <a:xfrm>
+            <a:off x="609600" y="2009774"/>
+            <a:ext cx="7086600" cy="285750"/>
+          </a:xfrm>
+          <a:prstGeom prst="rect">
+            <a:avLst/>
+          </a:prstGeom>
+          <a:noFill/>
+          <a:effectLst/>
+        </p:spPr>
+        <p:txBody>
+          <a:bodyPr wrap="square" lIns="0" rIns="0" tIns="0" bIns="0">
+            <a:spAutoFit/>
+          </a:bodyPr>
+          <a:lstStyle/>
+          <a:p>
+            <a:pPr algn="l">
+              <a:lnSpc>
+                <a:spcPct val="112000"/>
+              </a:lnSpc>
+              <a:spcAft>
+                <a:spcPts val="500"/>
+              </a:spcAft>
+            </a:pPr>
+            <a:r>
+              <a:rPr sz="1800" b="1" lang="zh-CN">
+                <a:solidFill>
+                  <a:srgbClr val="285EA8"/>
+                </a:solidFill>
+                <a:latin typeface="Microsoft YaHei"/>
+                <a:ea typeface="Microsoft YaHei"/>
+              </a:rPr>
+              <a:t>前台 · 本次读取</a:t>
+            </a:r>
+          </a:p>
+        </p:txBody>
+      </p:sp>
+      <p:sp>
+        <p:nvSpPr>
+          <p:cNvPr id="9" name="后台 · 后续复用"/>
+          <p:cNvSpPr txBox="1"/>
+          <p:nvPr/>
+        </p:nvSpPr>
+        <p:spPr>
+          <a:xfrm>
+            <a:off x="8077200" y="2009774"/>
+            <a:ext cx="3505200" cy="285750"/>
+          </a:xfrm>
+          <a:prstGeom prst="rect">
+            <a:avLst/>
+          </a:prstGeom>
+          <a:noFill/>
+          <a:effectLst/>
+        </p:spPr>
+        <p:txBody>
+          <a:bodyPr wrap="square" lIns="0" rIns="0" tIns="0" bIns="0">
+            <a:spAutoFit/>
+          </a:bodyPr>
+          <a:lstStyle/>
+          <a:p>
+            <a:pPr algn="l">
+              <a:lnSpc>
+                <a:spcPct val="112000"/>
+              </a:lnSpc>
+              <a:spcAft>
+                <a:spcPts val="500"/>
+              </a:spcAft>
+            </a:pPr>
+            <a:r>
+              <a:rPr sz="1800" b="1" lang="zh-CN">
+                <a:solidFill>
+                  <a:srgbClr val="24756D"/>
+                </a:solidFill>
+                <a:latin typeface="Microsoft YaHei"/>
+                <a:ea typeface="Microsoft YaHei"/>
+              </a:rPr>
+              <a:t>后台 · 后续复用</a:t>
+            </a:r>
+          </a:p>
+        </p:txBody>
+      </p:sp>
+      <p:sp>
+        <p:nvSpPr>
+          <p:cNvPr id="10" name="Rectangle 9"/>
           <p:cNvSpPr/>
           <p:nvPr/>
         </p:nvSpPr>
         <p:spPr>
           <a:xfrm>
-            <a:off x="609600" y="2152650"/>
-            <a:ext cx="7086600" cy="2638425"/>
+            <a:off x="609600" y="2409825"/>
+            <a:ext cx="3352800" cy="2495550"/>
           </a:xfrm>
           <a:prstGeom prst="rect">
             <a:avLst/>
@@ -8312,14 +8400,14 @@
       </p:sp>
       <p:sp>
         <p:nvSpPr>
-          <p:cNvPr id="9" name="Rectangle 8"/>
+          <p:cNvPr id="11" name="Rectangle 10"/>
           <p:cNvSpPr/>
           <p:nvPr/>
         </p:nvSpPr>
         <p:spPr>
           <a:xfrm>
-            <a:off x="609600" y="2152650"/>
-            <a:ext cx="38100" cy="2638425"/>
+            <a:off x="609600" y="2409825"/>
+            <a:ext cx="28575" cy="2495550"/>
           </a:xfrm>
           <a:prstGeom prst="rect">
             <a:avLst/>
@@ -8356,14 +8444,14 @@
       </p:sp>
       <p:sp>
         <p:nvSpPr>
-          <p:cNvPr id="10" name="前台观察 → 联合枚举（分组，路径）"/>
+          <p:cNvPr id="12" name="观察 1"/>
           <p:cNvSpPr txBox="1"/>
           <p:nvPr/>
         </p:nvSpPr>
         <p:spPr>
           <a:xfrm>
-            <a:off x="819150" y="2324100"/>
-            <a:ext cx="6667500" cy="342900"/>
+            <a:off x="781050" y="2524125"/>
+            <a:ext cx="3009900" cy="228600"/>
           </a:xfrm>
           <a:prstGeom prst="rect">
             <a:avLst/>
@@ -8386,28 +8474,28 @@
               </a:spcAft>
             </a:pPr>
             <a:r>
-              <a:rPr sz="2100" b="1" lang="zh-CN">
+              <a:rPr sz="1350" b="1" lang="zh-CN">
                 <a:solidFill>
                   <a:srgbClr val="285EA8"/>
                 </a:solidFill>
                 <a:latin typeface="Microsoft YaHei"/>
                 <a:ea typeface="Microsoft YaHei"/>
               </a:rPr>
-              <a:t>前台观察 → 联合枚举（分组，路径）</a:t>
-            </a:r>
-          </a:p>
-        </p:txBody>
-      </p:sp>
-      <p:sp>
-        <p:nvSpPr>
-          <p:cNvPr id="11" name="合并减少操作固定费，也可能减少重叠的物理读取； 但组数变少、块变大，会改变并发、带宽和池占用。"/>
+              <a:t>观察 1</a:t>
+            </a:r>
+          </a:p>
+        </p:txBody>
+      </p:sp>
+      <p:sp>
+        <p:nvSpPr>
+          <p:cNvPr id="13" name="合并有收益，也有代价"/>
           <p:cNvSpPr txBox="1"/>
           <p:nvPr/>
         </p:nvSpPr>
         <p:spPr>
           <a:xfrm>
-            <a:off x="819150" y="2847975"/>
-            <a:ext cx="6667500" cy="685800"/>
+            <a:off x="781050" y="2886075"/>
+            <a:ext cx="3009900" cy="342900"/>
           </a:xfrm>
           <a:prstGeom prst="rect">
             <a:avLst/>
@@ -8430,48 +8518,28 @@
               </a:spcAft>
             </a:pPr>
             <a:r>
-              <a:rPr sz="1800" b="0" lang="zh-CN">
-                <a:solidFill>
-                  <a:srgbClr val="1F2937"/>
-                </a:solidFill>
-                <a:latin typeface="Microsoft YaHei"/>
-                <a:ea typeface="Microsoft YaHei"/>
-              </a:rPr>
-              <a:t>合并减少操作固定费，也可能减少重叠的物理读取；</a:t>
-            </a:r>
-          </a:p>
-          <a:p>
-            <a:pPr algn="l">
-              <a:lnSpc>
-                <a:spcPct val="112000"/>
-              </a:lnSpc>
-              <a:spcAft>
-                <a:spcPts val="500"/>
-              </a:spcAft>
-            </a:pPr>
-            <a:r>
-              <a:rPr sz="1800" b="0" lang="zh-CN">
-                <a:solidFill>
-                  <a:srgbClr val="1F2937"/>
-                </a:solidFill>
-                <a:latin typeface="Microsoft YaHei"/>
-                <a:ea typeface="Microsoft YaHei"/>
-              </a:rPr>
-              <a:t>但组数变少、块变大，会改变并发、带宽和池占用。</a:t>
-            </a:r>
-          </a:p>
-        </p:txBody>
-      </p:sp>
-      <p:sp>
-        <p:nvSpPr>
-          <p:cNvPr id="12" name="同一组可走不同路径，调用费和复制资源随之改变。 因此每个合法分组都比较 DIRECT / AGGREGATE / FALLBACK， 由 DP 一起决定边界和路径。"/>
+              <a:rPr sz="1875" b="1" lang="zh-CN">
+                <a:solidFill>
+                  <a:srgbClr val="285EA8"/>
+                </a:solidFill>
+                <a:latin typeface="Microsoft YaHei"/>
+                <a:ea typeface="Microsoft YaHei"/>
+              </a:rPr>
+              <a:t>合并有收益，也有代价</a:t>
+            </a:r>
+          </a:p>
+        </p:txBody>
+      </p:sp>
+      <p:sp>
+        <p:nvSpPr>
+          <p:cNvPr id="14" name="合并可少付固定费， 重叠请求可共享物理读取； 组数与块大小改变， 并发和缓冲占用也会改变。"/>
           <p:cNvSpPr txBox="1"/>
           <p:nvPr/>
         </p:nvSpPr>
         <p:spPr>
           <a:xfrm>
-            <a:off x="819150" y="3695700"/>
-            <a:ext cx="6667500" cy="790575"/>
+            <a:off x="781050" y="3419475"/>
+            <a:ext cx="3009900" cy="1343025"/>
           </a:xfrm>
           <a:prstGeom prst="rect">
             <a:avLst/>
@@ -8494,14 +8562,14 @@
               </a:spcAft>
             </a:pPr>
             <a:r>
-              <a:rPr sz="1725" b="0" lang="zh-CN">
+              <a:rPr sz="1650" b="0" lang="zh-CN">
                 <a:solidFill>
                   <a:srgbClr val="1F2937"/>
                 </a:solidFill>
                 <a:latin typeface="Microsoft YaHei"/>
                 <a:ea typeface="Microsoft YaHei"/>
               </a:rPr>
-              <a:t>同一组可走不同路径，调用费和复制资源随之改变。</a:t>
+              <a:t>合并可少付固定费，</a:t>
             </a:r>
           </a:p>
           <a:p>
@@ -8514,14 +8582,14 @@
               </a:spcAft>
             </a:pPr>
             <a:r>
-              <a:rPr sz="1725" b="0" lang="zh-CN">
+              <a:rPr sz="1650" b="0" lang="zh-CN">
                 <a:solidFill>
                   <a:srgbClr val="1F2937"/>
                 </a:solidFill>
                 <a:latin typeface="Microsoft YaHei"/>
                 <a:ea typeface="Microsoft YaHei"/>
               </a:rPr>
-              <a:t>因此每个合法分组都比较 DIRECT / AGGREGATE / FALLBACK，</a:t>
+              <a:t>重叠请求可共享物理读取；</a:t>
             </a:r>
           </a:p>
           <a:p>
@@ -8534,28 +8602,328 @@
               </a:spcAft>
             </a:pPr>
             <a:r>
-              <a:rPr sz="1725" b="0" lang="zh-CN">
+              <a:rPr sz="1650" b="0" lang="zh-CN">
                 <a:solidFill>
                   <a:srgbClr val="1F2937"/>
                 </a:solidFill>
                 <a:latin typeface="Microsoft YaHei"/>
                 <a:ea typeface="Microsoft YaHei"/>
               </a:rPr>
-              <a:t>由 DP 一起决定边界和路径。</a:t>
-            </a:r>
-          </a:p>
-        </p:txBody>
-      </p:sp>
-      <p:sp>
-        <p:nvSpPr>
-          <p:cNvPr id="13" name="Rectangle 12"/>
+              <a:t>组数与块大小改变，</a:t>
+            </a:r>
+          </a:p>
+          <a:p>
+            <a:pPr algn="l">
+              <a:lnSpc>
+                <a:spcPct val="112000"/>
+              </a:lnSpc>
+              <a:spcAft>
+                <a:spcPts val="500"/>
+              </a:spcAft>
+            </a:pPr>
+            <a:r>
+              <a:rPr sz="1650" b="0" lang="zh-CN">
+                <a:solidFill>
+                  <a:srgbClr val="1F2937"/>
+                </a:solidFill>
+                <a:latin typeface="Microsoft YaHei"/>
+                <a:ea typeface="Microsoft YaHei"/>
+              </a:rPr>
+              <a:t>并发和缓冲占用也会改变。</a:t>
+            </a:r>
+          </a:p>
+        </p:txBody>
+      </p:sp>
+      <p:sp>
+        <p:nvSpPr>
+          <p:cNvPr id="15" name="Rectangle 14"/>
           <p:cNvSpPr/>
           <p:nvPr/>
         </p:nvSpPr>
         <p:spPr>
           <a:xfrm>
-            <a:off x="7924799" y="2152650"/>
-            <a:ext cx="3657600" cy="2638425"/>
+            <a:off x="4343400" y="2409825"/>
+            <a:ext cx="3352800" cy="2495550"/>
+          </a:xfrm>
+          <a:prstGeom prst="rect">
+            <a:avLst/>
+          </a:prstGeom>
+          <a:solidFill>
+            <a:srgbClr val="F5F7FA"/>
+          </a:solidFill>
+          <a:ln>
+            <a:noFill/>
+          </a:ln>
+          <a:effectLst/>
+        </p:spPr>
+        <p:style>
+          <a:lnRef idx="1">
+            <a:schemeClr val="accent1"/>
+          </a:lnRef>
+          <a:fillRef idx="3">
+            <a:schemeClr val="accent1"/>
+          </a:fillRef>
+          <a:effectRef idx="0">
+            <a:schemeClr val="accent1"/>
+          </a:effectRef>
+          <a:fontRef idx="minor">
+            <a:schemeClr val="lt1"/>
+          </a:fontRef>
+        </p:style>
+        <p:txBody>
+          <a:bodyPr rtlCol="0" anchor="ctr"/>
+          <a:lstStyle/>
+          <a:p>
+            <a:pPr algn="ctr"/>
+          </a:p>
+        </p:txBody>
+      </p:sp>
+      <p:sp>
+        <p:nvSpPr>
+          <p:cNvPr id="16" name="Rectangle 15"/>
+          <p:cNvSpPr/>
+          <p:nvPr/>
+        </p:nvSpPr>
+        <p:spPr>
+          <a:xfrm>
+            <a:off x="4343400" y="2409825"/>
+            <a:ext cx="28575" cy="2495550"/>
+          </a:xfrm>
+          <a:prstGeom prst="rect">
+            <a:avLst/>
+          </a:prstGeom>
+          <a:solidFill>
+            <a:srgbClr val="285EA8"/>
+          </a:solidFill>
+          <a:ln>
+            <a:noFill/>
+          </a:ln>
+          <a:effectLst/>
+        </p:spPr>
+        <p:style>
+          <a:lnRef idx="1">
+            <a:schemeClr val="accent1"/>
+          </a:lnRef>
+          <a:fillRef idx="3">
+            <a:schemeClr val="accent1"/>
+          </a:fillRef>
+          <a:effectRef idx="0">
+            <a:schemeClr val="accent1"/>
+          </a:effectRef>
+          <a:fontRef idx="minor">
+            <a:schemeClr val="lt1"/>
+          </a:fontRef>
+        </p:style>
+        <p:txBody>
+          <a:bodyPr rtlCol="0" anchor="ctr"/>
+          <a:lstStyle/>
+          <a:p>
+            <a:pPr algn="ctr"/>
+          </a:p>
+        </p:txBody>
+      </p:sp>
+      <p:sp>
+        <p:nvSpPr>
+          <p:cNvPr id="17" name="观察 2"/>
+          <p:cNvSpPr txBox="1"/>
+          <p:nvPr/>
+        </p:nvSpPr>
+        <p:spPr>
+          <a:xfrm>
+            <a:off x="4514850" y="2524125"/>
+            <a:ext cx="3009900" cy="228600"/>
+          </a:xfrm>
+          <a:prstGeom prst="rect">
+            <a:avLst/>
+          </a:prstGeom>
+          <a:noFill/>
+          <a:effectLst/>
+        </p:spPr>
+        <p:txBody>
+          <a:bodyPr wrap="square" lIns="0" rIns="0" tIns="0" bIns="0">
+            <a:spAutoFit/>
+          </a:bodyPr>
+          <a:lstStyle/>
+          <a:p>
+            <a:pPr algn="l">
+              <a:lnSpc>
+                <a:spcPct val="112000"/>
+              </a:lnSpc>
+              <a:spcAft>
+                <a:spcPts val="500"/>
+              </a:spcAft>
+            </a:pPr>
+            <a:r>
+              <a:rPr sz="1350" b="1" lang="zh-CN">
+                <a:solidFill>
+                  <a:srgbClr val="285EA8"/>
+                </a:solidFill>
+                <a:latin typeface="Microsoft YaHei"/>
+                <a:ea typeface="Microsoft YaHei"/>
+              </a:rPr>
+              <a:t>观察 2</a:t>
+            </a:r>
+          </a:p>
+        </p:txBody>
+      </p:sp>
+      <p:sp>
+        <p:nvSpPr>
+          <p:cNvPr id="18" name="路径可替代，成本不同"/>
+          <p:cNvSpPr txBox="1"/>
+          <p:nvPr/>
+        </p:nvSpPr>
+        <p:spPr>
+          <a:xfrm>
+            <a:off x="4514850" y="2886075"/>
+            <a:ext cx="3009900" cy="342900"/>
+          </a:xfrm>
+          <a:prstGeom prst="rect">
+            <a:avLst/>
+          </a:prstGeom>
+          <a:noFill/>
+          <a:effectLst/>
+        </p:spPr>
+        <p:txBody>
+          <a:bodyPr wrap="square" lIns="0" rIns="0" tIns="0" bIns="0">
+            <a:spAutoFit/>
+          </a:bodyPr>
+          <a:lstStyle/>
+          <a:p>
+            <a:pPr algn="l">
+              <a:lnSpc>
+                <a:spcPct val="112000"/>
+              </a:lnSpc>
+              <a:spcAft>
+                <a:spcPts val="500"/>
+              </a:spcAft>
+            </a:pPr>
+            <a:r>
+              <a:rPr sz="1875" b="1" lang="zh-CN">
+                <a:solidFill>
+                  <a:srgbClr val="285EA8"/>
+                </a:solidFill>
+                <a:latin typeface="Microsoft YaHei"/>
+                <a:ea typeface="Microsoft YaHei"/>
+              </a:rPr>
+              <a:t>路径可替代，成本不同</a:t>
+            </a:r>
+          </a:p>
+        </p:txBody>
+      </p:sp>
+      <p:sp>
+        <p:nvSpPr>
+          <p:cNvPr id="19" name="同组数据可有多条合法路径； 调用费、复制和池需求不同。 分组与资源改变时， 低成本路径也可能改变。"/>
+          <p:cNvSpPr txBox="1"/>
+          <p:nvPr/>
+        </p:nvSpPr>
+        <p:spPr>
+          <a:xfrm>
+            <a:off x="4514850" y="3419475"/>
+            <a:ext cx="3009900" cy="1343025"/>
+          </a:xfrm>
+          <a:prstGeom prst="rect">
+            <a:avLst/>
+          </a:prstGeom>
+          <a:noFill/>
+          <a:effectLst/>
+        </p:spPr>
+        <p:txBody>
+          <a:bodyPr wrap="square" lIns="0" rIns="0" tIns="0" bIns="0">
+            <a:spAutoFit/>
+          </a:bodyPr>
+          <a:lstStyle/>
+          <a:p>
+            <a:pPr algn="l">
+              <a:lnSpc>
+                <a:spcPct val="112000"/>
+              </a:lnSpc>
+              <a:spcAft>
+                <a:spcPts val="500"/>
+              </a:spcAft>
+            </a:pPr>
+            <a:r>
+              <a:rPr sz="1650" b="0" lang="zh-CN">
+                <a:solidFill>
+                  <a:srgbClr val="1F2937"/>
+                </a:solidFill>
+                <a:latin typeface="Microsoft YaHei"/>
+                <a:ea typeface="Microsoft YaHei"/>
+              </a:rPr>
+              <a:t>同组数据可有多条合法路径；</a:t>
+            </a:r>
+          </a:p>
+          <a:p>
+            <a:pPr algn="l">
+              <a:lnSpc>
+                <a:spcPct val="112000"/>
+              </a:lnSpc>
+              <a:spcAft>
+                <a:spcPts val="500"/>
+              </a:spcAft>
+            </a:pPr>
+            <a:r>
+              <a:rPr sz="1650" b="0" lang="zh-CN">
+                <a:solidFill>
+                  <a:srgbClr val="1F2937"/>
+                </a:solidFill>
+                <a:latin typeface="Microsoft YaHei"/>
+                <a:ea typeface="Microsoft YaHei"/>
+              </a:rPr>
+              <a:t>调用费、复制和池需求不同。</a:t>
+            </a:r>
+          </a:p>
+          <a:p>
+            <a:pPr algn="l">
+              <a:lnSpc>
+                <a:spcPct val="112000"/>
+              </a:lnSpc>
+              <a:spcAft>
+                <a:spcPts val="500"/>
+              </a:spcAft>
+            </a:pPr>
+            <a:r>
+              <a:rPr sz="1650" b="0" lang="zh-CN">
+                <a:solidFill>
+                  <a:srgbClr val="1F2937"/>
+                </a:solidFill>
+                <a:latin typeface="Microsoft YaHei"/>
+                <a:ea typeface="Microsoft YaHei"/>
+              </a:rPr>
+              <a:t>分组与资源改变时，</a:t>
+            </a:r>
+          </a:p>
+          <a:p>
+            <a:pPr algn="l">
+              <a:lnSpc>
+                <a:spcPct val="112000"/>
+              </a:lnSpc>
+              <a:spcAft>
+                <a:spcPts val="500"/>
+              </a:spcAft>
+            </a:pPr>
+            <a:r>
+              <a:rPr sz="1650" b="0" lang="zh-CN">
+                <a:solidFill>
+                  <a:srgbClr val="1F2937"/>
+                </a:solidFill>
+                <a:latin typeface="Microsoft YaHei"/>
+                <a:ea typeface="Microsoft YaHei"/>
+              </a:rPr>
+              <a:t>低成本路径也可能改变。</a:t>
+            </a:r>
+          </a:p>
+        </p:txBody>
+      </p:sp>
+      <p:sp>
+        <p:nvSpPr>
+          <p:cNvPr id="20" name="Rectangle 19"/>
+          <p:cNvSpPr/>
+          <p:nvPr/>
+        </p:nvSpPr>
+        <p:spPr>
+          <a:xfrm>
+            <a:off x="8077200" y="2409825"/>
+            <a:ext cx="3505200" cy="2495550"/>
           </a:xfrm>
           <a:prstGeom prst="rect">
             <a:avLst/>
@@ -8592,14 +8960,14 @@
       </p:sp>
       <p:sp>
         <p:nvSpPr>
-          <p:cNvPr id="14" name="Rectangle 13"/>
+          <p:cNvPr id="21" name="Rectangle 20"/>
           <p:cNvSpPr/>
           <p:nvPr/>
         </p:nvSpPr>
         <p:spPr>
           <a:xfrm>
-            <a:off x="7924799" y="2152650"/>
-            <a:ext cx="38100" cy="2638425"/>
+            <a:off x="8077200" y="2409825"/>
+            <a:ext cx="28575" cy="2495550"/>
           </a:xfrm>
           <a:prstGeom prst="rect">
             <a:avLst/>
@@ -8636,14 +9004,14 @@
       </p:sp>
       <p:sp>
         <p:nvSpPr>
-          <p:cNvPr id="15" name="后台观察 → 有条件地缓存"/>
+          <p:cNvPr id="22" name="观察 3"/>
           <p:cNvSpPr txBox="1"/>
           <p:nvPr/>
         </p:nvSpPr>
         <p:spPr>
           <a:xfrm>
-            <a:off x="8134350" y="2324100"/>
-            <a:ext cx="3238500" cy="342900"/>
+            <a:off x="8248650" y="2524125"/>
+            <a:ext cx="3162300" cy="228600"/>
           </a:xfrm>
           <a:prstGeom prst="rect">
             <a:avLst/>
@@ -8666,28 +9034,28 @@
               </a:spcAft>
             </a:pPr>
             <a:r>
-              <a:rPr sz="2025" b="1" lang="zh-CN">
+              <a:rPr sz="1350" b="1" lang="zh-CN">
                 <a:solidFill>
                   <a:srgbClr val="24756D"/>
                 </a:solidFill>
                 <a:latin typeface="Microsoft YaHei"/>
                 <a:ea typeface="Microsoft YaHei"/>
               </a:rPr>
-              <a:t>后台观察 → 有条件地缓存</a:t>
-            </a:r>
-          </a:p>
-        </p:txBody>
-      </p:sp>
-      <p:sp>
-        <p:nvSpPr>
-          <p:cNvPr id="16" name="PROMOTE 先付搬运和调用费， 未来命中仍需 KV → HBM。  只有复用证据有效、预计净收益 为正且历史预算够，才投入。"/>
+              <a:t>观察 3</a:t>
+            </a:r>
+          </a:p>
+        </p:txBody>
+      </p:sp>
+      <p:sp>
+        <p:nvSpPr>
+          <p:cNvPr id="23" name="缓存先投入，后回报"/>
           <p:cNvSpPr txBox="1"/>
           <p:nvPr/>
         </p:nvSpPr>
         <p:spPr>
           <a:xfrm>
-            <a:off x="8134350" y="2857500"/>
-            <a:ext cx="3238500" cy="1581150"/>
+            <a:off x="8248650" y="2886075"/>
+            <a:ext cx="3162300" cy="342900"/>
           </a:xfrm>
           <a:prstGeom prst="rect">
             <a:avLst/>
@@ -8710,108 +9078,28 @@
               </a:spcAft>
             </a:pPr>
             <a:r>
-              <a:rPr sz="1725" b="0" lang="zh-CN">
-                <a:solidFill>
-                  <a:srgbClr val="1F2937"/>
-                </a:solidFill>
-                <a:latin typeface="Microsoft YaHei"/>
-                <a:ea typeface="Microsoft YaHei"/>
-              </a:rPr>
-              <a:t>PROMOTE 先付搬运和调用费，</a:t>
-            </a:r>
-          </a:p>
-          <a:p>
-            <a:pPr algn="l">
-              <a:lnSpc>
-                <a:spcPct val="112000"/>
-              </a:lnSpc>
-              <a:spcAft>
-                <a:spcPts val="500"/>
-              </a:spcAft>
-            </a:pPr>
-            <a:r>
-              <a:rPr sz="1725" b="0" lang="zh-CN">
-                <a:solidFill>
-                  <a:srgbClr val="1F2937"/>
-                </a:solidFill>
-                <a:latin typeface="Microsoft YaHei"/>
-                <a:ea typeface="Microsoft YaHei"/>
-              </a:rPr>
-              <a:t>未来命中仍需 KV → HBM。</a:t>
-            </a:r>
-          </a:p>
-          <a:p>
-            <a:pPr algn="l">
-              <a:lnSpc>
-                <a:spcPct val="112000"/>
-              </a:lnSpc>
-              <a:spcAft>
-                <a:spcPts val="500"/>
-              </a:spcAft>
-            </a:pPr>
-            <a:r>
-              <a:rPr sz="1725" b="0" lang="zh-CN">
-                <a:solidFill>
-                  <a:srgbClr val="1F2937"/>
-                </a:solidFill>
-                <a:latin typeface="Microsoft YaHei"/>
-                <a:ea typeface="Microsoft YaHei"/>
-              </a:rPr>
-              <a:t/>
-            </a:r>
-          </a:p>
-          <a:p>
-            <a:pPr algn="l">
-              <a:lnSpc>
-                <a:spcPct val="112000"/>
-              </a:lnSpc>
-              <a:spcAft>
-                <a:spcPts val="500"/>
-              </a:spcAft>
-            </a:pPr>
-            <a:r>
-              <a:rPr sz="1725" b="0" lang="zh-CN">
-                <a:solidFill>
-                  <a:srgbClr val="1F2937"/>
-                </a:solidFill>
-                <a:latin typeface="Microsoft YaHei"/>
-                <a:ea typeface="Microsoft YaHei"/>
-              </a:rPr>
-              <a:t>只有复用证据有效、预计净收益</a:t>
-            </a:r>
-          </a:p>
-          <a:p>
-            <a:pPr algn="l">
-              <a:lnSpc>
-                <a:spcPct val="112000"/>
-              </a:lnSpc>
-              <a:spcAft>
-                <a:spcPts val="500"/>
-              </a:spcAft>
-            </a:pPr>
-            <a:r>
-              <a:rPr sz="1725" b="0" lang="zh-CN">
-                <a:solidFill>
-                  <a:srgbClr val="1F2937"/>
-                </a:solidFill>
-                <a:latin typeface="Microsoft YaHei"/>
-                <a:ea typeface="Microsoft YaHei"/>
-              </a:rPr>
-              <a:t>为正且历史预算够，才投入。</a:t>
-            </a:r>
-          </a:p>
-        </p:txBody>
-      </p:sp>
-      <p:sp>
-        <p:nvSpPr>
-          <p:cNvPr id="17" name="一组的估价 E = 时间单价 ×（读工作 + 复制工作）× 池压力系数 + 调用费"/>
+              <a:rPr sz="1875" b="1" lang="zh-CN">
+                <a:solidFill>
+                  <a:srgbClr val="24756D"/>
+                </a:solidFill>
+                <a:latin typeface="Microsoft YaHei"/>
+                <a:ea typeface="Microsoft YaHei"/>
+              </a:rPr>
+              <a:t>缓存先投入，后回报</a:t>
+            </a:r>
+          </a:p>
+        </p:txBody>
+      </p:sp>
+      <p:sp>
+        <p:nvSpPr>
+          <p:cNvPr id="24" name="提升先付搬运与调用费； 命中仍要复制到目标 HBM。 复用不够或证据过时， 就可能收不回这次投入。"/>
           <p:cNvSpPr txBox="1"/>
           <p:nvPr/>
         </p:nvSpPr>
         <p:spPr>
           <a:xfrm>
-            <a:off x="609600" y="5010150"/>
-            <a:ext cx="10972800" cy="314325"/>
+            <a:off x="8248650" y="3419475"/>
+            <a:ext cx="3162300" cy="1343025"/>
           </a:xfrm>
           <a:prstGeom prst="rect">
             <a:avLst/>
@@ -8834,28 +9122,314 @@
               </a:spcAft>
             </a:pPr>
             <a:r>
-              <a:rPr sz="1875" b="1" lang="zh-CN">
-                <a:solidFill>
-                  <a:srgbClr val="285EA8"/>
-                </a:solidFill>
-                <a:latin typeface="Microsoft YaHei"/>
-                <a:ea typeface="Microsoft YaHei"/>
-              </a:rPr>
-              <a:t>一组的估价 E = 时间单价 ×（读工作 + 复制工作）× 池压力系数 + 调用费</a:t>
-            </a:r>
-          </a:p>
-        </p:txBody>
-      </p:sp>
-      <p:sp>
-        <p:nvSpPr>
-          <p:cNvPr id="18" name="读按物理字节、复制按有效字节；工作量由公开性能表估计。DIRECT 系数为 1， 中转为 1 + 0.5 × 对应池已用比例；这是局部估价，不是官方最终 J。"/>
+              <a:rPr sz="1650" b="0" lang="zh-CN">
+                <a:solidFill>
+                  <a:srgbClr val="1F2937"/>
+                </a:solidFill>
+                <a:latin typeface="Microsoft YaHei"/>
+                <a:ea typeface="Microsoft YaHei"/>
+              </a:rPr>
+              <a:t>提升先付搬运与调用费；</a:t>
+            </a:r>
+          </a:p>
+          <a:p>
+            <a:pPr algn="l">
+              <a:lnSpc>
+                <a:spcPct val="112000"/>
+              </a:lnSpc>
+              <a:spcAft>
+                <a:spcPts val="500"/>
+              </a:spcAft>
+            </a:pPr>
+            <a:r>
+              <a:rPr sz="1650" b="0" lang="zh-CN">
+                <a:solidFill>
+                  <a:srgbClr val="1F2937"/>
+                </a:solidFill>
+                <a:latin typeface="Microsoft YaHei"/>
+                <a:ea typeface="Microsoft YaHei"/>
+              </a:rPr>
+              <a:t>命中仍要复制到目标 HBM。</a:t>
+            </a:r>
+          </a:p>
+          <a:p>
+            <a:pPr algn="l">
+              <a:lnSpc>
+                <a:spcPct val="112000"/>
+              </a:lnSpc>
+              <a:spcAft>
+                <a:spcPts val="500"/>
+              </a:spcAft>
+            </a:pPr>
+            <a:r>
+              <a:rPr sz="1650" b="0" lang="zh-CN">
+                <a:solidFill>
+                  <a:srgbClr val="1F2937"/>
+                </a:solidFill>
+                <a:latin typeface="Microsoft YaHei"/>
+                <a:ea typeface="Microsoft YaHei"/>
+              </a:rPr>
+              <a:t>复用不够或证据过时，</a:t>
+            </a:r>
+          </a:p>
+          <a:p>
+            <a:pPr algn="l">
+              <a:lnSpc>
+                <a:spcPct val="112000"/>
+              </a:lnSpc>
+              <a:spcAft>
+                <a:spcPts val="500"/>
+              </a:spcAft>
+            </a:pPr>
+            <a:r>
+              <a:rPr sz="1650" b="0" lang="zh-CN">
+                <a:solidFill>
+                  <a:srgbClr val="1F2937"/>
+                </a:solidFill>
+                <a:latin typeface="Microsoft YaHei"/>
+                <a:ea typeface="Microsoft YaHei"/>
+              </a:rPr>
+              <a:t>就可能收不回这次投入。</a:t>
+            </a:r>
+          </a:p>
+        </p:txBody>
+      </p:sp>
+      <p:cxnSp>
+        <p:nvCxnSpPr>
+          <p:cNvPr id="25" name="Connector 24"/>
+          <p:cNvCxnSpPr/>
+          <p:nvPr/>
+        </p:nvCxnSpPr>
+        <p:spPr>
+          <a:xfrm>
+            <a:off x="2286000" y="4905375"/>
+            <a:ext cx="0" cy="180975"/>
+          </a:xfrm>
+          <a:prstGeom prst="line">
+            <a:avLst/>
+          </a:prstGeom>
+          <a:ln w="17780">
+            <a:solidFill>
+              <a:srgbClr val="285EA8"/>
+            </a:solidFill>
+          </a:ln>
+          <a:effectLst/>
+        </p:spPr>
+        <p:style>
+          <a:lnRef idx="2">
+            <a:schemeClr val="accent1"/>
+          </a:lnRef>
+          <a:fillRef idx="0">
+            <a:schemeClr val="accent1"/>
+          </a:fillRef>
+          <a:effectRef idx="0">
+            <a:schemeClr val="accent1"/>
+          </a:effectRef>
+          <a:fontRef idx="minor">
+            <a:schemeClr val="tx1"/>
+          </a:fontRef>
+        </p:style>
+      </p:cxnSp>
+      <p:cxnSp>
+        <p:nvCxnSpPr>
+          <p:cNvPr id="26" name="Connector 25"/>
+          <p:cNvCxnSpPr/>
+          <p:nvPr/>
+        </p:nvCxnSpPr>
+        <p:spPr>
+          <a:xfrm>
+            <a:off x="6019800" y="4905375"/>
+            <a:ext cx="0" cy="180975"/>
+          </a:xfrm>
+          <a:prstGeom prst="line">
+            <a:avLst/>
+          </a:prstGeom>
+          <a:ln w="17780">
+            <a:solidFill>
+              <a:srgbClr val="285EA8"/>
+            </a:solidFill>
+          </a:ln>
+          <a:effectLst/>
+        </p:spPr>
+        <p:style>
+          <a:lnRef idx="2">
+            <a:schemeClr val="accent1"/>
+          </a:lnRef>
+          <a:fillRef idx="0">
+            <a:schemeClr val="accent1"/>
+          </a:fillRef>
+          <a:effectRef idx="0">
+            <a:schemeClr val="accent1"/>
+          </a:effectRef>
+          <a:fontRef idx="minor">
+            <a:schemeClr val="tx1"/>
+          </a:fontRef>
+        </p:style>
+      </p:cxnSp>
+      <p:cxnSp>
+        <p:nvCxnSpPr>
+          <p:cNvPr id="27" name="Connector 26"/>
+          <p:cNvCxnSpPr/>
+          <p:nvPr/>
+        </p:nvCxnSpPr>
+        <p:spPr>
+          <a:xfrm>
+            <a:off x="2286000" y="5086350"/>
+            <a:ext cx="3733800" cy="0"/>
+          </a:xfrm>
+          <a:prstGeom prst="line">
+            <a:avLst/>
+          </a:prstGeom>
+          <a:ln w="17780">
+            <a:solidFill>
+              <a:srgbClr val="285EA8"/>
+            </a:solidFill>
+          </a:ln>
+          <a:effectLst/>
+        </p:spPr>
+        <p:style>
+          <a:lnRef idx="2">
+            <a:schemeClr val="accent1"/>
+          </a:lnRef>
+          <a:fillRef idx="0">
+            <a:schemeClr val="accent1"/>
+          </a:fillRef>
+          <a:effectRef idx="0">
+            <a:schemeClr val="accent1"/>
+          </a:effectRef>
+          <a:fontRef idx="minor">
+            <a:schemeClr val="tx1"/>
+          </a:fontRef>
+        </p:style>
+      </p:cxnSp>
+      <p:cxnSp>
+        <p:nvCxnSpPr>
+          <p:cNvPr id="28" name="Connector 27"/>
+          <p:cNvCxnSpPr/>
+          <p:nvPr/>
+        </p:nvCxnSpPr>
+        <p:spPr>
+          <a:xfrm>
+            <a:off x="4152900" y="5086350"/>
+            <a:ext cx="0" cy="171450"/>
+          </a:xfrm>
+          <a:prstGeom prst="line">
+            <a:avLst/>
+          </a:prstGeom>
+          <a:ln w="17780">
+            <a:solidFill>
+              <a:srgbClr val="285EA8"/>
+            </a:solidFill>
+            <a:tailEnd type="triangle"/>
+          </a:ln>
+          <a:effectLst/>
+        </p:spPr>
+        <p:style>
+          <a:lnRef idx="2">
+            <a:schemeClr val="accent1"/>
+          </a:lnRef>
+          <a:fillRef idx="0">
+            <a:schemeClr val="accent1"/>
+          </a:fillRef>
+          <a:effectRef idx="0">
+            <a:schemeClr val="accent1"/>
+          </a:effectRef>
+          <a:fontRef idx="minor">
+            <a:schemeClr val="tx1"/>
+          </a:fontRef>
+        </p:style>
+      </p:cxnSp>
+      <p:cxnSp>
+        <p:nvCxnSpPr>
+          <p:cNvPr id="29" name="Connector 28"/>
+          <p:cNvCxnSpPr/>
+          <p:nvPr/>
+        </p:nvCxnSpPr>
+        <p:spPr>
+          <a:xfrm>
+            <a:off x="9829800" y="4905375"/>
+            <a:ext cx="0" cy="352425"/>
+          </a:xfrm>
+          <a:prstGeom prst="line">
+            <a:avLst/>
+          </a:prstGeom>
+          <a:ln w="17780">
+            <a:solidFill>
+              <a:srgbClr val="24756D"/>
+            </a:solidFill>
+            <a:tailEnd type="triangle"/>
+          </a:ln>
+          <a:effectLst/>
+        </p:spPr>
+        <p:style>
+          <a:lnRef idx="2">
+            <a:schemeClr val="accent1"/>
+          </a:lnRef>
+          <a:fillRef idx="0">
+            <a:schemeClr val="accent1"/>
+          </a:fillRef>
+          <a:effectRef idx="0">
+            <a:schemeClr val="accent1"/>
+          </a:effectRef>
+          <a:fontRef idx="minor">
+            <a:schemeClr val="tx1"/>
+          </a:fontRef>
+        </p:style>
+      </p:cxnSp>
+      <p:sp>
+        <p:nvSpPr>
+          <p:cNvPr id="30" name="Rectangle 29"/>
+          <p:cNvSpPr/>
+          <p:nvPr/>
+        </p:nvSpPr>
+        <p:spPr>
+          <a:xfrm>
+            <a:off x="609600" y="5286375"/>
+            <a:ext cx="7086600" cy="733425"/>
+          </a:xfrm>
+          <a:prstGeom prst="rect">
+            <a:avLst/>
+          </a:prstGeom>
+          <a:solidFill>
+            <a:srgbClr val="EDF3FA"/>
+          </a:solidFill>
+          <a:ln>
+            <a:noFill/>
+          </a:ln>
+          <a:effectLst/>
+        </p:spPr>
+        <p:style>
+          <a:lnRef idx="1">
+            <a:schemeClr val="accent1"/>
+          </a:lnRef>
+          <a:fillRef idx="3">
+            <a:schemeClr val="accent1"/>
+          </a:fillRef>
+          <a:effectRef idx="0">
+            <a:schemeClr val="accent1"/>
+          </a:effectRef>
+          <a:fontRef idx="minor">
+            <a:schemeClr val="lt1"/>
+          </a:fontRef>
+        </p:style>
+        <p:txBody>
+          <a:bodyPr rtlCol="0" anchor="ctr"/>
+          <a:lstStyle/>
+          <a:p>
+            <a:pPr algn="ctr"/>
+          </a:p>
+        </p:txBody>
+      </p:sp>
+      <p:sp>
+        <p:nvSpPr>
+          <p:cNvPr id="31" name="设计：用联合 DP 同时选择分组边界与路径"/>
           <p:cNvSpPr txBox="1"/>
           <p:nvPr/>
         </p:nvSpPr>
         <p:spPr>
           <a:xfrm>
-            <a:off x="609600" y="5448300"/>
-            <a:ext cx="10972800" cy="523874"/>
+            <a:off x="781050" y="5381625"/>
+            <a:ext cx="6743700" cy="295275"/>
           </a:xfrm>
           <a:prstGeom prst="rect">
             <a:avLst/>
@@ -8878,16 +9452,40 @@
               </a:spcAft>
             </a:pPr>
             <a:r>
-              <a:rPr sz="1650" b="0" lang="zh-CN">
-                <a:solidFill>
-                  <a:srgbClr val="657184"/>
-                </a:solidFill>
-                <a:latin typeface="Microsoft YaHei"/>
-                <a:ea typeface="Microsoft YaHei"/>
-              </a:rPr>
-              <a:t>读按物理字节、复制按有效字节；工作量由公开性能表估计。DIRECT 系数为 1，</a:t>
-            </a:r>
-          </a:p>
+              <a:rPr sz="1950" b="1" lang="zh-CN">
+                <a:solidFill>
+                  <a:srgbClr val="285EA8"/>
+                </a:solidFill>
+                <a:latin typeface="Microsoft YaHei"/>
+                <a:ea typeface="Microsoft YaHei"/>
+              </a:rPr>
+              <a:t>设计：用联合 DP 同时选择分组边界与路径</a:t>
+            </a:r>
+          </a:p>
+        </p:txBody>
+      </p:sp>
+      <p:sp>
+        <p:nvSpPr>
+          <p:cNvPr id="32" name="每个合法分组比较各条路径，用同一成本口径排序。"/>
+          <p:cNvSpPr txBox="1"/>
+          <p:nvPr/>
+        </p:nvSpPr>
+        <p:spPr>
+          <a:xfrm>
+            <a:off x="781050" y="5753100"/>
+            <a:ext cx="6743700" cy="228600"/>
+          </a:xfrm>
+          <a:prstGeom prst="rect">
+            <a:avLst/>
+          </a:prstGeom>
+          <a:noFill/>
+          <a:effectLst/>
+        </p:spPr>
+        <p:txBody>
+          <a:bodyPr wrap="square" lIns="0" rIns="0" tIns="0" bIns="0">
+            <a:spAutoFit/>
+          </a:bodyPr>
+          <a:lstStyle/>
           <a:p>
             <a:pPr algn="l">
               <a:lnSpc>
@@ -8898,14 +9496,146 @@
               </a:spcAft>
             </a:pPr>
             <a:r>
-              <a:rPr sz="1650" b="0" lang="zh-CN">
-                <a:solidFill>
-                  <a:srgbClr val="657184"/>
-                </a:solidFill>
-                <a:latin typeface="Microsoft YaHei"/>
-                <a:ea typeface="Microsoft YaHei"/>
-              </a:rPr>
-              <a:t>中转为 1 + 0.5 × 对应池已用比例；这是局部估价，不是官方最终 J。</a:t>
+              <a:rPr sz="1575" b="0" lang="zh-CN">
+                <a:solidFill>
+                  <a:srgbClr val="1F2937"/>
+                </a:solidFill>
+                <a:latin typeface="Microsoft YaHei"/>
+                <a:ea typeface="Microsoft YaHei"/>
+              </a:rPr>
+              <a:t>每个合法分组比较各条路径，用同一成本口径排序。</a:t>
+            </a:r>
+          </a:p>
+        </p:txBody>
+      </p:sp>
+      <p:sp>
+        <p:nvSpPr>
+          <p:cNvPr id="33" name="Rectangle 32"/>
+          <p:cNvSpPr/>
+          <p:nvPr/>
+        </p:nvSpPr>
+        <p:spPr>
+          <a:xfrm>
+            <a:off x="8077200" y="5286375"/>
+            <a:ext cx="3505200" cy="733425"/>
+          </a:xfrm>
+          <a:prstGeom prst="rect">
+            <a:avLst/>
+          </a:prstGeom>
+          <a:solidFill>
+            <a:srgbClr val="EEF6F3"/>
+          </a:solidFill>
+          <a:ln>
+            <a:noFill/>
+          </a:ln>
+          <a:effectLst/>
+        </p:spPr>
+        <p:style>
+          <a:lnRef idx="1">
+            <a:schemeClr val="accent1"/>
+          </a:lnRef>
+          <a:fillRef idx="3">
+            <a:schemeClr val="accent1"/>
+          </a:fillRef>
+          <a:effectRef idx="0">
+            <a:schemeClr val="accent1"/>
+          </a:effectRef>
+          <a:fontRef idx="minor">
+            <a:schemeClr val="lt1"/>
+          </a:fontRef>
+        </p:style>
+        <p:txBody>
+          <a:bodyPr rtlCol="0" anchor="ctr"/>
+          <a:lstStyle/>
+          <a:p>
+            <a:pPr algn="ctr"/>
+          </a:p>
+        </p:txBody>
+      </p:sp>
+      <p:sp>
+        <p:nvSpPr>
+          <p:cNvPr id="34" name="设计：按净收益与预算准入"/>
+          <p:cNvSpPr txBox="1"/>
+          <p:nvPr/>
+        </p:nvSpPr>
+        <p:spPr>
+          <a:xfrm>
+            <a:off x="8248650" y="5391150"/>
+            <a:ext cx="3162300" cy="276225"/>
+          </a:xfrm>
+          <a:prstGeom prst="rect">
+            <a:avLst/>
+          </a:prstGeom>
+          <a:noFill/>
+          <a:effectLst/>
+        </p:spPr>
+        <p:txBody>
+          <a:bodyPr wrap="square" lIns="0" rIns="0" tIns="0" bIns="0">
+            <a:spAutoFit/>
+          </a:bodyPr>
+          <a:lstStyle/>
+          <a:p>
+            <a:pPr algn="l">
+              <a:lnSpc>
+                <a:spcPct val="112000"/>
+              </a:lnSpc>
+              <a:spcAft>
+                <a:spcPts val="500"/>
+              </a:spcAft>
+            </a:pPr>
+            <a:r>
+              <a:rPr sz="1725" b="1" lang="zh-CN">
+                <a:solidFill>
+                  <a:srgbClr val="24756D"/>
+                </a:solidFill>
+                <a:latin typeface="Microsoft YaHei"/>
+                <a:ea typeface="Microsoft YaHei"/>
+              </a:rPr>
+              <a:t>设计：按净收益与预算准入</a:t>
+            </a:r>
+          </a:p>
+        </p:txBody>
+      </p:sp>
+      <p:sp>
+        <p:nvSpPr>
+          <p:cNvPr id="35" name="复用证据有效，再决定是否提升。"/>
+          <p:cNvSpPr txBox="1"/>
+          <p:nvPr/>
+        </p:nvSpPr>
+        <p:spPr>
+          <a:xfrm>
+            <a:off x="8248650" y="5762625"/>
+            <a:ext cx="3162300" cy="228600"/>
+          </a:xfrm>
+          <a:prstGeom prst="rect">
+            <a:avLst/>
+          </a:prstGeom>
+          <a:noFill/>
+          <a:effectLst/>
+        </p:spPr>
+        <p:txBody>
+          <a:bodyPr wrap="square" lIns="0" rIns="0" tIns="0" bIns="0">
+            <a:spAutoFit/>
+          </a:bodyPr>
+          <a:lstStyle/>
+          <a:p>
+            <a:pPr algn="l">
+              <a:lnSpc>
+                <a:spcPct val="112000"/>
+              </a:lnSpc>
+              <a:spcAft>
+                <a:spcPts val="500"/>
+              </a:spcAft>
+            </a:pPr>
+            <a:r>
+              <a:rPr sz="1500" b="0" lang="zh-CN">
+                <a:solidFill>
+                  <a:srgbClr val="1F2937"/>
+                </a:solidFill>
+                <a:latin typeface="Microsoft YaHei"/>
+                <a:ea typeface="Microsoft YaHei"/>
+              </a:rPr>
+              <a:t>复用证据有效，再决定是否提升。</a:t>
             </a:r>
           </a:p>
         </p:txBody>

</xml_diff>

<commit_message>
docs: clarify DP plan counts and focus the defense narrative
Signed-off-by: KaisennHu <74917084+KaisennHu@users.noreply.github.com>
</commit_message>
<xml_diff>
--- a/submissions/kaisennhu/07_答辩PPT/答辩介绍.pptx
+++ b/submissions/kaisennhu/07_答辩PPT/答辩介绍.pptx
@@ -652,7 +652,7 @@
           <a:lstStyle/>
           <a:p>
             <a:r>
-              <a:t>本页两张主图都是正常启用缓存的两套完整方案直接比较，同组39条公开Trace，各自从零起算、组内共享同一比例，费用越低越好；不混入关闭缓存的消融。后台总调用费=提升CPU/NPU费+框架命中H2D调用费：贪心722994+81662=804656，本方案24676+16806=41482，下降94.8447535%。该值不含前台调用费，也不含模拟搬运时间费，不称为整个后台J。平均每次命中的调用费=整条Trace汇总后台调用费/真实命中请求数；804656/40831=19.7069873，本方案41482/8403=4.93657027，下降74.9501525%。这是把所有提升投入（含最终没有命中的提升）和命中调用费摊到总命中数上的比值，包含准入选择的效果，不是单次命中固有单价。官方单次命中调用收费两者均为2，算法没有降低这一收费。每次提升的平均命中数=40831/8817=4.63094与8403/301=27.91694，后者6.02835倍。两项均为完整Trace的汇总效率，不代表单个对象必命中27.92次，不是同尺寸、同缓存内容的受控模块对照。请求总数相同198542，命中率20.57%→4.23%；提升次数与命中数均在页脚公开。选更少的缓存对象、保留更集中复用，是对总计数的解释，不声称每道门槛的独立因果贡献。high_mixed可直接核验：贪心3566次提升、提升调用费292412、命中0；本方案均0。全Trace J530416→174066还有前台变化，不能全算缓存收益。提升调用费单项下降96.59%，提升搬运字节3881057800→327938527，下降91.55%。补充消融与主图分开：双方各自保留前台，仅关闭PROMOTE，贪心J3686550→3581641，缓存净贡献104909；本方案2344079→2273874，缓存净贡献70205。绝对命中量和缓存净贡献较小，不能声称缓存模块在同一前台下收益更大。消融双方各6例正收益，贪心17例负收益、本方案2例；这不表示相对baseline退化。06_reuse_hot：本方案开/关36356/36302，baseline41233；mid_reuse：88409/87179，baseline185453。完整方案分别优于baseline11.83%、52.33%。公开39条35胜4平0负；扩展292条96条退化，详见报告。所有数据由已提交CSV聚合，算法与原始性能记录不变。</a:t>
+              <a:t>本页两张主图都是正常启用缓存的两套完整方案直接比较，同组39条公开Trace，各自从零起算、组内共享同一比例，费用越低越好；不混入关闭缓存的消融。后台总调用费=提升CPU/NPU费+框架命中H2D调用费：贪心722994+81662=804656，本方案24676+16806=41482，下降94.8447535%。该值不含前台调用费，也不含模拟搬运时间费，不称为整个后台J。平均每次命中的调用费=整条Trace汇总后台调用费/真实命中请求数；804656/40831=19.7069873，本方案41482/8403=4.93657027，下降74.9501525%。这是把所有提升投入（含最终没有命中的提升）和命中调用费摊到总命中数上的比值，包含准入选择的效果，不是单次命中固有单价。官方单次命中调用收费两者均为2，算法没有降低这一收费。每次提升的平均命中数=40831/8817=4.63094与8403/301=27.91694，后者6.02835倍。两项均为完整Trace的汇总效率，不代表单个对象必命中27.92次，不是同尺寸、同缓存内容的受控模块对照。请求总数相同198542，命中率20.57%→4.23%；提升次数与命中数均在页脚公开。选更少的缓存对象、保留更集中复用，是对总计数的解释，不声称每道门槛的独立因果贡献。high_mixed可直接核验：贪心3566次提升、提升调用费292412、命中0；本方案均0。全Trace J530416→174066还有前台变化，不能全算缓存收益。提升调用费单项下降96.59%，提升搬运字节3881057800→327938527，下降91.55%。完整方案在39条公开Trace上35胜4平0负。逐例结果与复现方法见验证报告。所有数据由已提交CSV聚合，算法与原始性能记录不变。</a:t>
             </a:r>
           </a:p>
         </p:txBody>
@@ -932,7 +932,7 @@
           <a:lstStyle/>
           <a:p>
             <a:r>
-              <a:t>讲解顺序是同一前台规划的三个串行步骤，不是两个互相投票的独立算法。快速DP每批必运行：用片段数与卡上请求数作为初始负载代理，对合法的分组加路径候选求一维前缀最小值，输出完整基础方案。细化DP不是只给原方案打分，也不是只改变路径：它复用同一合法候选边集合，从基础方案读取组数与卡号/复制类型比例，在固定候选总组数cnt后重新求解D[h][j]，可同时改变分组和路径。cnt影响SSD估价并发；复制估价按基础方案的各卡/类型占比计算，并按对应上限处理。为何有两阶段：分组影响并发，而并发影响估价；基础方案提供复制分布，有限细化缓解该相互依赖，避免每批进行高维全量搜索。细化入口要求无活动传输、排队、在途提升、占槽或旧未完成请求；最多1024请求、2048 iov、16384片段，基础方案最多2048操作。合法边至多262144，单次存储状态至多131072，共享200万估价/转移预算；具体预检查与回溯另计。每个cnt回溯后检查总槽位和两类临时池容量。最终选通过检查且完成求解的细化候选中估价最低者；无可用候选则保留基础方案。代码不将快速E和细化E直接比较，也不保证细化后的真实J必降。DP只处理当前未命中的合法连续片段，每起点最多向后看128片段，不规划未来、不决定PROMOTE。五次点击依次显示基础规划、细化、输出选择、更新公式与数值示例、实际结果。三个源区间[0,512)、[512,1024)、[1024,1536)，目标同卡且分别对齐。快速阶段qs=qc=3，整组D/A/F的E为5.406/32.820/22.559；快速dp[1/2/3]=3.135/4.271/5.406。细化时基础方案全DIRECT，复制估价q=1，因此整组AGGREGATE E重算为81.648，不能沿用快速阶段数值。页面只展示同一细化阶段内可比的最终候选：1/2/3组最低E为5.406/7.406/9.406，均由DIRECT取得；代码实际尝试顺序1、3、2。最终读工作3.4059797微秒，Trace时间向上取整为4微秒，调用费2，官方J=6；分别读3次时T=4、调用费6、J=10。已核验输入、估价及官方输出；放映不运行C++。</a:t>
+              <a:t>本页区分三层概念。合法操作候选是“某段连续片段合为一组，走某条路径”；一份完整方案是若干操作覆盖本批全部片段。快速DP枚举许多候选操作，但最终只回溯输出一份完整基础方案，不输出多份完整方案。每个dp[j]也只保留一个最低估价前驱；并列时保留先遇到的选择。细化阶段从基础方案获得组数seed以及卡号/复制类型的组数比例，再从前面枚举的同一合法操作集合中重新求解。多个完整候选来自对多个总组数cnt分别求解；每个cnt只回溯一个最低估价方案，回溯后进行总槽位与池容量检查，不保留该cnt的次优方案。最终提交的仍是一份计划。快速更新dp[j]=min_i,path(dp[i]+E(i,j,path))，状态只表示前缀j，最终组数由回溯决定。细化更新D[h][j]=min_i,path(D[h-1][i]+E_cnt(i,j,path))；每固定一个cnt，边权用对应并发重算，取D[cnt][n]回溯。两阶段都联合选分组边界和路径，并非先分组后选路。快速SSD估价并发max(1,active_ssd+n)，复制为max(1,active_copy+per_card_requests)；细化SSD为max(1,active_ssd+cnt)，因入口保守空闲，active_ssd为0。复制为active_copy+max(1,ceil(cnt*seed_copy_groups/seed))，按卡号与D2D/H2D类型分别估计，估价内再应用对应性能表及并发限制；DIRECT不计入复制组数。cnt不是整个执行期不变的真实并发，E用于排序，实际J由官方完整Trace回放计算。每批先运行快速DP。细化仅在无活动传输、queued_iocbs、promote_inflight、foreground_iocb_inflight及旧未完成到达登记时尝试；≤1024请求、≤2048 iov、≤16384片段，快速方案≤2048操作。合法边上限262144；每cnt状态≤131072，估价/转移共享200万工作预算。预检查、可达性过滤、采样及回溯资源检查按代码执行；预算不足的cnt不求解。有合格细化方案则选细化候选中的最低估价者，没有则保留快速方案；不是把快速E与细化E直接比较。n≤24时尝试所有cnt，否则采样性能桶边界、几何序列及尺寸拐点，并局部细化；采样包含基础方案组数，但该cnt重新求出的方案可能与基础方案不同。三个同卡相邻对齐512B片段：快速阶段qs=qc=3，整组D/A/F E=5.406/32.820/22.559，输出一个DIRECT组。细化时全DIRECT基础方案使复制qc=1，AGGREGATE整组E重算为81.648；每cnt的最佳D[cnt][3]在1/2/3组时为5.406/7.406/9.406，均由DIRECT取得。代码尝试顺序1、3、2，最终仍选一个DIRECT。实际读工作3.4059797微秒，Trace时间向上取整4微秒，调用费2，J=6；分别读时调用费6、J=10。前台最多考察起点后128片段，不处理未来请求或PROMOTE。五次点击对应快速输出、细化候选、入口范围、最终选择、数值示例；放映展示已核验的执行过程，不调用模拟器。</a:t>
             </a:r>
           </a:p>
         </p:txBody>
@@ -1212,7 +1212,7 @@
           <a:lstStyle/>
           <a:p>
             <a:r>
-              <a:t>这页专门回答调度算法开销，不把优化后的模拟J当成本机加速。所有数字来自主线验证报告和资源开销CSV。回调覆盖两个策略函数，正式策略本身没有计时器，测试使用外层计时器。逐例三轮取中位数后求和得到1.153s与0.831s；进程总时间同时包含框架执行、数据结构和JSON输入输出，故回调更慢而总程序更快并不矛盾。峰值取所有公开例正式轮的最大值，策略堆与RSS是不同范围。预热、编译和独立validator另计；共享主机噪声与硬件会影响实测值。不从总程序时间独立推断某一算法模块加速。扩展655条策略堆峰值13.06MiB；极端碎片探针1.58GiB，和公开集口径分开。</a:t>
+              <a:t>这页专门回答调度算法开销，不把优化后的模拟J当成本机加速。所有数字来自主线验证报告和资源开销CSV。回调覆盖两个策略函数，正式策略本身没有计时器，测试使用外层计时器。逐例三轮取中位数后求和得到1.153s与0.831s；进程总时间同时包含框架执行、数据结构和JSON输入输出，故回调更慢而总程序更快并不矛盾。峰值取所有公开例正式轮的最大值，策略堆与RSS是不同范围。预热、编译和独立validator另计；共享主机噪声与硬件会影响实测值。不从总程序时间独立推断某一算法模块加速。本页统一使用39条公开输入的统计口径，逐例记录见资源开销CSV。</a:t>
             </a:r>
           </a:p>
         </p:txBody>
@@ -11154,7 +11154,7 @@
       <p:grpSpPr/>
       <p:sp>
         <p:nvSpPr>
-          <p:cNvPr id="2" name="前台 · 分组与路径联合规划"/>
+          <p:cNvPr id="2" name="前台 · 联合 DP 的两阶段实现"/>
           <p:cNvSpPr txBox="1"/>
           <p:nvPr/>
         </p:nvSpPr>
@@ -11191,14 +11191,14 @@
                 <a:latin typeface="Microsoft YaHei"/>
                 <a:ea typeface="Microsoft YaHei"/>
               </a:rPr>
-              <a:t>前台 · 分组与路径联合规划</a:t>
-            </a:r>
-          </a:p>
-        </p:txBody>
-      </p:sp>
-      <p:sp>
-        <p:nvSpPr>
-          <p:cNvPr id="3" name="联合 DP：先出基础方案，再按需细化"/>
+              <a:t>前台 · 联合 DP 的两阶段实现</a:t>
+            </a:r>
+          </a:p>
+        </p:txBody>
+      </p:sp>
+      <p:sp>
+        <p:nvSpPr>
+          <p:cNvPr id="3" name="快速 DP 产出一个方案，细化按组数生成候选"/>
           <p:cNvSpPr txBox="1"/>
           <p:nvPr/>
         </p:nvSpPr>
@@ -11235,14 +11235,14 @@
                 <a:latin typeface="Microsoft YaHei"/>
                 <a:ea typeface="Microsoft YaHei"/>
               </a:rPr>
-              <a:t>联合 DP：先出基础方案，再按需细化</a:t>
-            </a:r>
-          </a:p>
-        </p:txBody>
-      </p:sp>
-      <p:sp>
-        <p:nvSpPr>
-          <p:cNvPr id="4" name="分组影响并发，并发又影响成本；基础方案提供复制分布，细化按候选组数重新求解。"/>
+              <a:t>快速 DP 产出一个方案，细化按组数生成候选</a:t>
+            </a:r>
+          </a:p>
+        </p:txBody>
+      </p:sp>
+      <p:sp>
+        <p:nvSpPr>
+          <p:cNvPr id="4" name="两阶段共用合法操作集合，都同时选分组与路径；细化利用基础方案的复制分布估计并发。"/>
           <p:cNvSpPr txBox="1"/>
           <p:nvPr/>
         </p:nvSpPr>
@@ -11279,7 +11279,7 @@
                 <a:latin typeface="Microsoft YaHei"/>
                 <a:ea typeface="Microsoft YaHei"/>
               </a:rPr>
-              <a:t>分组影响并发，并发又影响成本；基础方案提供复制分布，细化按候选组数重新求解。</a:t>
+              <a:t>两阶段共用合法操作集合，都同时选分组与路径；细化利用基础方案的复制分布估计并发。</a:t>
             </a:r>
           </a:p>
         </p:txBody>
@@ -11408,74 +11408,358 @@
           </a:p>
         </p:txBody>
       </p:sp>
+      <p:sp>
+        <p:nvSpPr>
+          <p:cNvPr id="8" name="Rectangle 7"/>
+          <p:cNvSpPr/>
+          <p:nvPr/>
+        </p:nvSpPr>
+        <p:spPr>
+          <a:xfrm>
+            <a:off x="609600" y="2076450"/>
+            <a:ext cx="10972800" cy="381000"/>
+          </a:xfrm>
+          <a:prstGeom prst="rect">
+            <a:avLst/>
+          </a:prstGeom>
+          <a:solidFill>
+            <a:srgbClr val="EDF3FA"/>
+          </a:solidFill>
+          <a:ln>
+            <a:noFill/>
+          </a:ln>
+          <a:effectLst/>
+        </p:spPr>
+        <p:style>
+          <a:lnRef idx="1">
+            <a:schemeClr val="accent1"/>
+          </a:lnRef>
+          <a:fillRef idx="3">
+            <a:schemeClr val="accent1"/>
+          </a:fillRef>
+          <a:effectRef idx="0">
+            <a:schemeClr val="accent1"/>
+          </a:effectRef>
+          <a:fontRef idx="minor">
+            <a:schemeClr val="lt1"/>
+          </a:fontRef>
+        </p:style>
+        <p:txBody>
+          <a:bodyPr rtlCol="0" anchor="ctr"/>
+          <a:lstStyle/>
+          <a:p>
+            <a:pPr algn="ctr"/>
+          </a:p>
+        </p:txBody>
+      </p:sp>
+      <p:sp>
+        <p:nvSpPr>
+          <p:cNvPr id="9" name="比较项"/>
+          <p:cNvSpPr txBox="1"/>
+          <p:nvPr/>
+        </p:nvSpPr>
+        <p:spPr>
+          <a:xfrm>
+            <a:off x="762000" y="2152650"/>
+            <a:ext cx="1409700" cy="276225"/>
+          </a:xfrm>
+          <a:prstGeom prst="rect">
+            <a:avLst/>
+          </a:prstGeom>
+          <a:noFill/>
+          <a:effectLst/>
+        </p:spPr>
+        <p:txBody>
+          <a:bodyPr wrap="square" lIns="0" rIns="0" tIns="0" bIns="0">
+            <a:spAutoFit/>
+          </a:bodyPr>
+          <a:lstStyle/>
+          <a:p>
+            <a:pPr algn="l">
+              <a:lnSpc>
+                <a:spcPct val="112000"/>
+              </a:lnSpc>
+              <a:spcAft>
+                <a:spcPts val="500"/>
+              </a:spcAft>
+            </a:pPr>
+            <a:r>
+              <a:rPr sz="1725" b="1" lang="zh-CN">
+                <a:solidFill>
+                  <a:srgbClr val="285EA8"/>
+                </a:solidFill>
+                <a:latin typeface="Microsoft YaHei"/>
+                <a:ea typeface="Microsoft YaHei"/>
+              </a:rPr>
+              <a:t>比较项</a:t>
+            </a:r>
+          </a:p>
+        </p:txBody>
+      </p:sp>
+      <p:sp>
+        <p:nvSpPr>
+          <p:cNvPr id="10" name="状态与约束"/>
+          <p:cNvSpPr txBox="1"/>
+          <p:nvPr/>
+        </p:nvSpPr>
+        <p:spPr>
+          <a:xfrm>
+            <a:off x="762000" y="2628900"/>
+            <a:ext cx="1409700" cy="571500"/>
+          </a:xfrm>
+          <a:prstGeom prst="rect">
+            <a:avLst/>
+          </a:prstGeom>
+          <a:noFill/>
+          <a:effectLst/>
+        </p:spPr>
+        <p:txBody>
+          <a:bodyPr wrap="square" lIns="0" rIns="0" tIns="0" bIns="0">
+            <a:spAutoFit/>
+          </a:bodyPr>
+          <a:lstStyle/>
+          <a:p>
+            <a:pPr algn="l">
+              <a:lnSpc>
+                <a:spcPct val="112000"/>
+              </a:lnSpc>
+              <a:spcAft>
+                <a:spcPts val="500"/>
+              </a:spcAft>
+            </a:pPr>
+            <a:r>
+              <a:rPr sz="1650" b="1" lang="zh-CN">
+                <a:solidFill>
+                  <a:srgbClr val="657184"/>
+                </a:solidFill>
+                <a:latin typeface="Microsoft YaHei"/>
+                <a:ea typeface="Microsoft YaHei"/>
+              </a:rPr>
+              <a:t>状态与约束</a:t>
+            </a:r>
+          </a:p>
+        </p:txBody>
+      </p:sp>
+      <p:cxnSp>
+        <p:nvCxnSpPr>
+          <p:cNvPr id="11" name="Connector 10"/>
+          <p:cNvCxnSpPr/>
+          <p:nvPr/>
+        </p:nvCxnSpPr>
+        <p:spPr>
+          <a:xfrm>
+            <a:off x="609600" y="3276600"/>
+            <a:ext cx="10972800" cy="0"/>
+          </a:xfrm>
+          <a:prstGeom prst="line">
+            <a:avLst/>
+          </a:prstGeom>
+          <a:ln w="12700">
+            <a:solidFill>
+              <a:srgbClr val="DCE2E9"/>
+            </a:solidFill>
+          </a:ln>
+          <a:effectLst/>
+        </p:spPr>
+        <p:style>
+          <a:lnRef idx="2">
+            <a:schemeClr val="accent1"/>
+          </a:lnRef>
+          <a:fillRef idx="0">
+            <a:schemeClr val="accent1"/>
+          </a:fillRef>
+          <a:effectRef idx="0">
+            <a:schemeClr val="accent1"/>
+          </a:effectRef>
+          <a:fontRef idx="minor">
+            <a:schemeClr val="tx1"/>
+          </a:fontRef>
+        </p:style>
+      </p:cxnSp>
+      <p:sp>
+        <p:nvSpPr>
+          <p:cNvPr id="12" name="并发估计"/>
+          <p:cNvSpPr txBox="1"/>
+          <p:nvPr/>
+        </p:nvSpPr>
+        <p:spPr>
+          <a:xfrm>
+            <a:off x="762000" y="3295650"/>
+            <a:ext cx="1409700" cy="571500"/>
+          </a:xfrm>
+          <a:prstGeom prst="rect">
+            <a:avLst/>
+          </a:prstGeom>
+          <a:noFill/>
+          <a:effectLst/>
+        </p:spPr>
+        <p:txBody>
+          <a:bodyPr wrap="square" lIns="0" rIns="0" tIns="0" bIns="0">
+            <a:spAutoFit/>
+          </a:bodyPr>
+          <a:lstStyle/>
+          <a:p>
+            <a:pPr algn="l">
+              <a:lnSpc>
+                <a:spcPct val="112000"/>
+              </a:lnSpc>
+              <a:spcAft>
+                <a:spcPts val="500"/>
+              </a:spcAft>
+            </a:pPr>
+            <a:r>
+              <a:rPr sz="1650" b="1" lang="zh-CN">
+                <a:solidFill>
+                  <a:srgbClr val="657184"/>
+                </a:solidFill>
+                <a:latin typeface="Microsoft YaHei"/>
+                <a:ea typeface="Microsoft YaHei"/>
+              </a:rPr>
+              <a:t>并发估计</a:t>
+            </a:r>
+          </a:p>
+        </p:txBody>
+      </p:sp>
+      <p:cxnSp>
+        <p:nvCxnSpPr>
+          <p:cNvPr id="13" name="Connector 12"/>
+          <p:cNvCxnSpPr/>
+          <p:nvPr/>
+        </p:nvCxnSpPr>
+        <p:spPr>
+          <a:xfrm>
+            <a:off x="609600" y="3943350"/>
+            <a:ext cx="10972800" cy="0"/>
+          </a:xfrm>
+          <a:prstGeom prst="line">
+            <a:avLst/>
+          </a:prstGeom>
+          <a:ln w="12700">
+            <a:solidFill>
+              <a:srgbClr val="DCE2E9"/>
+            </a:solidFill>
+          </a:ln>
+          <a:effectLst/>
+        </p:spPr>
+        <p:style>
+          <a:lnRef idx="2">
+            <a:schemeClr val="accent1"/>
+          </a:lnRef>
+          <a:fillRef idx="0">
+            <a:schemeClr val="accent1"/>
+          </a:fillRef>
+          <a:effectRef idx="0">
+            <a:schemeClr val="accent1"/>
+          </a:effectRef>
+          <a:fontRef idx="minor">
+            <a:schemeClr val="tx1"/>
+          </a:fontRef>
+        </p:style>
+      </p:cxnSp>
+      <p:sp>
+        <p:nvSpPr>
+          <p:cNvPr id="14" name="输出"/>
+          <p:cNvSpPr txBox="1"/>
+          <p:nvPr/>
+        </p:nvSpPr>
+        <p:spPr>
+          <a:xfrm>
+            <a:off x="762000" y="3981450"/>
+            <a:ext cx="1409700" cy="504825"/>
+          </a:xfrm>
+          <a:prstGeom prst="rect">
+            <a:avLst/>
+          </a:prstGeom>
+          <a:noFill/>
+          <a:effectLst/>
+        </p:spPr>
+        <p:txBody>
+          <a:bodyPr wrap="square" lIns="0" rIns="0" tIns="0" bIns="0">
+            <a:spAutoFit/>
+          </a:bodyPr>
+          <a:lstStyle/>
+          <a:p>
+            <a:pPr algn="l">
+              <a:lnSpc>
+                <a:spcPct val="112000"/>
+              </a:lnSpc>
+              <a:spcAft>
+                <a:spcPts val="500"/>
+              </a:spcAft>
+            </a:pPr>
+            <a:r>
+              <a:rPr sz="1650" b="1" lang="zh-CN">
+                <a:solidFill>
+                  <a:srgbClr val="657184"/>
+                </a:solidFill>
+                <a:latin typeface="Microsoft YaHei"/>
+                <a:ea typeface="Microsoft YaHei"/>
+              </a:rPr>
+              <a:t>输出</a:t>
+            </a:r>
+          </a:p>
+        </p:txBody>
+      </p:sp>
+      <p:cxnSp>
+        <p:nvCxnSpPr>
+          <p:cNvPr id="15" name="Connector 14"/>
+          <p:cNvCxnSpPr/>
+          <p:nvPr/>
+        </p:nvCxnSpPr>
+        <p:spPr>
+          <a:xfrm>
+            <a:off x="609600" y="4562475"/>
+            <a:ext cx="10972800" cy="0"/>
+          </a:xfrm>
+          <a:prstGeom prst="line">
+            <a:avLst/>
+          </a:prstGeom>
+          <a:ln w="12700">
+            <a:solidFill>
+              <a:srgbClr val="DCE2E9"/>
+            </a:solidFill>
+          </a:ln>
+          <a:effectLst/>
+        </p:spPr>
+        <p:style>
+          <a:lnRef idx="2">
+            <a:schemeClr val="accent1"/>
+          </a:lnRef>
+          <a:fillRef idx="0">
+            <a:schemeClr val="accent1"/>
+          </a:fillRef>
+          <a:effectRef idx="0">
+            <a:schemeClr val="accent1"/>
+          </a:effectRef>
+          <a:fontRef idx="minor">
+            <a:schemeClr val="tx1"/>
+          </a:fontRef>
+        </p:style>
+      </p:cxnSp>
       <p:grpSp>
         <p:nvGrpSpPr>
-          <p:cNvPr id="8" name="步骤1：快速 DP 输出基础方案"/>
+          <p:cNvPr id="16" name="步骤1：快速 DP 每批输出一份基础方案"/>
           <p:cNvGrpSpPr/>
           <p:nvPr/>
         </p:nvGrpSpPr>
         <p:grpSpPr>
           <a:xfrm>
-            <a:off x="609600" y="2076450"/>
-            <a:ext cx="3143250" cy="1114425"/>
-            <a:chOff x="609600" y="2076450"/>
-            <a:chExt cx="3143250" cy="1114425"/>
+            <a:off x="2381250" y="2152650"/>
+            <a:ext cx="4171950" cy="2305050"/>
+            <a:chOff x="2381250" y="2152650"/>
+            <a:chExt cx="4171950" cy="2305050"/>
           </a:xfrm>
         </p:grpSpPr>
         <p:sp>
           <p:nvSpPr>
-            <p:cNvPr id="9" name="Rectangle 8"/>
-            <p:cNvSpPr/>
-            <p:nvPr/>
-          </p:nvSpPr>
-          <p:spPr>
-            <a:xfrm>
-              <a:off x="609600" y="2076450"/>
-              <a:ext cx="3143250" cy="1114425"/>
-            </a:xfrm>
-            <a:prstGeom prst="rect">
-              <a:avLst/>
-            </a:prstGeom>
-            <a:solidFill>
-              <a:srgbClr val="EDF3FA"/>
-            </a:solidFill>
-            <a:ln>
-              <a:noFill/>
-            </a:ln>
-            <a:effectLst/>
-          </p:spPr>
-          <p:style>
-            <a:lnRef idx="1">
-              <a:schemeClr val="accent1"/>
-            </a:lnRef>
-            <a:fillRef idx="3">
-              <a:schemeClr val="accent1"/>
-            </a:fillRef>
-            <a:effectRef idx="0">
-              <a:schemeClr val="accent1"/>
-            </a:effectRef>
-            <a:fontRef idx="minor">
-              <a:schemeClr val="lt1"/>
-            </a:fontRef>
-          </p:style>
-          <p:txBody>
-            <a:bodyPr rtlCol="0" anchor="ctr"/>
-            <a:lstStyle/>
-            <a:p>
-              <a:pPr algn="ctr"/>
-            </a:p>
-          </p:txBody>
-        </p:sp>
-        <p:sp>
-          <p:nvSpPr>
-            <p:cNvPr id="10" name="① 快速 DP：先有方案"/>
+            <p:cNvPr id="17" name="快速 DP · 每批执行"/>
             <p:cNvSpPr txBox="1"/>
             <p:nvPr/>
           </p:nvSpPr>
           <p:spPr>
             <a:xfrm>
-              <a:off x="762000" y="2209800"/>
-              <a:ext cx="2838450" cy="285750"/>
+              <a:off x="2381250" y="2152650"/>
+              <a:ext cx="4171950" cy="276225"/>
             </a:xfrm>
             <a:prstGeom prst="rect">
               <a:avLst/>
@@ -11498,28 +11782,343 @@
                 </a:spcAft>
               </a:pPr>
               <a:r>
-                <a:rPr sz="1800" b="1" lang="zh-CN">
+                <a:rPr sz="1725" b="1" lang="zh-CN">
                   <a:solidFill>
                     <a:srgbClr val="285EA8"/>
                   </a:solidFill>
                   <a:latin typeface="Microsoft YaHei"/>
                   <a:ea typeface="Microsoft YaHei"/>
                 </a:rPr>
-                <a:t>① 快速 DP：先有方案</a:t>
+                <a:t>快速 DP · 每批执行</a:t>
               </a:r>
             </a:p>
           </p:txBody>
         </p:sp>
         <p:sp>
           <p:nvSpPr>
-            <p:cNvPr id="11" name="联合选分组和路径 同时得到各卡的复制路径占比"/>
+            <p:cNvPr id="18" name="dp[j]：前 j 段的最低估价 最终组数不预先固定"/>
             <p:cNvSpPr txBox="1"/>
             <p:nvPr/>
           </p:nvSpPr>
           <p:spPr>
             <a:xfrm>
-              <a:off x="762000" y="2619375"/>
-              <a:ext cx="2838450" cy="504825"/>
+              <a:off x="2381250" y="2619375"/>
+              <a:ext cx="4171950" cy="533400"/>
+            </a:xfrm>
+            <a:prstGeom prst="rect">
+              <a:avLst/>
+            </a:prstGeom>
+            <a:noFill/>
+            <a:effectLst/>
+          </p:spPr>
+          <p:txBody>
+            <a:bodyPr wrap="square" lIns="0" rIns="0" tIns="0" bIns="0">
+              <a:spAutoFit/>
+            </a:bodyPr>
+            <a:lstStyle/>
+            <a:p>
+              <a:pPr algn="l">
+                <a:lnSpc>
+                  <a:spcPct val="112000"/>
+                </a:lnSpc>
+                <a:spcAft>
+                  <a:spcPts val="500"/>
+                </a:spcAft>
+              </a:pPr>
+              <a:r>
+                <a:rPr sz="1650" b="0" lang="zh-CN">
+                  <a:solidFill>
+                    <a:srgbClr val="1F2937"/>
+                  </a:solidFill>
+                  <a:latin typeface="Microsoft YaHei"/>
+                  <a:ea typeface="Microsoft YaHei"/>
+                </a:rPr>
+                <a:t>dp[j]：前 j 段的最低估价</a:t>
+              </a:r>
+            </a:p>
+            <a:p>
+              <a:pPr algn="l">
+                <a:lnSpc>
+                  <a:spcPct val="112000"/>
+                </a:lnSpc>
+                <a:spcAft>
+                  <a:spcPts val="500"/>
+                </a:spcAft>
+              </a:pPr>
+              <a:r>
+                <a:rPr sz="1650" b="0" lang="zh-CN">
+                  <a:solidFill>
+                    <a:srgbClr val="1F2937"/>
+                  </a:solidFill>
+                  <a:latin typeface="Microsoft YaHei"/>
+                  <a:ea typeface="Microsoft YaHei"/>
+                </a:rPr>
+                <a:t>最终组数不预先固定</a:t>
+              </a:r>
+            </a:p>
+          </p:txBody>
+        </p:sp>
+        <p:sp>
+          <p:nvSpPr>
+            <p:cNvPr id="19" name="SSD：在途数 + 片段数 n 复制：在途数 + 该卡请求数"/>
+            <p:cNvSpPr txBox="1"/>
+            <p:nvPr/>
+          </p:nvSpPr>
+          <p:spPr>
+            <a:xfrm>
+              <a:off x="2381250" y="3286125"/>
+              <a:ext cx="4171950" cy="533400"/>
+            </a:xfrm>
+            <a:prstGeom prst="rect">
+              <a:avLst/>
+            </a:prstGeom>
+            <a:noFill/>
+            <a:effectLst/>
+          </p:spPr>
+          <p:txBody>
+            <a:bodyPr wrap="square" lIns="0" rIns="0" tIns="0" bIns="0">
+              <a:spAutoFit/>
+            </a:bodyPr>
+            <a:lstStyle/>
+            <a:p>
+              <a:pPr algn="l">
+                <a:lnSpc>
+                  <a:spcPct val="112000"/>
+                </a:lnSpc>
+                <a:spcAft>
+                  <a:spcPts val="500"/>
+                </a:spcAft>
+              </a:pPr>
+              <a:r>
+                <a:rPr sz="1650" b="0" lang="zh-CN">
+                  <a:solidFill>
+                    <a:srgbClr val="1F2937"/>
+                  </a:solidFill>
+                  <a:latin typeface="Microsoft YaHei"/>
+                  <a:ea typeface="Microsoft YaHei"/>
+                </a:rPr>
+                <a:t>SSD：在途数 + 片段数 n</a:t>
+              </a:r>
+            </a:p>
+            <a:p>
+              <a:pPr algn="l">
+                <a:lnSpc>
+                  <a:spcPct val="112000"/>
+                </a:lnSpc>
+                <a:spcAft>
+                  <a:spcPts val="500"/>
+                </a:spcAft>
+              </a:pPr>
+              <a:r>
+                <a:rPr sz="1650" b="0" lang="zh-CN">
+                  <a:solidFill>
+                    <a:srgbClr val="1F2937"/>
+                  </a:solidFill>
+                  <a:latin typeface="Microsoft YaHei"/>
+                  <a:ea typeface="Microsoft YaHei"/>
+                </a:rPr>
+                <a:t>复制：在途数 + 该卡请求数</a:t>
+              </a:r>
+            </a:p>
+          </p:txBody>
+        </p:sp>
+        <p:sp>
+          <p:nvSpPr>
+            <p:cNvPr id="20" name="一份完整基础方案 提供各卡 / 复制类型的组数比例"/>
+            <p:cNvSpPr txBox="1"/>
+            <p:nvPr/>
+          </p:nvSpPr>
+          <p:spPr>
+            <a:xfrm>
+              <a:off x="2381250" y="3971925"/>
+              <a:ext cx="4171950" cy="485775"/>
+            </a:xfrm>
+            <a:prstGeom prst="rect">
+              <a:avLst/>
+            </a:prstGeom>
+            <a:noFill/>
+            <a:effectLst/>
+          </p:spPr>
+          <p:txBody>
+            <a:bodyPr wrap="square" lIns="0" rIns="0" tIns="0" bIns="0">
+              <a:spAutoFit/>
+            </a:bodyPr>
+            <a:lstStyle/>
+            <a:p>
+              <a:pPr algn="l">
+                <a:lnSpc>
+                  <a:spcPct val="112000"/>
+                </a:lnSpc>
+                <a:spcAft>
+                  <a:spcPts val="500"/>
+                </a:spcAft>
+              </a:pPr>
+              <a:r>
+                <a:rPr sz="1575" b="1" lang="zh-CN">
+                  <a:solidFill>
+                    <a:srgbClr val="285EA8"/>
+                  </a:solidFill>
+                  <a:latin typeface="Microsoft YaHei"/>
+                  <a:ea typeface="Microsoft YaHei"/>
+                </a:rPr>
+                <a:t>一份完整基础方案</a:t>
+              </a:r>
+            </a:p>
+            <a:p>
+              <a:pPr algn="l">
+                <a:lnSpc>
+                  <a:spcPct val="112000"/>
+                </a:lnSpc>
+                <a:spcAft>
+                  <a:spcPts val="500"/>
+                </a:spcAft>
+              </a:pPr>
+              <a:r>
+                <a:rPr sz="1575" b="1" lang="zh-CN">
+                  <a:solidFill>
+                    <a:srgbClr val="285EA8"/>
+                  </a:solidFill>
+                  <a:latin typeface="Microsoft YaHei"/>
+                  <a:ea typeface="Microsoft YaHei"/>
+                </a:rPr>
+                <a:t>提供各卡 / 复制类型的组数比例</a:t>
+              </a:r>
+            </a:p>
+          </p:txBody>
+        </p:sp>
+      </p:grpSp>
+      <p:grpSp>
+        <p:nvGrpSpPr>
+          <p:cNvPr id="21" name="步骤2：细化对多个 cnt 分别生成完整方案"/>
+          <p:cNvGrpSpPr/>
+          <p:nvPr/>
+        </p:nvGrpSpPr>
+        <p:grpSpPr>
+          <a:xfrm>
+            <a:off x="6896100" y="2152650"/>
+            <a:ext cx="4533900" cy="2305050"/>
+            <a:chOff x="6896100" y="2152650"/>
+            <a:chExt cx="4533900" cy="2305050"/>
+          </a:xfrm>
+        </p:grpSpPr>
+        <p:sp>
+          <p:nvSpPr>
+            <p:cNvPr id="22" name="细化 DP · 按条件执行"/>
+            <p:cNvSpPr txBox="1"/>
+            <p:nvPr/>
+          </p:nvSpPr>
+          <p:spPr>
+            <a:xfrm>
+              <a:off x="6896100" y="2152650"/>
+              <a:ext cx="4533900" cy="276225"/>
+            </a:xfrm>
+            <a:prstGeom prst="rect">
+              <a:avLst/>
+            </a:prstGeom>
+            <a:noFill/>
+            <a:effectLst/>
+          </p:spPr>
+          <p:txBody>
+            <a:bodyPr wrap="square" lIns="0" rIns="0" tIns="0" bIns="0">
+              <a:spAutoFit/>
+            </a:bodyPr>
+            <a:lstStyle/>
+            <a:p>
+              <a:pPr algn="l">
+                <a:lnSpc>
+                  <a:spcPct val="112000"/>
+                </a:lnSpc>
+                <a:spcAft>
+                  <a:spcPts val="500"/>
+                </a:spcAft>
+              </a:pPr>
+              <a:r>
+                <a:rPr sz="1725" b="1" lang="zh-CN">
+                  <a:solidFill>
+                    <a:srgbClr val="24756D"/>
+                  </a:solidFill>
+                  <a:latin typeface="Microsoft YaHei"/>
+                  <a:ea typeface="Microsoft YaHei"/>
+                </a:rPr>
+                <a:t>细化 DP · 按条件执行</a:t>
+              </a:r>
+            </a:p>
+          </p:txBody>
+        </p:sp>
+        <p:sp>
+          <p:nvSpPr>
+            <p:cNvPr id="23" name="D[h][j]：前 j 段恰好 h 组 对每个 cnt，要求最终 h = cnt"/>
+            <p:cNvSpPr txBox="1"/>
+            <p:nvPr/>
+          </p:nvSpPr>
+          <p:spPr>
+            <a:xfrm>
+              <a:off x="6896100" y="2619375"/>
+              <a:ext cx="4533900" cy="533400"/>
+            </a:xfrm>
+            <a:prstGeom prst="rect">
+              <a:avLst/>
+            </a:prstGeom>
+            <a:noFill/>
+            <a:effectLst/>
+          </p:spPr>
+          <p:txBody>
+            <a:bodyPr wrap="square" lIns="0" rIns="0" tIns="0" bIns="0">
+              <a:spAutoFit/>
+            </a:bodyPr>
+            <a:lstStyle/>
+            <a:p>
+              <a:pPr algn="l">
+                <a:lnSpc>
+                  <a:spcPct val="112000"/>
+                </a:lnSpc>
+                <a:spcAft>
+                  <a:spcPts val="500"/>
+                </a:spcAft>
+              </a:pPr>
+              <a:r>
+                <a:rPr sz="1650" b="0" lang="zh-CN">
+                  <a:solidFill>
+                    <a:srgbClr val="1F2937"/>
+                  </a:solidFill>
+                  <a:latin typeface="Microsoft YaHei"/>
+                  <a:ea typeface="Microsoft YaHei"/>
+                </a:rPr>
+                <a:t>D[h][j]：前 j 段恰好 h 组</a:t>
+              </a:r>
+            </a:p>
+            <a:p>
+              <a:pPr algn="l">
+                <a:lnSpc>
+                  <a:spcPct val="112000"/>
+                </a:lnSpc>
+                <a:spcAft>
+                  <a:spcPts val="500"/>
+                </a:spcAft>
+              </a:pPr>
+              <a:r>
+                <a:rPr sz="1650" b="0" lang="zh-CN">
+                  <a:solidFill>
+                    <a:srgbClr val="1F2937"/>
+                  </a:solidFill>
+                  <a:latin typeface="Microsoft YaHei"/>
+                  <a:ea typeface="Microsoft YaHei"/>
+                </a:rPr>
+                <a:t>对每个 cnt，要求最终 h = cnt</a:t>
+              </a:r>
+            </a:p>
+          </p:txBody>
+        </p:sp>
+        <p:sp>
+          <p:nvSpPr>
+            <p:cNvPr id="24" name="SSD：候选组数 cnt（入口空闲） 复制：按基础方案的卡 / 类型比例缩放"/>
+            <p:cNvSpPr txBox="1"/>
+            <p:nvPr/>
+          </p:nvSpPr>
+          <p:spPr>
+            <a:xfrm>
+              <a:off x="6896100" y="3286125"/>
+              <a:ext cx="4533900" cy="533400"/>
             </a:xfrm>
             <a:prstGeom prst="rect">
               <a:avLst/>
@@ -11549,7 +12148,7 @@
                   <a:latin typeface="Microsoft YaHei"/>
                   <a:ea typeface="Microsoft YaHei"/>
                 </a:rPr>
-                <a:t>联合选分组和路径</a:t>
+                <a:t>SSD：候选组数 cnt（入口空闲）</a:t>
               </a:r>
             </a:p>
             <a:p>
@@ -11569,7 +12168,71 @@
                   <a:latin typeface="Microsoft YaHei"/>
                   <a:ea typeface="Microsoft YaHei"/>
                 </a:rPr>
-                <a:t>同时得到各卡的复制路径占比</a:t>
+                <a:t>复制：按基础方案的卡 / 类型比例缩放</a:t>
+              </a:r>
+            </a:p>
+          </p:txBody>
+        </p:sp>
+        <p:sp>
+          <p:nvSpPr>
+            <p:cNvPr id="25" name="每个 cnt 至多一份合格方案 再从这些方案中选最低估价者"/>
+            <p:cNvSpPr txBox="1"/>
+            <p:nvPr/>
+          </p:nvSpPr>
+          <p:spPr>
+            <a:xfrm>
+              <a:off x="6896100" y="3971925"/>
+              <a:ext cx="4533900" cy="485775"/>
+            </a:xfrm>
+            <a:prstGeom prst="rect">
+              <a:avLst/>
+            </a:prstGeom>
+            <a:noFill/>
+            <a:effectLst/>
+          </p:spPr>
+          <p:txBody>
+            <a:bodyPr wrap="square" lIns="0" rIns="0" tIns="0" bIns="0">
+              <a:spAutoFit/>
+            </a:bodyPr>
+            <a:lstStyle/>
+            <a:p>
+              <a:pPr algn="l">
+                <a:lnSpc>
+                  <a:spcPct val="112000"/>
+                </a:lnSpc>
+                <a:spcAft>
+                  <a:spcPts val="500"/>
+                </a:spcAft>
+              </a:pPr>
+              <a:r>
+                <a:rPr sz="1575" b="1" lang="zh-CN">
+                  <a:solidFill>
+                    <a:srgbClr val="24756D"/>
+                  </a:solidFill>
+                  <a:latin typeface="Microsoft YaHei"/>
+                  <a:ea typeface="Microsoft YaHei"/>
+                </a:rPr>
+                <a:t>每个 cnt 至多一份合格方案</a:t>
+              </a:r>
+            </a:p>
+            <a:p>
+              <a:pPr algn="l">
+                <a:lnSpc>
+                  <a:spcPct val="112000"/>
+                </a:lnSpc>
+                <a:spcAft>
+                  <a:spcPts val="500"/>
+                </a:spcAft>
+              </a:pPr>
+              <a:r>
+                <a:rPr sz="1575" b="1" lang="zh-CN">
+                  <a:solidFill>
+                    <a:srgbClr val="24756D"/>
+                  </a:solidFill>
+                  <a:latin typeface="Microsoft YaHei"/>
+                  <a:ea typeface="Microsoft YaHei"/>
+                </a:rPr>
+                <a:t>再从这些方案中选最低估价者</a:t>
               </a:r>
             </a:p>
           </p:txBody>
@@ -11577,65 +12240,28 @@
       </p:grpSp>
       <p:grpSp>
         <p:nvGrpSpPr>
-          <p:cNvPr id="12" name="步骤2：沿用候选与基础方案统计，按需细化"/>
+          <p:cNvPr id="26" name="步骤3：明确细化入口和搜索规模边界"/>
           <p:cNvGrpSpPr/>
           <p:nvPr/>
         </p:nvGrpSpPr>
         <p:grpSpPr>
           <a:xfrm>
-            <a:off x="3829050" y="2076450"/>
-            <a:ext cx="3857624" cy="1114425"/>
-            <a:chOff x="3829050" y="2076450"/>
-            <a:chExt cx="3857624" cy="1114425"/>
+            <a:off x="609600" y="4619625"/>
+            <a:ext cx="10972800" cy="857250"/>
+            <a:chOff x="609600" y="4619625"/>
+            <a:chExt cx="10972800" cy="857250"/>
           </a:xfrm>
         </p:grpSpPr>
-        <p:cxnSp>
-          <p:nvCxnSpPr>
-            <p:cNvPr id="13" name="Connector 12"/>
-            <p:cNvCxnSpPr/>
-            <p:nvPr/>
-          </p:nvCxnSpPr>
-          <p:spPr>
-            <a:xfrm>
-              <a:off x="3829050" y="2609850"/>
-              <a:ext cx="238125" cy="0"/>
-            </a:xfrm>
-            <a:prstGeom prst="line">
-              <a:avLst/>
-            </a:prstGeom>
-            <a:ln w="20320">
-              <a:solidFill>
-                <a:srgbClr val="285EA8"/>
-              </a:solidFill>
-              <a:tailEnd type="triangle"/>
-            </a:ln>
-            <a:effectLst/>
-          </p:spPr>
-          <p:style>
-            <a:lnRef idx="2">
-              <a:schemeClr val="accent1"/>
-            </a:lnRef>
-            <a:fillRef idx="0">
-              <a:schemeClr val="accent1"/>
-            </a:fillRef>
-            <a:effectRef idx="0">
-              <a:schemeClr val="accent1"/>
-            </a:effectRef>
-            <a:fontRef idx="minor">
-              <a:schemeClr val="tx1"/>
-            </a:fontRef>
-          </p:style>
-        </p:cxnSp>
         <p:sp>
           <p:nvSpPr>
-            <p:cNvPr id="14" name="Rectangle 13"/>
+            <p:cNvPr id="27" name="Rectangle 26"/>
             <p:cNvSpPr/>
             <p:nvPr/>
           </p:nvSpPr>
           <p:spPr>
             <a:xfrm>
-              <a:off x="4190999" y="2076450"/>
-              <a:ext cx="3495675" cy="1114425"/>
+              <a:off x="609600" y="4619625"/>
+              <a:ext cx="10972800" cy="857250"/>
             </a:xfrm>
             <a:prstGeom prst="rect">
               <a:avLst/>
@@ -11672,14 +12298,14 @@
         </p:sp>
         <p:sp>
           <p:nvSpPr>
-            <p:cNvPr id="15" name="② 细化 DP：按组数重估"/>
+            <p:cNvPr id="28" name="空闲：无在途传输、排队、提升、占槽及旧未完成请求。"/>
             <p:cNvSpPr txBox="1"/>
             <p:nvPr/>
           </p:nvSpPr>
           <p:spPr>
             <a:xfrm>
-              <a:off x="4343400" y="2209800"/>
-              <a:ext cx="3190875" cy="285750"/>
+              <a:off x="762000" y="4695825"/>
+              <a:ext cx="10668000" cy="228600"/>
             </a:xfrm>
             <a:prstGeom prst="rect">
               <a:avLst/>
@@ -11702,28 +12328,28 @@
                 </a:spcAft>
               </a:pPr>
               <a:r>
-                <a:rPr sz="1800" b="1" lang="zh-CN">
+                <a:rPr sz="1500" b="1" lang="zh-CN">
                   <a:solidFill>
                     <a:srgbClr val="24756D"/>
                   </a:solidFill>
                   <a:latin typeface="Microsoft YaHei"/>
                   <a:ea typeface="Microsoft YaHei"/>
                 </a:rPr>
-                <a:t>② 细化 DP：按组数重估</a:t>
+                <a:t>空闲：无在途传输、排队、提升、占槽及旧未完成请求。</a:t>
               </a:r>
             </a:p>
           </p:txBody>
         </p:sp>
         <p:sp>
           <p:nvSpPr>
-            <p:cNvPr id="16" name="沿用候选，重估 SSD / 复制并发 重新选择分组和路径"/>
+            <p:cNvPr id="29" name="规模：请求 ≤1024，iov ≤2048，片段 ≤16384，基础方案操作 ≤2048。"/>
             <p:cNvSpPr txBox="1"/>
             <p:nvPr/>
           </p:nvSpPr>
           <p:spPr>
             <a:xfrm>
-              <a:off x="4343400" y="2619375"/>
-              <a:ext cx="3190875" cy="504825"/>
+              <a:off x="762000" y="4962525"/>
+              <a:ext cx="10668000" cy="228600"/>
             </a:xfrm>
             <a:prstGeom prst="rect">
               <a:avLst/>
@@ -11746,144 +12372,28 @@
                 </a:spcAft>
               </a:pPr>
               <a:r>
-                <a:rPr sz="1575" b="0" lang="zh-CN">
+                <a:rPr sz="1500" b="0" lang="zh-CN">
                   <a:solidFill>
                     <a:srgbClr val="1F2937"/>
                   </a:solidFill>
                   <a:latin typeface="Microsoft YaHei"/>
                   <a:ea typeface="Microsoft YaHei"/>
                 </a:rPr>
-                <a:t>沿用候选，重估 SSD / 复制并发</a:t>
+                <a:t>规模：请求 ≤1024，iov ≤2048，片段 ≤16384，基础方案操作 ≤2048。</a:t>
               </a:r>
-            </a:p>
-            <a:p>
-              <a:pPr algn="l">
-                <a:lnSpc>
-                  <a:spcPct val="112000"/>
-                </a:lnSpc>
-                <a:spcAft>
-                  <a:spcPts val="500"/>
-                </a:spcAft>
-              </a:pPr>
-              <a:r>
-                <a:rPr sz="1575" b="0" lang="zh-CN">
-                  <a:solidFill>
-                    <a:srgbClr val="1F2937"/>
-                  </a:solidFill>
-                  <a:latin typeface="Microsoft YaHei"/>
-                  <a:ea typeface="Microsoft YaHei"/>
-                </a:rPr>
-                <a:t>重新选择分组和路径</a:t>
-              </a:r>
-            </a:p>
-          </p:txBody>
-        </p:sp>
-      </p:grpSp>
-      <p:grpSp>
-        <p:nvGrpSpPr>
-          <p:cNvPr id="17" name="步骤3：按条件选择唯一的提交方案"/>
-          <p:cNvGrpSpPr/>
-          <p:nvPr/>
-        </p:nvGrpSpPr>
-        <p:grpSpPr>
-          <a:xfrm>
-            <a:off x="609600" y="2076450"/>
-            <a:ext cx="10972800" cy="1524000"/>
-            <a:chOff x="609600" y="2076450"/>
-            <a:chExt cx="10972800" cy="1524000"/>
-          </a:xfrm>
-        </p:grpSpPr>
-        <p:cxnSp>
-          <p:nvCxnSpPr>
-            <p:cNvPr id="18" name="Connector 17"/>
-            <p:cNvCxnSpPr/>
-            <p:nvPr/>
-          </p:nvCxnSpPr>
-          <p:spPr>
-            <a:xfrm>
-              <a:off x="7762875" y="2609850"/>
-              <a:ext cx="238125" cy="0"/>
-            </a:xfrm>
-            <a:prstGeom prst="line">
-              <a:avLst/>
-            </a:prstGeom>
-            <a:ln w="20320">
-              <a:solidFill>
-                <a:srgbClr val="285EA8"/>
-              </a:solidFill>
-              <a:tailEnd type="triangle"/>
-            </a:ln>
-            <a:effectLst/>
-          </p:spPr>
-          <p:style>
-            <a:lnRef idx="2">
-              <a:schemeClr val="accent1"/>
-            </a:lnRef>
-            <a:fillRef idx="0">
-              <a:schemeClr val="accent1"/>
-            </a:fillRef>
-            <a:effectRef idx="0">
-              <a:schemeClr val="accent1"/>
-            </a:effectRef>
-            <a:fontRef idx="minor">
-              <a:schemeClr val="tx1"/>
-            </a:fontRef>
-          </p:style>
-        </p:cxnSp>
-        <p:sp>
-          <p:nvSpPr>
-            <p:cNvPr id="19" name="Rectangle 18"/>
-            <p:cNvSpPr/>
-            <p:nvPr/>
-          </p:nvSpPr>
-          <p:spPr>
-            <a:xfrm>
-              <a:off x="8124824" y="2076450"/>
-              <a:ext cx="3457575" cy="1114425"/>
-            </a:xfrm>
-            <a:prstGeom prst="rect">
-              <a:avLst/>
-            </a:prstGeom>
-            <a:solidFill>
-              <a:srgbClr val="EDF3FA"/>
-            </a:solidFill>
-            <a:ln>
-              <a:noFill/>
-            </a:ln>
-            <a:effectLst/>
-          </p:spPr>
-          <p:style>
-            <a:lnRef idx="1">
-              <a:schemeClr val="accent1"/>
-            </a:lnRef>
-            <a:fillRef idx="3">
-              <a:schemeClr val="accent1"/>
-            </a:fillRef>
-            <a:effectRef idx="0">
-              <a:schemeClr val="accent1"/>
-            </a:effectRef>
-            <a:fontRef idx="minor">
-              <a:schemeClr val="lt1"/>
-            </a:fontRef>
-          </p:style>
-          <p:txBody>
-            <a:bodyPr rtlCol="0" anchor="ctr"/>
-            <a:lstStyle/>
-            <a:p>
-              <a:pPr algn="ctr"/>
             </a:p>
           </p:txBody>
         </p:sp>
         <p:sp>
           <p:nvSpPr>
-            <p:cNvPr id="20" name="③ 只提交一份最终方案"/>
+            <p:cNvPr id="30" name="搜索：每批 200 万估价 / 转移；合法边 ≤262144，单次存储状态 ≤131072。"/>
             <p:cNvSpPr txBox="1"/>
             <p:nvPr/>
           </p:nvSpPr>
           <p:spPr>
             <a:xfrm>
-              <a:off x="8277225" y="2209800"/>
-              <a:ext cx="3152775" cy="285750"/>
+              <a:off x="762000" y="5229225"/>
+              <a:ext cx="10668000" cy="219075"/>
             </a:xfrm>
             <a:prstGeom prst="rect">
               <a:avLst/>
@@ -11906,91 +12416,42 @@
                 </a:spcAft>
               </a:pPr>
               <a:r>
-                <a:rPr sz="1800" b="1" lang="zh-CN">
-                  <a:solidFill>
-                    <a:srgbClr val="285EA8"/>
-                  </a:solidFill>
-                  <a:latin typeface="Microsoft YaHei"/>
-                  <a:ea typeface="Microsoft YaHei"/>
-                </a:rPr>
-                <a:t>③ 只提交一份最终方案</a:t>
-              </a:r>
-            </a:p>
-          </p:txBody>
-        </p:sp>
-        <p:sp>
-          <p:nvSpPr>
-            <p:cNvPr id="21" name="有可用细化候选：选其最低估价 否则：保留基础方案"/>
-            <p:cNvSpPr txBox="1"/>
-            <p:nvPr/>
-          </p:nvSpPr>
-          <p:spPr>
-            <a:xfrm>
-              <a:off x="8277225" y="2619375"/>
-              <a:ext cx="3152775" cy="504825"/>
-            </a:xfrm>
-            <a:prstGeom prst="rect">
-              <a:avLst/>
-            </a:prstGeom>
-            <a:noFill/>
-            <a:effectLst/>
-          </p:spPr>
-          <p:txBody>
-            <a:bodyPr wrap="square" lIns="0" rIns="0" tIns="0" bIns="0">
-              <a:spAutoFit/>
-            </a:bodyPr>
-            <a:lstStyle/>
-            <a:p>
-              <a:pPr algn="l">
-                <a:lnSpc>
-                  <a:spcPct val="112000"/>
-                </a:lnSpc>
-                <a:spcAft>
-                  <a:spcPts val="500"/>
-                </a:spcAft>
-              </a:pPr>
-              <a:r>
-                <a:rPr sz="1575" b="0" lang="zh-CN">
+                <a:rPr sz="1425" b="0" lang="zh-CN">
                   <a:solidFill>
                     <a:srgbClr val="1F2937"/>
                   </a:solidFill>
                   <a:latin typeface="Microsoft YaHei"/>
                   <a:ea typeface="Microsoft YaHei"/>
                 </a:rPr>
-                <a:t>有可用细化候选：选其最低估价</a:t>
-              </a:r>
-            </a:p>
-            <a:p>
-              <a:pPr algn="l">
-                <a:lnSpc>
-                  <a:spcPct val="112000"/>
-                </a:lnSpc>
-                <a:spcAft>
-                  <a:spcPts val="500"/>
-                </a:spcAft>
-              </a:pPr>
-              <a:r>
-                <a:rPr sz="1575" b="0" lang="zh-CN">
-                  <a:solidFill>
-                    <a:srgbClr val="1F2937"/>
-                  </a:solidFill>
-                  <a:latin typeface="Microsoft YaHei"/>
-                  <a:ea typeface="Microsoft YaHei"/>
-                </a:rPr>
-                <a:t>否则：保留基础方案</a:t>
+                <a:t>搜索：每批 200 万估价 / 转移；合法边 ≤262144，单次存储状态 ≤131072。</a:t>
               </a:r>
             </a:p>
           </p:txBody>
         </p:sp>
+      </p:grpSp>
+      <p:grpSp>
+        <p:nvGrpSpPr>
+          <p:cNvPr id="31" name="步骤4：从合格候选中选择最终方案或保留基础方案"/>
+          <p:cNvGrpSpPr/>
+          <p:nvPr/>
+        </p:nvGrpSpPr>
+        <p:grpSpPr>
+          <a:xfrm>
+            <a:off x="609600" y="5610225"/>
+            <a:ext cx="10972800" cy="276225"/>
+            <a:chOff x="609600" y="5610225"/>
+            <a:chExt cx="10972800" cy="276225"/>
+          </a:xfrm>
+        </p:grpSpPr>
         <p:sp>
           <p:nvSpPr>
-            <p:cNvPr id="22" name="细化入口：系统空闲，规模与预算允许；候选回溯后，还须通过总槽位与池容量检查。"/>
+            <p:cNvPr id="32" name="选择：细化候选须通过总槽位与池容量检查；无可用候选，则提交快速 DP 的基础方案。"/>
             <p:cNvSpPr txBox="1"/>
             <p:nvPr/>
           </p:nvSpPr>
           <p:spPr>
             <a:xfrm>
-              <a:off x="609600" y="3324225"/>
+              <a:off x="609600" y="5610225"/>
               <a:ext cx="10972800" cy="276225"/>
             </a:xfrm>
             <a:prstGeom prst="rect">
@@ -12021,7 +12482,7 @@
                   <a:latin typeface="Microsoft YaHei"/>
                   <a:ea typeface="Microsoft YaHei"/>
                 </a:rPr>
-                <a:t>细化入口：系统空闲，规模与预算允许；候选回溯后，还须通过总槽位与池容量检查。</a:t>
+                <a:t>选择：细化候选须通过总槽位与池容量检查；无可用候选，则提交快速 DP 的基础方案。</a:t>
               </a:r>
             </a:p>
           </p:txBody>
@@ -12029,356 +12490,28 @@
       </p:grpSp>
       <p:grpSp>
         <p:nvGrpSpPr>
-          <p:cNvPr id="23" name="步骤4：同一个联合更新规则与三片段示例"/>
+          <p:cNvPr id="33" name="步骤5：同一输入在两阶段的输出示例"/>
           <p:cNvGrpSpPr/>
           <p:nvPr/>
         </p:nvGrpSpPr>
         <p:grpSpPr>
           <a:xfrm>
-            <a:off x="609600" y="3838575"/>
-            <a:ext cx="10972800" cy="1447800"/>
-            <a:chOff x="609600" y="3838575"/>
-            <a:chExt cx="10972800" cy="1447800"/>
+            <a:off x="609600" y="6000750"/>
+            <a:ext cx="10972800" cy="238125"/>
+            <a:chOff x="609600" y="6000750"/>
+            <a:chExt cx="10972800" cy="238125"/>
           </a:xfrm>
         </p:grpSpPr>
         <p:sp>
           <p:nvSpPr>
-            <p:cNvPr id="24" name="Rectangle 23"/>
-            <p:cNvSpPr/>
-            <p:nvPr/>
-          </p:nvSpPr>
-          <p:spPr>
-            <a:xfrm>
-              <a:off x="609600" y="3838575"/>
-              <a:ext cx="5238750" cy="1447800"/>
-            </a:xfrm>
-            <a:prstGeom prst="rect">
-              <a:avLst/>
-            </a:prstGeom>
-            <a:solidFill>
-              <a:srgbClr val="F5F7FA"/>
-            </a:solidFill>
-            <a:ln>
-              <a:noFill/>
-            </a:ln>
-            <a:effectLst/>
-          </p:spPr>
-          <p:style>
-            <a:lnRef idx="1">
-              <a:schemeClr val="accent1"/>
-            </a:lnRef>
-            <a:fillRef idx="3">
-              <a:schemeClr val="accent1"/>
-            </a:fillRef>
-            <a:effectRef idx="0">
-              <a:schemeClr val="accent1"/>
-            </a:effectRef>
-            <a:fontRef idx="minor">
-              <a:schemeClr val="lt1"/>
-            </a:fontRef>
-          </p:style>
-          <p:txBody>
-            <a:bodyPr rtlCol="0" anchor="ctr"/>
-            <a:lstStyle/>
-            <a:p>
-              <a:pPr algn="ctr"/>
-            </a:p>
-          </p:txBody>
-        </p:sp>
-        <p:sp>
-          <p:nvSpPr>
-            <p:cNvPr id="25" name="核心更新：每次同时选择边界 i 与路径 path"/>
+            <p:cNvPr id="34" name="例：3 × 512B，快速选 1 组 DIRECT；细化比较 1 / 2 / 3 组后仍选 1 组。官方 J = 6。"/>
             <p:cNvSpPr txBox="1"/>
             <p:nvPr/>
           </p:nvSpPr>
           <p:spPr>
             <a:xfrm>
-              <a:off x="781050" y="3962399"/>
-              <a:ext cx="4895850" cy="276225"/>
-            </a:xfrm>
-            <a:prstGeom prst="rect">
-              <a:avLst/>
-            </a:prstGeom>
-            <a:noFill/>
-            <a:effectLst/>
-          </p:spPr>
-          <p:txBody>
-            <a:bodyPr wrap="square" lIns="0" rIns="0" tIns="0" bIns="0">
-              <a:spAutoFit/>
-            </a:bodyPr>
-            <a:lstStyle/>
-            <a:p>
-              <a:pPr algn="l">
-                <a:lnSpc>
-                  <a:spcPct val="112000"/>
-                </a:lnSpc>
-                <a:spcAft>
-                  <a:spcPts val="500"/>
-                </a:spcAft>
-              </a:pPr>
-              <a:r>
-                <a:rPr sz="1650" b="1" lang="zh-CN">
-                  <a:solidFill>
-                    <a:srgbClr val="285EA8"/>
-                  </a:solidFill>
-                  <a:latin typeface="Microsoft YaHei"/>
-                  <a:ea typeface="Microsoft YaHei"/>
-                </a:rPr>
-                <a:t>核心更新：每次同时选择边界 i 与路径 path</a:t>
-              </a:r>
-            </a:p>
-          </p:txBody>
-        </p:sp>
-        <p:sp>
-          <p:nvSpPr>
-            <p:cNvPr id="26" name="dp[j] = min { dp[i] + E(i, j, path) }"/>
-            <p:cNvSpPr txBox="1"/>
-            <p:nvPr/>
-          </p:nvSpPr>
-          <p:spPr>
-            <a:xfrm>
-              <a:off x="781050" y="4343400"/>
-              <a:ext cx="4895850" cy="323850"/>
-            </a:xfrm>
-            <a:prstGeom prst="rect">
-              <a:avLst/>
-            </a:prstGeom>
-            <a:noFill/>
-            <a:effectLst/>
-          </p:spPr>
-          <p:txBody>
-            <a:bodyPr wrap="square" lIns="0" rIns="0" tIns="0" bIns="0">
-              <a:spAutoFit/>
-            </a:bodyPr>
-            <a:lstStyle/>
-            <a:p>
-              <a:pPr algn="l">
-                <a:lnSpc>
-                  <a:spcPct val="112000"/>
-                </a:lnSpc>
-                <a:spcAft>
-                  <a:spcPts val="500"/>
-                </a:spcAft>
-              </a:pPr>
-              <a:r>
-                <a:rPr sz="1875" b="1" lang="zh-CN">
-                  <a:solidFill>
-                    <a:srgbClr val="285EA8"/>
-                  </a:solidFill>
-                  <a:latin typeface="Microsoft YaHei"/>
-                  <a:ea typeface="Microsoft YaHei"/>
-                </a:rPr>
-                <a:t>dp[j] = min { dp[i] + E(i, j, path) }</a:t>
-              </a:r>
-            </a:p>
-          </p:txBody>
-        </p:sp>
-        <p:sp>
-          <p:nvSpPr>
-            <p:cNvPr id="27" name="记录前驱与路径；细化时增加已分组数 h， 用 D[h][j] 约束最终组数。"/>
-            <p:cNvSpPr txBox="1"/>
-            <p:nvPr/>
-          </p:nvSpPr>
-          <p:spPr>
-            <a:xfrm>
-              <a:off x="781050" y="4781550"/>
-              <a:ext cx="4895850" cy="409575"/>
-            </a:xfrm>
-            <a:prstGeom prst="rect">
-              <a:avLst/>
-            </a:prstGeom>
-            <a:noFill/>
-            <a:effectLst/>
-          </p:spPr>
-          <p:txBody>
-            <a:bodyPr wrap="square" lIns="0" rIns="0" tIns="0" bIns="0">
-              <a:spAutoFit/>
-            </a:bodyPr>
-            <a:lstStyle/>
-            <a:p>
-              <a:pPr algn="l">
-                <a:lnSpc>
-                  <a:spcPct val="112000"/>
-                </a:lnSpc>
-                <a:spcAft>
-                  <a:spcPts val="500"/>
-                </a:spcAft>
-              </a:pPr>
-              <a:r>
-                <a:rPr sz="1500" b="0" lang="zh-CN">
-                  <a:solidFill>
-                    <a:srgbClr val="1F2937"/>
-                  </a:solidFill>
-                  <a:latin typeface="Microsoft YaHei"/>
-                  <a:ea typeface="Microsoft YaHei"/>
-                </a:rPr>
-                <a:t>记录前驱与路径；细化时增加已分组数 h，</a:t>
-              </a:r>
-            </a:p>
-            <a:p>
-              <a:pPr algn="l">
-                <a:lnSpc>
-                  <a:spcPct val="112000"/>
-                </a:lnSpc>
-                <a:spcAft>
-                  <a:spcPts val="500"/>
-                </a:spcAft>
-              </a:pPr>
-              <a:r>
-                <a:rPr sz="1500" b="0" lang="zh-CN">
-                  <a:solidFill>
-                    <a:srgbClr val="1F2937"/>
-                  </a:solidFill>
-                  <a:latin typeface="Microsoft YaHei"/>
-                  <a:ea typeface="Microsoft YaHei"/>
-                </a:rPr>
-                <a:t>用 D[h][j] 约束最终组数。</a:t>
-              </a:r>
-            </a:p>
-          </p:txBody>
-        </p:sp>
-        <p:sp>
-          <p:nvSpPr>
-            <p:cNvPr id="28" name="同卡相邻片段：512B + 512B + 512B"/>
-            <p:cNvSpPr txBox="1"/>
-            <p:nvPr/>
-          </p:nvSpPr>
-          <p:spPr>
-            <a:xfrm>
-              <a:off x="6191250" y="3848099"/>
-              <a:ext cx="5391150" cy="276225"/>
-            </a:xfrm>
-            <a:prstGeom prst="rect">
-              <a:avLst/>
-            </a:prstGeom>
-            <a:noFill/>
-            <a:effectLst/>
-          </p:spPr>
-          <p:txBody>
-            <a:bodyPr wrap="square" lIns="0" rIns="0" tIns="0" bIns="0">
-              <a:spAutoFit/>
-            </a:bodyPr>
-            <a:lstStyle/>
-            <a:p>
-              <a:pPr algn="l">
-                <a:lnSpc>
-                  <a:spcPct val="112000"/>
-                </a:lnSpc>
-                <a:spcAft>
-                  <a:spcPts val="500"/>
-                </a:spcAft>
-              </a:pPr>
-              <a:r>
-                <a:rPr sz="1650" b="1" lang="zh-CN">
-                  <a:solidFill>
-                    <a:srgbClr val="1F2937"/>
-                  </a:solidFill>
-                  <a:latin typeface="Microsoft YaHei"/>
-                  <a:ea typeface="Microsoft YaHei"/>
-                </a:rPr>
-                <a:t>同卡相邻片段：512B + 512B + 512B</a:t>
-              </a:r>
-            </a:p>
-          </p:txBody>
-        </p:sp>
-        <p:sp>
-          <p:nvSpPr>
-            <p:cNvPr id="29" name="细化候选组数       1          2          3"/>
-            <p:cNvSpPr txBox="1"/>
-            <p:nvPr/>
-          </p:nvSpPr>
-          <p:spPr>
-            <a:xfrm>
-              <a:off x="6191250" y="4267200"/>
-              <a:ext cx="5391150" cy="238125"/>
-            </a:xfrm>
-            <a:prstGeom prst="rect">
-              <a:avLst/>
-            </a:prstGeom>
-            <a:noFill/>
-            <a:effectLst/>
-          </p:spPr>
-          <p:txBody>
-            <a:bodyPr wrap="square" lIns="0" rIns="0" tIns="0" bIns="0">
-              <a:spAutoFit/>
-            </a:bodyPr>
-            <a:lstStyle/>
-            <a:p>
-              <a:pPr algn="l">
-                <a:lnSpc>
-                  <a:spcPct val="112000"/>
-                </a:lnSpc>
-                <a:spcAft>
-                  <a:spcPts val="500"/>
-                </a:spcAft>
-              </a:pPr>
-              <a:r>
-                <a:rPr sz="1575" b="1" lang="zh-CN">
-                  <a:solidFill>
-                    <a:srgbClr val="24756D"/>
-                  </a:solidFill>
-                  <a:latin typeface="Microsoft YaHei"/>
-                  <a:ea typeface="Microsoft YaHei"/>
-                </a:rPr>
-                <a:t>细化候选组数       1          2          3</a:t>
-              </a:r>
-            </a:p>
-          </p:txBody>
-        </p:sp>
-        <p:sp>
-          <p:nvSpPr>
-            <p:cNvPr id="30" name="最低估价 E       5.406     7.406     9.406"/>
-            <p:cNvSpPr txBox="1"/>
-            <p:nvPr/>
-          </p:nvSpPr>
-          <p:spPr>
-            <a:xfrm>
-              <a:off x="6191250" y="4581525"/>
-              <a:ext cx="5391150" cy="238125"/>
-            </a:xfrm>
-            <a:prstGeom prst="rect">
-              <a:avLst/>
-            </a:prstGeom>
-            <a:noFill/>
-            <a:effectLst/>
-          </p:spPr>
-          <p:txBody>
-            <a:bodyPr wrap="square" lIns="0" rIns="0" tIns="0" bIns="0">
-              <a:spAutoFit/>
-            </a:bodyPr>
-            <a:lstStyle/>
-            <a:p>
-              <a:pPr algn="l">
-                <a:lnSpc>
-                  <a:spcPct val="112000"/>
-                </a:lnSpc>
-                <a:spcAft>
-                  <a:spcPts val="500"/>
-                </a:spcAft>
-              </a:pPr>
-              <a:r>
-                <a:rPr sz="1575" b="0" lang="zh-CN">
-                  <a:solidFill>
-                    <a:srgbClr val="1F2937"/>
-                  </a:solidFill>
-                  <a:latin typeface="Microsoft YaHei"/>
-                  <a:ea typeface="Microsoft YaHei"/>
-                </a:rPr>
-                <a:t>最低估价 E       5.406     7.406     9.406</a:t>
-              </a:r>
-            </a:p>
-          </p:txBody>
-        </p:sp>
-        <p:sp>
-          <p:nvSpPr>
-            <p:cNvPr id="31" name="本例：快速、细化均选 1 组 DIRECT。"/>
-            <p:cNvSpPr txBox="1"/>
-            <p:nvPr/>
-          </p:nvSpPr>
-          <p:spPr>
-            <a:xfrm>
-              <a:off x="6191250" y="4981575"/>
-              <a:ext cx="5391150" cy="247649"/>
+              <a:off x="609600" y="6000750"/>
+              <a:ext cx="10972800" cy="238125"/>
             </a:xfrm>
             <a:prstGeom prst="rect">
               <a:avLst/>
@@ -12408,159 +12541,12 @@
                   <a:latin typeface="Microsoft YaHei"/>
                   <a:ea typeface="Microsoft YaHei"/>
                 </a:rPr>
-                <a:t>本例：快速、细化均选 1 组 DIRECT。</a:t>
+                <a:t>例：3 × 512B，快速选 1 组 DIRECT；细化比较 1 / 2 / 3 组后仍选 1 组。官方 J = 6。</a:t>
               </a:r>
             </a:p>
           </p:txBody>
         </p:sp>
       </p:grpSp>
-      <p:grpSp>
-        <p:nvGrpSpPr>
-          <p:cNvPr id="32" name="步骤5：回溯映射并输出真实计划"/>
-          <p:cNvGrpSpPr/>
-          <p:nvPr/>
-        </p:nvGrpSpPr>
-        <p:grpSpPr>
-          <a:xfrm>
-            <a:off x="609600" y="5505450"/>
-            <a:ext cx="10972800" cy="504825"/>
-            <a:chOff x="609600" y="5505450"/>
-            <a:chExt cx="10972800" cy="504825"/>
-          </a:xfrm>
-        </p:grpSpPr>
-        <p:sp>
-          <p:nvSpPr>
-            <p:cNvPr id="33" name="Rectangle 32"/>
-            <p:cNvSpPr/>
-            <p:nvPr/>
-          </p:nvSpPr>
-          <p:spPr>
-            <a:xfrm>
-              <a:off x="609600" y="5505450"/>
-              <a:ext cx="10972800" cy="504825"/>
-            </a:xfrm>
-            <a:prstGeom prst="rect">
-              <a:avLst/>
-            </a:prstGeom>
-            <a:solidFill>
-              <a:srgbClr val="EDF3FA"/>
-            </a:solidFill>
-            <a:ln>
-              <a:noFill/>
-            </a:ln>
-            <a:effectLst/>
-          </p:spPr>
-          <p:style>
-            <a:lnRef idx="1">
-              <a:schemeClr val="accent1"/>
-            </a:lnRef>
-            <a:fillRef idx="3">
-              <a:schemeClr val="accent1"/>
-            </a:fillRef>
-            <a:effectRef idx="0">
-              <a:schemeClr val="accent1"/>
-            </a:effectRef>
-            <a:fontRef idx="minor">
-              <a:schemeClr val="lt1"/>
-            </a:fontRef>
-          </p:style>
-          <p:txBody>
-            <a:bodyPr rtlCol="0" anchor="ctr"/>
-            <a:lstStyle/>
-            <a:p>
-              <a:pPr algn="ctr"/>
-            </a:p>
-          </p:txBody>
-        </p:sp>
-        <p:sp>
-          <p:nvSpPr>
-            <p:cNvPr id="34" name="最终：1 组 DIRECT 读 1536B；官方 J = 6，分别读取 J = 10，成本降低 40%。"/>
-            <p:cNvSpPr txBox="1"/>
-            <p:nvPr/>
-          </p:nvSpPr>
-          <p:spPr>
-            <a:xfrm>
-              <a:off x="781050" y="5619750"/>
-              <a:ext cx="10629900" cy="295275"/>
-            </a:xfrm>
-            <a:prstGeom prst="rect">
-              <a:avLst/>
-            </a:prstGeom>
-            <a:noFill/>
-            <a:effectLst/>
-          </p:spPr>
-          <p:txBody>
-            <a:bodyPr wrap="square" lIns="0" rIns="0" tIns="0" bIns="0">
-              <a:spAutoFit/>
-            </a:bodyPr>
-            <a:lstStyle/>
-            <a:p>
-              <a:pPr algn="l">
-                <a:lnSpc>
-                  <a:spcPct val="112000"/>
-                </a:lnSpc>
-                <a:spcAft>
-                  <a:spcPts val="500"/>
-                </a:spcAft>
-              </a:pPr>
-              <a:r>
-                <a:rPr sz="1875" b="1" lang="zh-CN">
-                  <a:solidFill>
-                    <a:srgbClr val="285EA8"/>
-                  </a:solidFill>
-                  <a:latin typeface="Microsoft YaHei"/>
-                  <a:ea typeface="Microsoft YaHei"/>
-                </a:rPr>
-                <a:t>最终：1 组 DIRECT 读 1536B；官方 J = 6，分别读取 J = 10，成本降低 40%。</a:t>
-              </a:r>
-            </a:p>
-          </p:txBody>
-        </p:sp>
-      </p:grpSp>
-      <p:sp>
-        <p:nvSpPr>
-          <p:cNvPr id="35" name="E 是候选排序估价；全过程使用公开性能表，策略内部不执行模拟器。"/>
-          <p:cNvSpPr txBox="1"/>
-          <p:nvPr/>
-        </p:nvSpPr>
-        <p:spPr>
-          <a:xfrm>
-            <a:off x="609600" y="6076950"/>
-            <a:ext cx="10972800" cy="171450"/>
-          </a:xfrm>
-          <a:prstGeom prst="rect">
-            <a:avLst/>
-          </a:prstGeom>
-          <a:noFill/>
-          <a:effectLst/>
-        </p:spPr>
-        <p:txBody>
-          <a:bodyPr wrap="square" lIns="0" rIns="0" tIns="0" bIns="0">
-            <a:spAutoFit/>
-          </a:bodyPr>
-          <a:lstStyle/>
-          <a:p>
-            <a:pPr algn="l">
-              <a:lnSpc>
-                <a:spcPct val="112000"/>
-              </a:lnSpc>
-              <a:spcAft>
-                <a:spcPts val="500"/>
-              </a:spcAft>
-            </a:pPr>
-            <a:r>
-              <a:rPr sz="1200" b="0" lang="zh-CN">
-                <a:solidFill>
-                  <a:srgbClr val="657184"/>
-                </a:solidFill>
-                <a:latin typeface="Microsoft YaHei"/>
-                <a:ea typeface="Microsoft YaHei"/>
-              </a:rPr>
-              <a:t>E 是候选排序估价；全过程使用公开性能表，策略内部不执行模拟器。</a:t>
-            </a:r>
-          </a:p>
-        </p:txBody>
-      </p:sp>
     </p:spTree>
   </p:cSld>
   <p:clrMapOvr>
@@ -12600,7 +12586,7 @@
                                           </p:stCondLst>
                                         </p:cTn>
                                         <p:tgtEl>
-                                          <p:spTgt spid="8"/>
+                                          <p:spTgt spid="16"/>
                                         </p:tgtEl>
                                         <p:attrNameLst>
                                           <p:attrName>style.visibility</p:attrName>
@@ -12614,7 +12600,7 @@
                                       <p:cBhvr>
                                         <p:cTn id="7" dur="280"/>
                                         <p:tgtEl>
-                                          <p:spTgt spid="8"/>
+                                          <p:spTgt spid="16"/>
                                         </p:tgtEl>
                                       </p:cBhvr>
                                     </p:animEffect>
@@ -12653,7 +12639,7 @@
                                           </p:stCondLst>
                                         </p:cTn>
                                         <p:tgtEl>
-                                          <p:spTgt spid="12"/>
+                                          <p:spTgt spid="21"/>
                                         </p:tgtEl>
                                         <p:attrNameLst>
                                           <p:attrName>style.visibility</p:attrName>
@@ -12667,7 +12653,7 @@
                                       <p:cBhvr>
                                         <p:cTn id="12" dur="280"/>
                                         <p:tgtEl>
-                                          <p:spTgt spid="12"/>
+                                          <p:spTgt spid="21"/>
                                         </p:tgtEl>
                                       </p:cBhvr>
                                     </p:animEffect>
@@ -12706,7 +12692,7 @@
                                           </p:stCondLst>
                                         </p:cTn>
                                         <p:tgtEl>
-                                          <p:spTgt spid="17"/>
+                                          <p:spTgt spid="26"/>
                                         </p:tgtEl>
                                         <p:attrNameLst>
                                           <p:attrName>style.visibility</p:attrName>
@@ -12720,7 +12706,7 @@
                                       <p:cBhvr>
                                         <p:cTn id="17" dur="280"/>
                                         <p:tgtEl>
-                                          <p:spTgt spid="17"/>
+                                          <p:spTgt spid="26"/>
                                         </p:tgtEl>
                                       </p:cBhvr>
                                     </p:animEffect>
@@ -12759,7 +12745,7 @@
                                           </p:stCondLst>
                                         </p:cTn>
                                         <p:tgtEl>
-                                          <p:spTgt spid="23"/>
+                                          <p:spTgt spid="31"/>
                                         </p:tgtEl>
                                         <p:attrNameLst>
                                           <p:attrName>style.visibility</p:attrName>
@@ -12773,7 +12759,7 @@
                                       <p:cBhvr>
                                         <p:cTn id="22" dur="280"/>
                                         <p:tgtEl>
-                                          <p:spTgt spid="23"/>
+                                          <p:spTgt spid="31"/>
                                         </p:tgtEl>
                                       </p:cBhvr>
                                     </p:animEffect>
@@ -12812,7 +12798,7 @@
                                           </p:stCondLst>
                                         </p:cTn>
                                         <p:tgtEl>
-                                          <p:spTgt spid="32"/>
+                                          <p:spTgt spid="33"/>
                                         </p:tgtEl>
                                         <p:attrNameLst>
                                           <p:attrName>style.visibility</p:attrName>
@@ -12826,7 +12812,7 @@
                                       <p:cBhvr>
                                         <p:cTn id="27" dur="280"/>
                                         <p:tgtEl>
-                                          <p:spTgt spid="32"/>
+                                          <p:spTgt spid="33"/>
                                         </p:tgtEl>
                                       </p:cBhvr>
                                     </p:animEffect>
@@ -17793,7 +17779,7 @@
       </p:sp>
       <p:sp>
         <p:nvSpPr>
-          <p:cNvPr id="35" name="R / A = 在途提升 / 活动传输数；H / U = 历史记录 / 未完成请求数（历史含更新队列）。 预算不覆盖全部预检查、输入与输出开销；输入索引和未完成请求增长时，总内存仍会增长。"/>
+          <p:cNvPr id="35" name="R / A = 在途提升 / 活动传输数；H / U = 历史记录 / 未完成请求数（历史含更新队列）。 总空间计入输入索引、活动请求和输出映射；搜索预算约束细化 DP 的估价与转移。"/>
           <p:cNvSpPr txBox="1"/>
           <p:nvPr/>
         </p:nvSpPr>
@@ -17850,7 +17836,7 @@
                 <a:latin typeface="Microsoft YaHei"/>
                 <a:ea typeface="Microsoft YaHei"/>
               </a:rPr>
-              <a:t>预算不覆盖全部预检查、输入与输出开销；输入索引和未完成请求增长时，总内存仍会增长。</a:t>
+              <a:t>总空间计入输入索引、活动请求和输出映射；搜索预算约束细化 DP 的估价与转移。</a:t>
             </a:r>
           </a:p>
         </p:txBody>
@@ -17927,7 +17913,7 @@
       </p:sp>
       <p:sp>
         <p:nvSpPr>
-          <p:cNvPr id="3" name="多投入 0.322s 策略计算，进程总耗时下降 14.4%"/>
+          <p:cNvPr id="3" name="进程总耗时下降 14.4%，RSS 峰值下降 33.3%"/>
           <p:cNvSpPr txBox="1"/>
           <p:nvPr/>
         </p:nvSpPr>
@@ -17964,7 +17950,7 @@
                 <a:latin typeface="Microsoft YaHei"/>
                 <a:ea typeface="Microsoft YaHei"/>
               </a:rPr>
-              <a:t>多投入 0.322s 策略计算，进程总耗时下降 14.4%</a:t>
+              <a:t>进程总耗时下降 14.4%，RSS 峰值下降 33.3%</a:t>
             </a:r>
           </a:p>
         </p:txBody>
@@ -18623,7 +18609,7 @@
       </p:sp>
       <p:sp>
         <p:nvSpPr>
-          <p:cNvPr id="19" name="增加 0.322s，约 +38.7%"/>
+          <p:cNvPr id="19" name="单独计量两个策略回调"/>
           <p:cNvSpPr txBox="1"/>
           <p:nvPr/>
         </p:nvSpPr>
@@ -18660,7 +18646,7 @@
                 <a:latin typeface="Microsoft YaHei"/>
                 <a:ea typeface="Microsoft YaHei"/>
               </a:rPr>
-              <a:t>增加 0.322s，约 +38.7%</a:t>
+              <a:t>单独计量两个策略回调</a:t>
             </a:r>
           </a:p>
         </p:txBody>
@@ -19339,7 +19325,7 @@
       </p:cxnSp>
       <p:sp>
         <p:nvSpPr>
-          <p:cNvPr id="36" name="策略堆峰值 12.34MiB，进程 RSS 下降 33.3%；策略计算增加，整体执行仍更省时。"/>
+          <p:cNvPr id="36" name="策略堆峰值 12.34MiB；策略决策、框架执行和输入输出分别计量，便于复现。"/>
           <p:cNvSpPr txBox="1"/>
           <p:nvPr/>
         </p:nvSpPr>
@@ -19376,7 +19362,7 @@
                 <a:latin typeface="Microsoft YaHei"/>
                 <a:ea typeface="Microsoft YaHei"/>
               </a:rPr>
-              <a:t>策略堆峰值 12.34MiB，进程 RSS 下降 33.3%；策略计算增加，整体执行仍更省时。</a:t>
+              <a:t>策略堆峰值 12.34MiB；策略决策、框架执行和输入输出分别计量，便于复现。</a:t>
             </a:r>
           </a:p>
         </p:txBody>

</xml_diff>

<commit_message>
docs: distinguish DP transitions from candidate set maintenance
Signed-off-by: KaisennHu <74917084+KaisennHu@users.noreply.github.com>
</commit_message>
<xml_diff>
--- a/submissions/kaisennhu/07_答辩PPT/答辩介绍.pptx
+++ b/submissions/kaisennhu/07_答辩PPT/答辩介绍.pptx
@@ -1142,7 +1142,7 @@
           <a:lstStyle/>
           <a:p>
             <a:r>
-              <a:t>Vmax为单个请求最多iov数，L为最终片段与目标iov的有效交集数。快速DP每个起点至多扩展W个片段，每组比较三条路径；维护std::set的所有者集合带log W因子，因此仅这一核心的保守界为O(nW log(W+1))。固定cnt时DP状态至多cnt*n，每状态看至多3W条边；若无采样和预算约束，全枚举cnt=1..n的核心转移上界可达O(n^3 W)。实现使用采样，单次状态上限131072、合法边上限262144，估价和转移每批共享2000000预算。状态/边预检查以及回溯后的所有者和缓冲检查另计。复制估价按卡维护映射，也有集合访问成本。后台若有R个在途提升和A个活动传输，同步约O(R log(R+1))，还扫描A项、查history和未完成请求map；不逐次扫描全部缓存。history_queue最多131072条更新记录，未完成Work及输入输出不受这一常数限制。这里按模块分析，没有把整个策略概括为O(nW)。</a:t>
+              <a:t>Vmax为单个请求最多iov数，L为最终片段与目标iov的有效交集数。候选组枚举与快速DP状态更新在同一段循环中交织执行，这里按开销来源分列，并非代码先枚举完整候选表再做快速DP。每个起点至多扩展W个片段，每组比较三条路径，每条边的DP更新为常数时间，因此快速DP核心转移为O(nW)。候选组每扩展一个片段，要把请求编号插入std::set owners；集合大小最多min(W,请求数)，单次插入最坏O(log(W+1))，故候选维护为O(nW log(W+1))。两项相加，含集合维护的枚举和快速规划为O(nW log(W+1))，不是DP转移本身有额外一层循环。W固定128时，这两项都随n线性增长，排序O(n log n)另计；按卡状态map查询另计。固定cnt时DP状态至多cnt*n，每状态看至多3W条边；若无采样和预算约束，全枚举cnt=1..n的核心转移上界可达O(n^3 W)。实现使用采样，单次状态上限131072、合法边上限262144，估价和转移每批共享2000000预算。状态/边预检查以及回溯后的所有者和缓冲检查另计。复制估价按卡维护映射，也有集合访问成本。后台若有R个在途提升和A个活动传输，同步约O(R log(R+1))，还扫描A项、查history和未完成请求map；不逐次扫描全部缓存。history_queue最多131072条更新记录，未完成Work及输入输出不受这一常数限制。这里按模块分析，没有把整个策略概括为O(nW)。</a:t>
             </a:r>
           </a:p>
         </p:txBody>
@@ -16675,7 +16675,7 @@
       </p:sp>
       <p:sp>
         <p:nvSpPr>
-          <p:cNvPr id="9" name="阶段"/>
+          <p:cNvPr id="9" name="开销项"/>
           <p:cNvSpPr txBox="1"/>
           <p:nvPr/>
         </p:nvSpPr>
@@ -16712,7 +16712,7 @@
                 <a:latin typeface="Microsoft YaHei"/>
                 <a:ea typeface="Microsoft YaHei"/>
               </a:rPr>
-              <a:t>阶段</a:t>
+              <a:t>开销项</a:t>
             </a:r>
           </a:p>
         </p:txBody>
@@ -16901,8 +16901,8 @@
         </p:nvSpPr>
         <p:spPr>
           <a:xfrm>
-            <a:off x="742950" y="2724150"/>
-            <a:ext cx="2000250" cy="304800"/>
+            <a:off x="742950" y="2676525"/>
+            <a:ext cx="2000250" cy="276225"/>
           </a:xfrm>
           <a:prstGeom prst="rect">
             <a:avLst/>
@@ -16925,7 +16925,7 @@
               </a:spcAft>
             </a:pPr>
             <a:r>
-              <a:rPr sz="1500" b="1" lang="zh-CN">
+              <a:rPr sz="1425" b="1" lang="zh-CN">
                 <a:solidFill>
                   <a:srgbClr val="1F2937"/>
                 </a:solidFill>
@@ -16945,8 +16945,8 @@
         </p:nvSpPr>
         <p:spPr>
           <a:xfrm>
-            <a:off x="3009900" y="2724150"/>
-            <a:ext cx="4067175" cy="304800"/>
+            <a:off x="3009900" y="2676525"/>
+            <a:ext cx="4067175" cy="276225"/>
           </a:xfrm>
           <a:prstGeom prst="rect">
             <a:avLst/>
@@ -16969,7 +16969,7 @@
               </a:spcAft>
             </a:pPr>
             <a:r>
-              <a:rPr sz="1500" b="0" lang="zh-CN">
+              <a:rPr sz="1425" b="0" lang="zh-CN">
                 <a:solidFill>
                   <a:srgbClr val="1F2937"/>
                 </a:solidFill>
@@ -16989,8 +16989,8 @@
         </p:nvSpPr>
         <p:spPr>
           <a:xfrm>
-            <a:off x="7343775" y="2724150"/>
-            <a:ext cx="4105274" cy="304800"/>
+            <a:off x="7343775" y="2676525"/>
+            <a:ext cx="4105274" cy="276225"/>
           </a:xfrm>
           <a:prstGeom prst="rect">
             <a:avLst/>
@@ -17013,7 +17013,7 @@
               </a:spcAft>
             </a:pPr>
             <a:r>
-              <a:rPr sz="1500" b="0" lang="zh-CN">
+              <a:rPr sz="1425" b="0" lang="zh-CN">
                 <a:solidFill>
                   <a:srgbClr val="1F2937"/>
                 </a:solidFill>
@@ -17033,7 +17033,7 @@
         </p:nvCxnSpPr>
         <p:spPr>
           <a:xfrm>
-            <a:off x="609600" y="3067050"/>
+            <a:off x="609600" y="2981325"/>
             <a:ext cx="10972800" cy="0"/>
           </a:xfrm>
           <a:prstGeom prst="line">
@@ -17063,14 +17063,14 @@
       </p:cxnSp>
       <p:sp>
         <p:nvSpPr>
-          <p:cNvPr id="18" name="快速区间 DP"/>
+          <p:cNvPr id="18" name="候选组枚举"/>
           <p:cNvSpPr txBox="1"/>
           <p:nvPr/>
         </p:nvSpPr>
         <p:spPr>
           <a:xfrm>
-            <a:off x="742950" y="3181350"/>
-            <a:ext cx="2000250" cy="304800"/>
+            <a:off x="742950" y="3076575"/>
+            <a:ext cx="2000250" cy="276225"/>
           </a:xfrm>
           <a:prstGeom prst="rect">
             <a:avLst/>
@@ -17093,28 +17093,28 @@
               </a:spcAft>
             </a:pPr>
             <a:r>
-              <a:rPr sz="1500" b="1" lang="zh-CN">
+              <a:rPr sz="1425" b="1" lang="zh-CN">
                 <a:solidFill>
                   <a:srgbClr val="1F2937"/>
                 </a:solidFill>
                 <a:latin typeface="Microsoft YaHei"/>
                 <a:ea typeface="Microsoft YaHei"/>
               </a:rPr>
-              <a:t>快速区间 DP</a:t>
-            </a:r>
-          </a:p>
-        </p:txBody>
-      </p:sp>
-      <p:sp>
-        <p:nvSpPr>
-          <p:cNvPr id="19" name="O(nW log(W+1))：含所有者集合维护"/>
+              <a:t>候选组枚举</a:t>
+            </a:r>
+          </a:p>
+        </p:txBody>
+      </p:sp>
+      <p:sp>
+        <p:nvSpPr>
+          <p:cNvPr id="19" name="O(nW log(W+1))：含 owners 集合插入"/>
           <p:cNvSpPr txBox="1"/>
           <p:nvPr/>
         </p:nvSpPr>
         <p:spPr>
           <a:xfrm>
-            <a:off x="3009900" y="3181350"/>
-            <a:ext cx="4067175" cy="304800"/>
+            <a:off x="3009900" y="3076575"/>
+            <a:ext cx="4067175" cy="276225"/>
           </a:xfrm>
           <a:prstGeom prst="rect">
             <a:avLst/>
@@ -17137,28 +17137,28 @@
               </a:spcAft>
             </a:pPr>
             <a:r>
-              <a:rPr sz="1500" b="0" lang="zh-CN">
+              <a:rPr sz="1425" b="0" lang="zh-CN">
                 <a:solidFill>
                   <a:srgbClr val="1F2937"/>
                 </a:solidFill>
                 <a:latin typeface="Microsoft YaHei"/>
                 <a:ea typeface="Microsoft YaHei"/>
               </a:rPr>
-              <a:t>O(nW log(W+1))：含所有者集合维护</a:t>
-            </a:r>
-          </a:p>
-        </p:txBody>
-      </p:sp>
-      <p:sp>
-        <p:nvSpPr>
-          <p:cNvPr id="20" name="dp / prev / paths 为 O(n)"/>
+              <a:t>O(nW log(W+1))：含 owners 集合插入</a:t>
+            </a:r>
+          </a:p>
+        </p:txBody>
+      </p:sp>
+      <p:sp>
+        <p:nvSpPr>
+          <p:cNvPr id="20" name="owners 临时空间 O(W)"/>
           <p:cNvSpPr txBox="1"/>
           <p:nvPr/>
         </p:nvSpPr>
         <p:spPr>
           <a:xfrm>
-            <a:off x="7343775" y="3181350"/>
-            <a:ext cx="4105274" cy="304800"/>
+            <a:off x="7343775" y="3076575"/>
+            <a:ext cx="4105274" cy="276225"/>
           </a:xfrm>
           <a:prstGeom prst="rect">
             <a:avLst/>
@@ -17181,14 +17181,14 @@
               </a:spcAft>
             </a:pPr>
             <a:r>
-              <a:rPr sz="1500" b="0" lang="zh-CN">
+              <a:rPr sz="1425" b="0" lang="zh-CN">
                 <a:solidFill>
                   <a:srgbClr val="1F2937"/>
                 </a:solidFill>
                 <a:latin typeface="Microsoft YaHei"/>
                 <a:ea typeface="Microsoft YaHei"/>
               </a:rPr>
-              <a:t>dp / prev / paths 为 O(n)</a:t>
+              <a:t>owners 临时空间 O(W)</a:t>
             </a:r>
           </a:p>
         </p:txBody>
@@ -17201,7 +17201,7 @@
         </p:nvCxnSpPr>
         <p:spPr>
           <a:xfrm>
-            <a:off x="609600" y="3524250"/>
+            <a:off x="609600" y="3381375"/>
             <a:ext cx="10972800" cy="0"/>
           </a:xfrm>
           <a:prstGeom prst="line">
@@ -17231,14 +17231,14 @@
       </p:cxnSp>
       <p:sp>
         <p:nvSpPr>
-          <p:cNvPr id="22" name="细化 DP（固定 cnt）"/>
+          <p:cNvPr id="22" name="快速 DP 转移"/>
           <p:cNvSpPr txBox="1"/>
           <p:nvPr/>
         </p:nvSpPr>
         <p:spPr>
           <a:xfrm>
-            <a:off x="742950" y="3638550"/>
-            <a:ext cx="2000250" cy="304800"/>
+            <a:off x="742950" y="3476625"/>
+            <a:ext cx="2000250" cy="276225"/>
           </a:xfrm>
           <a:prstGeom prst="rect">
             <a:avLst/>
@@ -17261,28 +17261,28 @@
               </a:spcAft>
             </a:pPr>
             <a:r>
-              <a:rPr sz="1500" b="1" lang="zh-CN">
+              <a:rPr sz="1425" b="1" lang="zh-CN">
                 <a:solidFill>
                   <a:srgbClr val="1F2937"/>
                 </a:solidFill>
                 <a:latin typeface="Microsoft YaHei"/>
                 <a:ea typeface="Microsoft YaHei"/>
               </a:rPr>
-              <a:t>细化 DP（固定 cnt）</a:t>
-            </a:r>
-          </a:p>
-        </p:txBody>
-      </p:sp>
-      <p:sp>
-        <p:nvSpPr>
-          <p:cNvPr id="23" name="最坏 O(cnt × n × W)"/>
+              <a:t>快速 DP 转移</a:t>
+            </a:r>
+          </a:p>
+        </p:txBody>
+      </p:sp>
+      <p:sp>
+        <p:nvSpPr>
+          <p:cNvPr id="23" name="O(nW)：每组比较 3 条路径"/>
           <p:cNvSpPr txBox="1"/>
           <p:nvPr/>
         </p:nvSpPr>
         <p:spPr>
           <a:xfrm>
-            <a:off x="3009900" y="3638550"/>
-            <a:ext cx="4067175" cy="304800"/>
+            <a:off x="3009900" y="3476625"/>
+            <a:ext cx="4067175" cy="276225"/>
           </a:xfrm>
           <a:prstGeom prst="rect">
             <a:avLst/>
@@ -17305,28 +17305,28 @@
               </a:spcAft>
             </a:pPr>
             <a:r>
-              <a:rPr sz="1500" b="0" lang="zh-CN">
+              <a:rPr sz="1425" b="0" lang="zh-CN">
                 <a:solidFill>
                   <a:srgbClr val="1F2937"/>
                 </a:solidFill>
                 <a:latin typeface="Microsoft YaHei"/>
                 <a:ea typeface="Microsoft YaHei"/>
               </a:rPr>
-              <a:t>最坏 O(cnt × n × W)</a:t>
-            </a:r>
-          </a:p>
-        </p:txBody>
-      </p:sp>
-      <p:sp>
-        <p:nvSpPr>
-          <p:cNvPr id="24" name="状态 O(cnt × n)，合法边 O(nW)"/>
+              <a:t>O(nW)：每组比较 3 条路径</a:t>
+            </a:r>
+          </a:p>
+        </p:txBody>
+      </p:sp>
+      <p:sp>
+        <p:nvSpPr>
+          <p:cNvPr id="24" name="dp / prev / paths 为 O(n)"/>
           <p:cNvSpPr txBox="1"/>
           <p:nvPr/>
         </p:nvSpPr>
         <p:spPr>
           <a:xfrm>
-            <a:off x="7343775" y="3638550"/>
-            <a:ext cx="4105274" cy="304800"/>
+            <a:off x="7343775" y="3476625"/>
+            <a:ext cx="4105274" cy="276225"/>
           </a:xfrm>
           <a:prstGeom prst="rect">
             <a:avLst/>
@@ -17349,14 +17349,14 @@
               </a:spcAft>
             </a:pPr>
             <a:r>
-              <a:rPr sz="1500" b="0" lang="zh-CN">
+              <a:rPr sz="1425" b="0" lang="zh-CN">
                 <a:solidFill>
                   <a:srgbClr val="1F2937"/>
                 </a:solidFill>
                 <a:latin typeface="Microsoft YaHei"/>
                 <a:ea typeface="Microsoft YaHei"/>
               </a:rPr>
-              <a:t>状态 O(cnt × n)，合法边 O(nW)</a:t>
+              <a:t>dp / prev / paths 为 O(n)</a:t>
             </a:r>
           </a:p>
         </p:txBody>
@@ -17369,7 +17369,7 @@
         </p:nvCxnSpPr>
         <p:spPr>
           <a:xfrm>
-            <a:off x="609600" y="3981450"/>
+            <a:off x="609600" y="3781425"/>
             <a:ext cx="10972800" cy="0"/>
           </a:xfrm>
           <a:prstGeom prst="line">
@@ -17399,14 +17399,14 @@
       </p:cxnSp>
       <p:sp>
         <p:nvSpPr>
-          <p:cNvPr id="26" name="映射与输出"/>
+          <p:cNvPr id="26" name="细化 DP（固定 cnt）"/>
           <p:cNvSpPr txBox="1"/>
           <p:nvPr/>
         </p:nvSpPr>
         <p:spPr>
           <a:xfrm>
-            <a:off x="742950" y="4095750"/>
-            <a:ext cx="2000250" cy="304800"/>
+            <a:off x="742950" y="3876674"/>
+            <a:ext cx="2000250" cy="276225"/>
           </a:xfrm>
           <a:prstGeom prst="rect">
             <a:avLst/>
@@ -17429,28 +17429,28 @@
               </a:spcAft>
             </a:pPr>
             <a:r>
-              <a:rPr sz="1500" b="1" lang="zh-CN">
+              <a:rPr sz="1425" b="1" lang="zh-CN">
                 <a:solidFill>
                   <a:srgbClr val="1F2937"/>
                 </a:solidFill>
                 <a:latin typeface="Microsoft YaHei"/>
                 <a:ea typeface="Microsoft YaHei"/>
               </a:rPr>
-              <a:t>映射与输出</a:t>
-            </a:r>
-          </a:p>
-        </p:txBody>
-      </p:sp>
-      <p:sp>
-        <p:nvSpPr>
-          <p:cNvPr id="27" name="约 O(n log Vmax + L)"/>
+              <a:t>细化 DP（固定 cnt）</a:t>
+            </a:r>
+          </a:p>
+        </p:txBody>
+      </p:sp>
+      <p:sp>
+        <p:nvSpPr>
+          <p:cNvPr id="27" name="最坏 O(cnt × n × W)"/>
           <p:cNvSpPr txBox="1"/>
           <p:nvPr/>
         </p:nvSpPr>
         <p:spPr>
           <a:xfrm>
-            <a:off x="3009900" y="4095750"/>
-            <a:ext cx="4067175" cy="304800"/>
+            <a:off x="3009900" y="3876674"/>
+            <a:ext cx="4067175" cy="276225"/>
           </a:xfrm>
           <a:prstGeom prst="rect">
             <a:avLst/>
@@ -17473,28 +17473,28 @@
               </a:spcAft>
             </a:pPr>
             <a:r>
-              <a:rPr sz="1500" b="0" lang="zh-CN">
+              <a:rPr sz="1425" b="0" lang="zh-CN">
                 <a:solidFill>
                   <a:srgbClr val="1F2937"/>
                 </a:solidFill>
                 <a:latin typeface="Microsoft YaHei"/>
                 <a:ea typeface="Microsoft YaHei"/>
               </a:rPr>
-              <a:t>约 O(n log Vmax + L)</a:t>
-            </a:r>
-          </a:p>
-        </p:txBody>
-      </p:sp>
-      <p:sp>
-        <p:nvSpPr>
-          <p:cNvPr id="28" name="O(L)，L 为片段与目标 iov 的交集数"/>
+              <a:t>最坏 O(cnt × n × W)</a:t>
+            </a:r>
+          </a:p>
+        </p:txBody>
+      </p:sp>
+      <p:sp>
+        <p:nvSpPr>
+          <p:cNvPr id="28" name="状态 O(cnt × n)，合法边 O(nW)"/>
           <p:cNvSpPr txBox="1"/>
           <p:nvPr/>
         </p:nvSpPr>
         <p:spPr>
           <a:xfrm>
-            <a:off x="7343775" y="4095750"/>
-            <a:ext cx="4105274" cy="304800"/>
+            <a:off x="7343775" y="3876674"/>
+            <a:ext cx="4105274" cy="276225"/>
           </a:xfrm>
           <a:prstGeom prst="rect">
             <a:avLst/>
@@ -17517,14 +17517,14 @@
               </a:spcAft>
             </a:pPr>
             <a:r>
-              <a:rPr sz="1500" b="0" lang="zh-CN">
+              <a:rPr sz="1425" b="0" lang="zh-CN">
                 <a:solidFill>
                   <a:srgbClr val="1F2937"/>
                 </a:solidFill>
                 <a:latin typeface="Microsoft YaHei"/>
                 <a:ea typeface="Microsoft YaHei"/>
               </a:rPr>
-              <a:t>O(L)，L 为片段与目标 iov 的交集数</a:t>
+              <a:t>状态 O(cnt × n)，合法边 O(nW)</a:t>
             </a:r>
           </a:p>
         </p:txBody>
@@ -17537,7 +17537,7 @@
         </p:nvCxnSpPr>
         <p:spPr>
           <a:xfrm>
-            <a:off x="609600" y="4438650"/>
+            <a:off x="609600" y="4181475"/>
             <a:ext cx="10972800" cy="0"/>
           </a:xfrm>
           <a:prstGeom prst="line">
@@ -17567,14 +17567,14 @@
       </p:cxnSp>
       <p:sp>
         <p:nvSpPr>
-          <p:cNvPr id="30" name="后台同步 / 扫描"/>
+          <p:cNvPr id="30" name="映射与输出"/>
           <p:cNvSpPr txBox="1"/>
           <p:nvPr/>
         </p:nvSpPr>
         <p:spPr>
           <a:xfrm>
-            <a:off x="742950" y="4552950"/>
-            <a:ext cx="2000250" cy="304800"/>
+            <a:off x="742950" y="4276725"/>
+            <a:ext cx="2000250" cy="276225"/>
           </a:xfrm>
           <a:prstGeom prst="rect">
             <a:avLst/>
@@ -17597,28 +17597,28 @@
               </a:spcAft>
             </a:pPr>
             <a:r>
-              <a:rPr sz="1500" b="1" lang="zh-CN">
+              <a:rPr sz="1425" b="1" lang="zh-CN">
                 <a:solidFill>
                   <a:srgbClr val="1F2937"/>
                 </a:solidFill>
                 <a:latin typeface="Microsoft YaHei"/>
                 <a:ea typeface="Microsoft YaHei"/>
               </a:rPr>
-              <a:t>后台同步 / 扫描</a:t>
-            </a:r>
-          </a:p>
-        </p:txBody>
-      </p:sp>
-      <p:sp>
-        <p:nvSpPr>
-          <p:cNvPr id="31" name="O(R log(R+1)+A)，另有状态查表"/>
+              <a:t>映射与输出</a:t>
+            </a:r>
+          </a:p>
+        </p:txBody>
+      </p:sp>
+      <p:sp>
+        <p:nvSpPr>
+          <p:cNvPr id="31" name="约 O(n log Vmax + L)"/>
           <p:cNvSpPr txBox="1"/>
           <p:nvPr/>
         </p:nvSpPr>
         <p:spPr>
           <a:xfrm>
-            <a:off x="3009900" y="4552950"/>
-            <a:ext cx="4067175" cy="304800"/>
+            <a:off x="3009900" y="4276725"/>
+            <a:ext cx="4067175" cy="276225"/>
           </a:xfrm>
           <a:prstGeom prst="rect">
             <a:avLst/>
@@ -17641,28 +17641,28 @@
               </a:spcAft>
             </a:pPr>
             <a:r>
-              <a:rPr sz="1500" b="0" lang="zh-CN">
+              <a:rPr sz="1425" b="0" lang="zh-CN">
                 <a:solidFill>
                   <a:srgbClr val="1F2937"/>
                 </a:solidFill>
                 <a:latin typeface="Microsoft YaHei"/>
                 <a:ea typeface="Microsoft YaHei"/>
               </a:rPr>
-              <a:t>O(R log(R+1)+A)，另有状态查表</a:t>
-            </a:r>
-          </a:p>
-        </p:txBody>
-      </p:sp>
-      <p:sp>
-        <p:nvSpPr>
-          <p:cNvPr id="32" name="临时 O(R)，持久 O(H+U+R)"/>
+              <a:t>约 O(n log Vmax + L)</a:t>
+            </a:r>
+          </a:p>
+        </p:txBody>
+      </p:sp>
+      <p:sp>
+        <p:nvSpPr>
+          <p:cNvPr id="32" name="O(L)，L 为片段与目标 iov 的交集数"/>
           <p:cNvSpPr txBox="1"/>
           <p:nvPr/>
         </p:nvSpPr>
         <p:spPr>
           <a:xfrm>
-            <a:off x="7343775" y="4552950"/>
-            <a:ext cx="4105274" cy="304800"/>
+            <a:off x="7343775" y="4276725"/>
+            <a:ext cx="4105274" cy="276225"/>
           </a:xfrm>
           <a:prstGeom prst="rect">
             <a:avLst/>
@@ -17685,14 +17685,14 @@
               </a:spcAft>
             </a:pPr>
             <a:r>
-              <a:rPr sz="1500" b="0" lang="zh-CN">
+              <a:rPr sz="1425" b="0" lang="zh-CN">
                 <a:solidFill>
                   <a:srgbClr val="1F2937"/>
                 </a:solidFill>
                 <a:latin typeface="Microsoft YaHei"/>
                 <a:ea typeface="Microsoft YaHei"/>
               </a:rPr>
-              <a:t>临时 O(R)，持久 O(H+U+R)</a:t>
+              <a:t>O(L)，L 为片段与目标 iov 的交集数</a:t>
             </a:r>
           </a:p>
         </p:txBody>
@@ -17705,7 +17705,7 @@
         </p:nvCxnSpPr>
         <p:spPr>
           <a:xfrm>
-            <a:off x="609600" y="4895850"/>
+            <a:off x="609600" y="4581525"/>
             <a:ext cx="10972800" cy="0"/>
           </a:xfrm>
           <a:prstGeom prst="line">
@@ -17735,14 +17735,14 @@
       </p:cxnSp>
       <p:sp>
         <p:nvSpPr>
-          <p:cNvPr id="34" name="细化搜索：单次至多 131072 个存储状态；每批共享 200 万次边估价 / 转移预算。"/>
+          <p:cNvPr id="34" name="后台同步 / 扫描"/>
           <p:cNvSpPr txBox="1"/>
           <p:nvPr/>
         </p:nvSpPr>
         <p:spPr>
           <a:xfrm>
-            <a:off x="609600" y="5067300"/>
-            <a:ext cx="10972800" cy="295275"/>
+            <a:off x="742950" y="4676775"/>
+            <a:ext cx="2000250" cy="276225"/>
           </a:xfrm>
           <a:prstGeom prst="rect">
             <a:avLst/>
@@ -17765,6 +17765,174 @@
               </a:spcAft>
             </a:pPr>
             <a:r>
+              <a:rPr sz="1425" b="1" lang="zh-CN">
+                <a:solidFill>
+                  <a:srgbClr val="1F2937"/>
+                </a:solidFill>
+                <a:latin typeface="Microsoft YaHei"/>
+                <a:ea typeface="Microsoft YaHei"/>
+              </a:rPr>
+              <a:t>后台同步 / 扫描</a:t>
+            </a:r>
+          </a:p>
+        </p:txBody>
+      </p:sp>
+      <p:sp>
+        <p:nvSpPr>
+          <p:cNvPr id="35" name="O(R log(R+1)+A)，另有状态查表"/>
+          <p:cNvSpPr txBox="1"/>
+          <p:nvPr/>
+        </p:nvSpPr>
+        <p:spPr>
+          <a:xfrm>
+            <a:off x="3009900" y="4676775"/>
+            <a:ext cx="4067175" cy="276225"/>
+          </a:xfrm>
+          <a:prstGeom prst="rect">
+            <a:avLst/>
+          </a:prstGeom>
+          <a:noFill/>
+          <a:effectLst/>
+        </p:spPr>
+        <p:txBody>
+          <a:bodyPr wrap="square" lIns="0" rIns="0" tIns="0" bIns="0">
+            <a:spAutoFit/>
+          </a:bodyPr>
+          <a:lstStyle/>
+          <a:p>
+            <a:pPr algn="l">
+              <a:lnSpc>
+                <a:spcPct val="112000"/>
+              </a:lnSpc>
+              <a:spcAft>
+                <a:spcPts val="500"/>
+              </a:spcAft>
+            </a:pPr>
+            <a:r>
+              <a:rPr sz="1425" b="0" lang="zh-CN">
+                <a:solidFill>
+                  <a:srgbClr val="1F2937"/>
+                </a:solidFill>
+                <a:latin typeface="Microsoft YaHei"/>
+                <a:ea typeface="Microsoft YaHei"/>
+              </a:rPr>
+              <a:t>O(R log(R+1)+A)，另有状态查表</a:t>
+            </a:r>
+          </a:p>
+        </p:txBody>
+      </p:sp>
+      <p:sp>
+        <p:nvSpPr>
+          <p:cNvPr id="36" name="临时 O(R)，持久 O(H+U+R)"/>
+          <p:cNvSpPr txBox="1"/>
+          <p:nvPr/>
+        </p:nvSpPr>
+        <p:spPr>
+          <a:xfrm>
+            <a:off x="7343775" y="4676775"/>
+            <a:ext cx="4105274" cy="276225"/>
+          </a:xfrm>
+          <a:prstGeom prst="rect">
+            <a:avLst/>
+          </a:prstGeom>
+          <a:noFill/>
+          <a:effectLst/>
+        </p:spPr>
+        <p:txBody>
+          <a:bodyPr wrap="square" lIns="0" rIns="0" tIns="0" bIns="0">
+            <a:spAutoFit/>
+          </a:bodyPr>
+          <a:lstStyle/>
+          <a:p>
+            <a:pPr algn="l">
+              <a:lnSpc>
+                <a:spcPct val="112000"/>
+              </a:lnSpc>
+              <a:spcAft>
+                <a:spcPts val="500"/>
+              </a:spcAft>
+            </a:pPr>
+            <a:r>
+              <a:rPr sz="1425" b="0" lang="zh-CN">
+                <a:solidFill>
+                  <a:srgbClr val="1F2937"/>
+                </a:solidFill>
+                <a:latin typeface="Microsoft YaHei"/>
+                <a:ea typeface="Microsoft YaHei"/>
+              </a:rPr>
+              <a:t>临时 O(R)，持久 O(H+U+R)</a:t>
+            </a:r>
+          </a:p>
+        </p:txBody>
+      </p:sp>
+      <p:cxnSp>
+        <p:nvCxnSpPr>
+          <p:cNvPr id="37" name="Connector 36"/>
+          <p:cNvCxnSpPr/>
+          <p:nvPr/>
+        </p:nvCxnSpPr>
+        <p:spPr>
+          <a:xfrm>
+            <a:off x="609600" y="4981575"/>
+            <a:ext cx="10972800" cy="0"/>
+          </a:xfrm>
+          <a:prstGeom prst="line">
+            <a:avLst/>
+          </a:prstGeom>
+          <a:ln w="12700">
+            <a:solidFill>
+              <a:srgbClr val="DCE2E9"/>
+            </a:solidFill>
+          </a:ln>
+          <a:effectLst/>
+        </p:spPr>
+        <p:style>
+          <a:lnRef idx="2">
+            <a:schemeClr val="accent1"/>
+          </a:lnRef>
+          <a:fillRef idx="0">
+            <a:schemeClr val="accent1"/>
+          </a:fillRef>
+          <a:effectRef idx="0">
+            <a:schemeClr val="accent1"/>
+          </a:effectRef>
+          <a:fontRef idx="minor">
+            <a:schemeClr val="tx1"/>
+          </a:fontRef>
+        </p:style>
+      </p:cxnSp>
+      <p:sp>
+        <p:nvSpPr>
+          <p:cNvPr id="38" name="细化搜索：单次至多 131072 个存储状态；每批共享 200 万次边估价 / 转移预算。"/>
+          <p:cNvSpPr txBox="1"/>
+          <p:nvPr/>
+        </p:nvSpPr>
+        <p:spPr>
+          <a:xfrm>
+            <a:off x="609600" y="5067300"/>
+            <a:ext cx="10972800" cy="295275"/>
+          </a:xfrm>
+          <a:prstGeom prst="rect">
+            <a:avLst/>
+          </a:prstGeom>
+          <a:noFill/>
+          <a:effectLst/>
+        </p:spPr>
+        <p:txBody>
+          <a:bodyPr wrap="square" lIns="0" rIns="0" tIns="0" bIns="0">
+            <a:spAutoFit/>
+          </a:bodyPr>
+          <a:lstStyle/>
+          <a:p>
+            <a:pPr algn="l">
+              <a:lnSpc>
+                <a:spcPct val="112000"/>
+              </a:lnSpc>
+              <a:spcAft>
+                <a:spcPts val="500"/>
+              </a:spcAft>
+            </a:pPr>
+            <a:r>
               <a:rPr sz="1800" b="1" lang="zh-CN">
                 <a:solidFill>
                   <a:srgbClr val="285EA8"/>
@@ -17779,7 +17947,7 @@
       </p:sp>
       <p:sp>
         <p:nvSpPr>
-          <p:cNvPr id="35" name="R / A = 在途提升 / 活动传输数；H / U = 历史记录 / 未完成请求数（历史含更新队列）。 总空间计入输入索引、活动请求和输出映射；搜索预算约束细化 DP 的估价与转移。"/>
+          <p:cNvPr id="39" name="R / A = 在途提升 / 活动传输数；H / U = 历史记录 / 未完成请求数（历史含更新队列）。 总空间计入输入索引、活动请求和输出映射；搜索预算约束细化 DP 的估价与转移。"/>
           <p:cNvSpPr txBox="1"/>
           <p:nvPr/>
         </p:nvSpPr>

</xml_diff>

<commit_message>
docs: consolidate final submission materials and remove redundant guides
Signed-off-by: KaisennHu <74917084+KaisennHu@users.noreply.github.com>
</commit_message>
<xml_diff>
--- a/submissions/kaisennhu/07_答辩PPT/答辩介绍.pptx
+++ b/submissions/kaisennhu/07_答辩PPT/答辩介绍.pptx
@@ -932,7 +932,7 @@
           <a:lstStyle/>
           <a:p>
             <a:r>
-              <a:t>本页区分三层概念。合法操作候选是“某段连续片段合为一组，走某条路径”；一份完整方案是若干操作覆盖本批全部片段。快速DP枚举许多候选操作，但最终只回溯输出一份完整基础方案，不输出多份完整方案。每个dp[j]也只保留一个最低估价前驱；并列时保留先遇到的选择。细化阶段从基础方案获得组数seed以及卡号/复制类型的组数比例，再从前面枚举的同一合法操作集合中重新求解。多个完整候选来自对多个总组数cnt分别求解；每个cnt只回溯一个最低估价方案，回溯后进行总槽位与池容量检查，不保留该cnt的次优方案。最终提交的仍是一份计划。快速更新dp[j]=min_i,path(dp[i]+E(i,j,path))，状态只表示前缀j，最终组数由回溯决定。细化更新D[h][j]=min_i,path(D[h-1][i]+E_cnt(i,j,path))；每固定一个cnt，边权用对应并发重算，取D[cnt][n]回溯。两阶段都联合选分组边界和路径，并非先分组后选路。快速SSD估价并发max(1,active_ssd+n)，复制为max(1,active_copy+per_card_requests)；细化SSD为max(1,active_ssd+cnt)，因入口保守空闲，active_ssd为0。复制为active_copy+max(1,ceil(cnt*seed_copy_groups/seed))，按卡号与D2D/H2D类型分别估计，估价内再应用对应性能表及并发限制；DIRECT不计入复制组数。cnt不是整个执行期不变的真实并发，E用于排序，实际J由官方完整Trace回放计算。每批先运行快速DP。细化仅在无活动传输、queued_iocbs、promote_inflight、foreground_iocb_inflight及旧未完成到达登记时尝试；≤1024请求、≤2048 iov、≤16384片段，快速方案≤2048操作。合法边上限262144；每cnt状态≤131072，估价/转移共享200万工作预算。预检查、可达性过滤、采样及回溯资源检查按代码执行；预算不足的cnt不求解。有合格细化方案则选细化候选中的最低估价者，没有则保留快速方案；不是把快速E与细化E直接比较。n≤24时尝试所有cnt，否则采样性能桶边界、几何序列及尺寸拐点，并局部细化；采样包含基础方案组数，但该cnt重新求出的方案可能与基础方案不同。三个同卡相邻对齐512B片段：快速阶段qs=qc=3，整组D/A/F E=5.406/32.820/22.559，输出一个DIRECT组。细化时全DIRECT基础方案使复制qc=1，AGGREGATE整组E重算为81.648；每cnt的最佳D[cnt][3]在1/2/3组时为5.406/7.406/9.406，均由DIRECT取得。代码尝试顺序1、3、2，最终仍选一个DIRECT。实际读工作3.4059797微秒，Trace时间向上取整4微秒，调用费2，J=6；分别读时调用费6、J=10。前台最多考察起点后128片段，不处理未来请求或PROMOTE。五次点击对应快速输出、细化候选、入口范围、最终选择、数值示例；放映展示已核验的执行过程，不调用模拟器。</a:t>
+              <a:t>本页区分三层概念。合法操作候选是“某段连续片段合为一组，走某条路径”；一份完整方案是若干操作覆盖本批全部片段。快速DP枚举许多候选操作，但最终只回溯输出一份完整基础方案，不输出多份完整方案。每个dp[j]也只保留一个最低估价前驱；并列时保留先遇到的选择。细化阶段从基础方案获得组数seed以及卡号/复制类型的组数比例，再从前面枚举的同一合法操作集合中重新求解。多个完整候选来自对多个总组数cnt分别求解；每个cnt只回溯一个最低估价方案，回溯后进行总槽位与池容量检查，不保留该cnt的次优方案。最终提交的仍是一份计划。快速更新dp[j]=min_i,path(dp[i]+E(i,j,path))，状态只表示前缀j，最终组数由回溯决定。细化更新D[h][j]=min_i,path(D[h-1][i]+E_cnt(i,j,path))；每固定一个cnt，边权用对应并发重算，取D[cnt][n]回溯。两阶段都联合选分组边界和路径，并非先分组后选路。先快速的目的是取得估价依据和可用方案；单独假设cnt不能推知各卡的复制类型分布。例如基础4组、某卡AGGREGATE占1组，尝试cnt=8时该卡D2D新增并发估为2。当前细化依赖这项统计和基础组数采样；直接细化需要另行设计复制估价和超限处理。快速SSD估价并发max(1,active_ssd+n)，复制为max(1,active_copy+per_card_requests)；细化SSD为max(1,active_ssd+cnt)，因入口保守空闲，active_ssd为0。复制为active_copy+max(1,ceil(cnt*seed_copy_groups/seed))，按卡号与D2D/H2D类型分别估计，估价内再应用对应性能表及并发限制；DIRECT不计入复制组数。cnt不是整个执行期不变的真实并发，E用于排序，实际J由官方完整Trace回放计算。每批先运行快速DP。细化仅在无活动传输、queued_iocbs、promote_inflight、foreground_iocb_inflight及旧未完成到达登记时尝试；≤1024请求、≤2048 iov、≤16384片段，快速方案≤2048操作。合法边上限262144；每cnt状态≤131072，估价/转移共享200万工作预算。预检查、可达性过滤、采样及回溯资源检查按代码执行；预算不足的cnt不求解。有合格细化方案则选细化候选中的最低估价者，没有则保留快速方案；不是把快速E与细化E直接比较。n≤24时尝试所有cnt，否则采样性能桶边界、几何序列及尺寸拐点，并局部细化；采样包含基础方案组数，但该cnt重新求出的方案可能与基础方案不同。三个同卡相邻对齐512B片段：快速阶段qs=qc=3，整组D/A/F E=5.406/32.820/22.559，输出一个DIRECT组。细化时全DIRECT基础方案使复制qc=1，AGGREGATE整组E重算为81.648；每cnt的最佳D[cnt][3]在1/2/3组时为5.406/7.406/9.406，均由DIRECT取得。代码尝试顺序1、3、2，最终仍选一个DIRECT。实际读工作3.4059797微秒，Trace时间向上取整4微秒，调用费2，J=6；分别读时调用费6、J=10。前台最多考察起点后128片段，不处理未来请求或PROMOTE。五次点击对应快速输出、细化候选、入口范围、最终选择、数值示例；放映展示已核验的执行过程，不调用模拟器。</a:t>
             </a:r>
           </a:p>
         </p:txBody>
@@ -11242,7 +11242,7 @@
       </p:sp>
       <p:sp>
         <p:nvSpPr>
-          <p:cNvPr id="4" name="两阶段共用合法操作集合，都同时选分组与路径；细化利用基础方案的复制分布估计并发。"/>
+          <p:cNvPr id="4" name="快速DP先低成本取得可提交方案与复制分布；细化据此估价，在预算内按组数搜索。"/>
           <p:cNvSpPr txBox="1"/>
           <p:nvPr/>
         </p:nvSpPr>
@@ -11279,7 +11279,7 @@
                 <a:latin typeface="Microsoft YaHei"/>
                 <a:ea typeface="Microsoft YaHei"/>
               </a:rPr>
-              <a:t>两阶段共用合法操作集合，都同时选分组与路径；细化利用基础方案的复制分布估计并发。</a:t>
+              <a:t>快速DP先低成本取得可提交方案与复制分布；细化据此估价，在预算内按组数搜索。</a:t>
             </a:r>
           </a:p>
         </p:txBody>
@@ -19493,7 +19493,7 @@
       </p:cxnSp>
       <p:sp>
         <p:nvSpPr>
-          <p:cNvPr id="36" name="策略堆峰值 12.34MiB；策略决策、框架执行和输入输出分别计量，便于复现。"/>
+          <p:cNvPr id="36" name="策略堆峰值 12.34MiB；策略回调单独计时，进程总耗时包含框架执行与输入输出。"/>
           <p:cNvSpPr txBox="1"/>
           <p:nvPr/>
         </p:nvSpPr>
@@ -19530,7 +19530,7 @@
                 <a:latin typeface="Microsoft YaHei"/>
                 <a:ea typeface="Microsoft YaHei"/>
               </a:rPr>
-              <a:t>策略堆峰值 12.34MiB；策略决策、框架执行和输入输出分别计量，便于复现。</a:t>
+              <a:t>策略堆峰值 12.34MiB；策略回调单独计时，进程总耗时包含框架执行与输入输出。</a:t>
             </a:r>
           </a:p>
         </p:txBody>

</xml_diff>

<commit_message>
docs: explain planning dependencies without threshold details
Signed-off-by: KaisennHu <74917084+KaisennHu@users.noreply.github.com>
</commit_message>
<xml_diff>
--- a/submissions/kaisennhu/07_答辩PPT/答辩介绍.pptx
+++ b/submissions/kaisennhu/07_答辩PPT/答辩介绍.pptx
@@ -932,7 +932,7 @@
           <a:lstStyle/>
           <a:p>
             <a:r>
-              <a:t>本页区分三层概念。合法操作候选是“某段连续片段合为一组，走某条路径”；一份完整方案是若干操作覆盖本批全部片段。快速DP枚举许多候选操作，但最终只回溯输出一份完整基础方案，不输出多份完整方案。每个dp[j]也只保留一个最低估价前驱；并列时保留先遇到的选择。细化阶段从基础方案获得组数seed以及卡号/复制类型的组数比例，再从前面枚举的同一合法操作集合中重新求解。多个完整候选来自对多个总组数cnt分别求解；每个cnt只回溯一个最低估价方案，回溯后进行总槽位与池容量检查，不保留该cnt的次优方案。最终提交的仍是一份计划。快速更新dp[j]=min_i,path(dp[i]+E(i,j,path))，状态只表示前缀j，最终组数由回溯决定。细化更新D[h][j]=min_i,path(D[h-1][i]+E_cnt(i,j,path))；每固定一个cnt，边权用对应并发重算，取D[cnt][n]回溯。两阶段都联合选分组边界和路径，并非先分组后选路。先快速的目的是取得估价依据和可用方案；单独假设cnt不能推知各卡的复制类型分布。例如基础4组、某卡AGGREGATE占1组，尝试cnt=8时该卡D2D新增并发估为2。当前细化依赖这项统计和基础组数采样；直接细化需要另行设计复制估价和超限处理。快速SSD估价并发max(1,active_ssd+n)，复制为max(1,active_copy+per_card_requests)；细化SSD为max(1,active_ssd+cnt)，因入口保守空闲，active_ssd为0。复制为active_copy+max(1,ceil(cnt*seed_copy_groups/seed))，按卡号与D2D/H2D类型分别估计，估价内再应用对应性能表及并发限制；DIRECT不计入复制组数。cnt不是整个执行期不变的真实并发，E用于排序，实际J由官方完整Trace回放计算。每批先运行快速DP。细化仅在无活动传输、queued_iocbs、promote_inflight、foreground_iocb_inflight及旧未完成到达登记时尝试；≤1024请求、≤2048 iov、≤16384片段，快速方案≤2048操作。合法边上限262144；每cnt状态≤131072，估价/转移共享200万工作预算。预检查、可达性过滤、采样及回溯资源检查按代码执行；预算不足的cnt不求解。有合格细化方案则选细化候选中的最低估价者，没有则保留快速方案；不是把快速E与细化E直接比较。n≤24时尝试所有cnt，否则采样性能桶边界、几何序列及尺寸拐点，并局部细化；采样包含基础方案组数，但该cnt重新求出的方案可能与基础方案不同。三个同卡相邻对齐512B片段：快速阶段qs=qc=3，整组D/A/F E=5.406/32.820/22.559，输出一个DIRECT组。细化时全DIRECT基础方案使复制qc=1，AGGREGATE整组E重算为81.648；每cnt的最佳D[cnt][3]在1/2/3组时为5.406/7.406/9.406，均由DIRECT取得。代码尝试顺序1、3、2，最终仍选一个DIRECT。实际读工作3.4059797微秒，Trace时间向上取整4微秒，调用费2，J=6；分别读时调用费6、J=10。前台最多考察起点后128片段，不处理未来请求或PROMOTE。五次点击对应快速输出、细化候选、入口范围、最终选择、数值示例；放映展示已核验的执行过程，不调用模拟器。</a:t>
+              <a:t>本页区分三层概念。合法操作候选是“某段连续片段合为一组，走某条路径”；一份完整方案是若干操作覆盖本批全部片段。快速DP枚举许多候选操作，但最终只回溯输出一份完整基础方案，不输出多份完整方案。每个dp[j]也只保留一个最低估价前驱；并列时保留先遇到的选择。细化阶段从基础方案获得组数seed以及卡号/复制类型的组数比例，再从前面枚举的同一合法操作集合中重新求解。多个完整候选来自对多个总组数cnt分别求解；每个cnt只回溯一个最低估价方案，回溯后进行总槽位与池容量检查，不保留该cnt的次优方案。最终提交的仍是一份计划。快速更新dp[j]=min_i,path(dp[i]+E(i,j,path))，状态只表示前缀j，最终组数由回溯决定。细化更新D[h][j]=min_i,path(D[h-1][i]+E_cnt(i,j,path))；每固定一个cnt，边权用对应并发重算，取D[cnt][n]回溯。两阶段都联合选分组边界和路径，并非先分组后选路。先快速的目的是取得估价依据和可用方案；单独假设cnt不能推知各卡的复制类型分布。例如基础4组、某卡AGGREGATE占1组，尝试cnt=8时该卡D2D新增并发估为2。当前细化依赖这项统计和基础组数采样；直接细化需要另行设计复制估价和超限处理。快速SSD估价并发max(1,active_ssd+n)，复制为max(1,active_copy+per_card_requests)；细化SSD为max(1,active_ssd+cnt)，因入口保守空闲，active_ssd为0。复制为active_copy+max(1,ceil(cnt*seed_copy_groups/seed))，按卡号与D2D/H2D类型分别估计，估价内再应用对应性能表及并发限制；DIRECT不计入复制组数。cnt不是整个执行期不变的真实并发，E用于排序，实际J由官方完整Trace回放计算。每批先运行快速DP。细化只在系统空闲且输入规模适合时尝试，候选规模、存储状态和搜索工作量均受限制；具体实现阈值见算法与复杂度文档。预检查、可达性过滤、采样及回溯资源检查按代码执行；预算不足的cnt不求解。有合格细化方案则选细化候选中的最低估价者，没有则保留快速方案；不是把快速E与细化E直接比较。候选总组数按输入规模枚举或采样，采样覆盖性能桶边界、几何序列及尺寸拐点，并局部细化；采样包含基础方案组数，但该cnt重新求出的方案可能与基础方案不同。三个同卡相邻对齐512B片段：快速阶段qs=qc=3，整组D/A/F E=5.406/32.820/22.559，输出一个DIRECT组。细化时全DIRECT基础方案使复制qc=1，AGGREGATE整组E重算为81.648；每cnt的最佳D[cnt][3]在1/2/3组时为5.406/7.406/9.406，均由DIRECT取得。代码尝试顺序1、3、2，最终仍选一个DIRECT。实际读工作3.4059797微秒，Trace时间向上取整4微秒，调用费2，J=6；分别读时调用费6、J=10。前台用有限窗口考察连续片段，不处理未来请求或PROMOTE。五次点击对应快速输出、细化候选、入口范围、最终选择、数值示例；放映展示已核验的执行过程，不调用模拟器。</a:t>
             </a:r>
           </a:p>
         </p:txBody>
@@ -1002,7 +1002,7 @@
           <a:lstStyle/>
           <a:p>
             <a:r>
-              <a:t>四道条件与末尾数值例子各一次点击。缓存键按卡号、SSD起点、完整长度。命中通过缺少arrivals_登记辨认；已准入且无新的真实miss也不重复提升。复用还有字节距离不能超过池容量的检查。频率0&lt;gap&lt;TTL；新鲜度age&lt;TTL且age≤max(1微秒,gap+2jitter)，1微秒下限与TTL严格小于关系均按代码保留。gain扣除命中H2D费用，并按本卡份额、是否能被到达空隙吸收调整时间项。提升投入包含80固定费、来源传输和调用费，选较便宜来源。教学例取R=30、D=10、H=12、C=12、a=1、时间权重w=0、c_t=1，所以gain=10；每次可记预算52，第二次104不够112.5、第三次156足够。已有及在途占用计入需替换字节。这是算式假设不是实测Trace。credit是投入节制，不等于预测未来必命中的次数。</a:t>
+              <a:t>四道条件与末尾数值例子各一次点击。缓存键按卡号、SSD起点、完整长度。命中通过缺少arrivals_登记辨认；已准入且无新的真实miss也不重复提升。复用还有字节距离不能超过池容量的检查。复用间隔与证据年龄都严格小于TTL，并按已观察的复用节奏检查新鲜度；具体条件见算法设计。gain扣除命中H2D费用，并按本卡份额、是否能被到达空隙吸收调整时间项。提升投入包含80固定费、来源传输和调用费，选较便宜来源。教学例取R=30、D=10、H=12、C=12、a=1、时间权重w=0、c_t=1，所以gain=10；每次可记预算52，第二次104不够112.5、第三次156足够。已有及在途占用计入需替换字节。这是算式假设不是实测Trace。credit是投入节制，不等于预测未来必命中的次数。</a:t>
             </a:r>
           </a:p>
         </p:txBody>
@@ -1142,7 +1142,7 @@
           <a:lstStyle/>
           <a:p>
             <a:r>
-              <a:t>Vmax为单个请求最多iov数，L为最终片段与目标iov的有效交集数。候选组枚举与快速DP状态更新在同一段循环中交织执行，这里按开销来源分列，并非代码先枚举完整候选表再做快速DP。每个起点至多扩展W个片段，每组比较三条路径，每条边的DP更新为常数时间，因此快速DP核心转移为O(nW)。候选组每扩展一个片段，要把请求编号插入std::set owners；集合大小最多min(W,请求数)，单次插入最坏O(log(W+1))，故候选维护为O(nW log(W+1))。两项相加，含集合维护的枚举和快速规划为O(nW log(W+1))，不是DP转移本身有额外一层循环。W固定128时，这两项都随n线性增长，排序O(n log n)另计；按卡状态map查询另计。固定cnt时DP状态至多cnt*n，每状态看至多3W条边；若无采样和预算约束，全枚举cnt=1..n的核心转移上界可达O(n^3 W)。实现使用采样，单次状态上限131072、合法边上限262144，估价和转移每批共享2000000预算。状态/边预检查以及回溯后的所有者和缓冲检查另计。复制估价按卡维护映射，也有集合访问成本。后台若有R个在途提升和A个活动传输，同步约O(R log(R+1))，还扫描A项、查history和未完成请求map；不逐次扫描全部缓存。history_queue最多131072条更新记录，未完成Work及输入输出不受这一常数限制。这里按模块分析，没有把整个策略概括为O(nW)。</a:t>
+              <a:t>Vmax为单个请求最多iov数，L为最终片段与目标iov的有效交集数。候选组枚举与快速DP状态更新在同一段循环中交织执行，这里按开销来源分列，并非代码先枚举完整候选表再做快速DP。每个起点至多扩展W个片段，每组比较三条路径，每条边的DP更新为常数时间，因此快速DP核心转移为O(nW)。候选组每扩展一个片段，要把请求编号插入std::set owners；集合大小最多min(W,请求数)，单次插入最坏O(log(W+1))，故候选维护为O(nW log(W+1))。两项相加，含集合维护的枚举和快速规划为O(nW log(W+1))，不是DP转移本身有额外一层循环。W固定时，这两项都随n线性增长，排序O(n log n)另计；按卡状态map查询另计。固定cnt时DP状态至多cnt*n，每状态看至多3W条边；若无采样和预算约束，全枚举cnt=1..n的核心转移上界可达O(n^3 W)。实现使用采样和工作量限制，控制候选状态、合法边与估价/转移规模；具体上限保存在算法与复杂度文档。状态/边预检查以及回溯后的所有者和缓冲检查另计。复制估价按卡维护映射，也有集合访问成本。后台若有R个在途提升和A个活动传输，同步约O(R log(R+1))，还扫描A项、查history和未完成请求map；不逐次扫描全部缓存。history_queue限制长期历史规模，未完成Work及输入输出另行统计。这里按模块分析，没有把整个策略概括为O(nW)。</a:t>
             </a:r>
           </a:p>
         </p:txBody>
@@ -11198,7 +11198,7 @@
       </p:sp>
       <p:sp>
         <p:nvSpPr>
-          <p:cNvPr id="3" name="快速 DP 产出一个方案，细化按组数生成候选"/>
+          <p:cNvPr id="3" name="先用快速 DP 得到方案，再利用其统计进行细化"/>
           <p:cNvSpPr txBox="1"/>
           <p:nvPr/>
         </p:nvSpPr>
@@ -11235,14 +11235,14 @@
                 <a:latin typeface="Microsoft YaHei"/>
                 <a:ea typeface="Microsoft YaHei"/>
               </a:rPr>
-              <a:t>快速 DP 产出一个方案，细化按组数生成候选</a:t>
-            </a:r>
-          </a:p>
-        </p:txBody>
-      </p:sp>
-      <p:sp>
-        <p:nvSpPr>
-          <p:cNvPr id="4" name="快速DP先低成本取得可提交方案与复制分布；细化据此估价，在预算内按组数搜索。"/>
+              <a:t>先用快速 DP 得到方案，再利用其统计进行细化</a:t>
+            </a:r>
+          </a:p>
+        </p:txBody>
+      </p:sp>
+      <p:sp>
+        <p:nvSpPr>
+          <p:cNvPr id="4" name="前后衔接，最终只提交一份计划；基础方案提供复制分布，也在未采用细化时直接使用。"/>
           <p:cNvSpPr txBox="1"/>
           <p:nvPr/>
         </p:nvSpPr>
@@ -11279,7 +11279,7 @@
                 <a:latin typeface="Microsoft YaHei"/>
                 <a:ea typeface="Microsoft YaHei"/>
               </a:rPr>
-              <a:t>快速DP先低成本取得可提交方案与复制分布；细化据此估价，在预算内按组数搜索。</a:t>
+              <a:t>前后衔接，最终只提交一份计划；基础方案提供复制分布，也在未采用细化时直接使用。</a:t>
             </a:r>
           </a:p>
         </p:txBody>
@@ -12298,7 +12298,7 @@
         </p:sp>
         <p:sp>
           <p:nvSpPr>
-            <p:cNvPr id="28" name="空闲：无在途传输、排队、提升、占槽及旧未完成请求。"/>
+            <p:cNvPr id="28" name="依赖关系：基础方案的复制分布 → 细化的并发估计 → 重新选择分组与路径。"/>
             <p:cNvSpPr txBox="1"/>
             <p:nvPr/>
           </p:nvSpPr>
@@ -12335,14 +12335,14 @@
                   <a:latin typeface="Microsoft YaHei"/>
                   <a:ea typeface="Microsoft YaHei"/>
                 </a:rPr>
-                <a:t>空闲：无在途传输、排队、提升、占槽及旧未完成请求。</a:t>
+                <a:t>依赖关系：基础方案的复制分布 → 细化的并发估计 → 重新选择分组与路径。</a:t>
               </a:r>
             </a:p>
           </p:txBody>
         </p:sp>
         <p:sp>
           <p:nvSpPr>
-            <p:cNvPr id="29" name="规模：请求 ≤1024，iov ≤2048，片段 ≤16384，基础方案操作 ≤2048。"/>
+            <p:cNvPr id="29" name="启动条件：系统空闲，输入规模适合进一步搜索。"/>
             <p:cNvSpPr txBox="1"/>
             <p:nvPr/>
           </p:nvSpPr>
@@ -12379,14 +12379,14 @@
                   <a:latin typeface="Microsoft YaHei"/>
                   <a:ea typeface="Microsoft YaHei"/>
                 </a:rPr>
-                <a:t>规模：请求 ≤1024，iov ≤2048，片段 ≤16384，基础方案操作 ≤2048。</a:t>
+                <a:t>启动条件：系统空闲，输入规模适合进一步搜索。</a:t>
               </a:r>
             </a:p>
           </p:txBody>
         </p:sp>
         <p:sp>
           <p:nvSpPr>
-            <p:cNvPr id="30" name="搜索：每批 200 万估价 / 转移；合法边 ≤262144，单次存储状态 ≤131072。"/>
+            <p:cNvPr id="30" name="开销控制：限制候选规模和搜索工作量，保留已经完成的合格方案。"/>
             <p:cNvSpPr txBox="1"/>
             <p:nvPr/>
           </p:nvSpPr>
@@ -12423,7 +12423,7 @@
                   <a:latin typeface="Microsoft YaHei"/>
                   <a:ea typeface="Microsoft YaHei"/>
                 </a:rPr>
-                <a:t>搜索：每批 200 万估价 / 转移；合法边 ≤262144，单次存储状态 ≤131072。</a:t>
+                <a:t>开销控制：限制候选规模和搜索工作量，保留已经完成的合格方案。</a:t>
               </a:r>
             </a:p>
           </p:txBody>
@@ -13503,7 +13503,7 @@
         </p:sp>
         <p:sp>
           <p:nvSpPr>
-            <p:cNvPr id="17" name="跨时刻未命中至少两次 0 &lt; gap &lt; TTL age &lt; TTL，且不超过 max(1μs,gap+2×抖动)"/>
+            <p:cNvPr id="17" name="跨时刻有重复访问 复用间隔短于 TTL 最近访问证据仍新鲜 符合已观察的复用节奏"/>
             <p:cNvSpPr txBox="1"/>
             <p:nvPr/>
           </p:nvSpPr>
@@ -13540,7 +13540,7 @@
                   <a:latin typeface="Microsoft YaHei"/>
                   <a:ea typeface="Microsoft YaHei"/>
                 </a:rPr>
-                <a:t>跨时刻未命中至少两次</a:t>
+                <a:t>跨时刻有重复访问</a:t>
               </a:r>
             </a:p>
             <a:p>
@@ -13560,7 +13560,7 @@
                   <a:latin typeface="Microsoft YaHei"/>
                   <a:ea typeface="Microsoft YaHei"/>
                 </a:rPr>
-                <a:t>0 &lt; gap &lt; TTL</a:t>
+                <a:t>复用间隔短于 TTL</a:t>
               </a:r>
             </a:p>
             <a:p>
@@ -13580,7 +13580,7 @@
                   <a:latin typeface="Microsoft YaHei"/>
                   <a:ea typeface="Microsoft YaHei"/>
                 </a:rPr>
-                <a:t>age &lt; TTL，且不超过</a:t>
+                <a:t>最近访问证据仍新鲜</a:t>
               </a:r>
             </a:p>
             <a:p>
@@ -13600,7 +13600,7 @@
                   <a:latin typeface="Microsoft YaHei"/>
                   <a:ea typeface="Microsoft YaHei"/>
                 </a:rPr>
-                <a:t>max(1μs,gap+2×抖动)</a:t>
+                <a:t>符合已观察的复用节奏</a:t>
               </a:r>
             </a:p>
           </p:txBody>
@@ -16463,7 +16463,7 @@
       </p:sp>
       <p:sp>
         <p:nvSpPr>
-          <p:cNvPr id="4" name="n = 片段数，W = 窗口（最多128），cnt = 组数；V / Vmax = 总 / 单请求最多 iov 数。"/>
+          <p:cNvPr id="4" name="n = 片段数，W = 候选窗口大小，cnt = 组数；V / Vmax = 总 / 单请求最多 iov 数。"/>
           <p:cNvSpPr txBox="1"/>
           <p:nvPr/>
         </p:nvSpPr>
@@ -16500,7 +16500,7 @@
                 <a:latin typeface="Microsoft YaHei"/>
                 <a:ea typeface="Microsoft YaHei"/>
               </a:rPr>
-              <a:t>n = 片段数，W = 窗口（最多128），cnt = 组数；V / Vmax = 总 / 单请求最多 iov 数。</a:t>
+              <a:t>n = 片段数，W = 候选窗口大小，cnt = 组数；V / Vmax = 总 / 单请求最多 iov 数。</a:t>
             </a:r>
           </a:p>
         </p:txBody>
@@ -17903,7 +17903,7 @@
       </p:cxnSp>
       <p:sp>
         <p:nvSpPr>
-          <p:cNvPr id="38" name="细化搜索：单次至多 131072 个存储状态；每批共享 200 万次边估价 / 转移预算。"/>
+          <p:cNvPr id="38" name="细化按需启用；限制候选规模与搜索开销，保留已完成的合格方案。"/>
           <p:cNvSpPr txBox="1"/>
           <p:nvPr/>
         </p:nvSpPr>
@@ -17940,7 +17940,7 @@
                 <a:latin typeface="Microsoft YaHei"/>
                 <a:ea typeface="Microsoft YaHei"/>
               </a:rPr>
-              <a:t>细化搜索：单次至多 131072 个存储状态；每批共享 200 万次边估价 / 转移预算。</a:t>
+              <a:t>细化按需启用；限制候选规模与搜索开销，保留已完成的合格方案。</a:t>
             </a:r>
           </a:p>
         </p:txBody>

</xml_diff>